<commit_message>
Presentation done ready for polishing
</commit_message>
<xml_diff>
--- a/Delivery 1 KPIs/Deliverables/Game_Analytics_Presentation.pptx
+++ b/Delivery 1 KPIs/Deliverables/Game_Analytics_Presentation.pptx
@@ -5,16 +5,16 @@
     <p:sldMasterId id="2147483648" r:id="rId1"/>
   </p:sldMasterIdLst>
   <p:sldIdLst>
-    <p:sldId id="256" r:id="rId7"/>
-    <p:sldId id="257" r:id="rId8"/>
-    <p:sldId id="258" r:id="rId9"/>
-    <p:sldId id="259" r:id="rId10"/>
-    <p:sldId id="260" r:id="rId11"/>
-    <p:sldId id="261" r:id="rId12"/>
-    <p:sldId id="262" r:id="rId13"/>
-    <p:sldId id="263" r:id="rId14"/>
-    <p:sldId id="264" r:id="rId15"/>
-    <p:sldId id="265" r:id="rId16"/>
+    <p:sldId id="256" r:id="rId2"/>
+    <p:sldId id="257" r:id="rId3"/>
+    <p:sldId id="258" r:id="rId4"/>
+    <p:sldId id="259" r:id="rId5"/>
+    <p:sldId id="260" r:id="rId6"/>
+    <p:sldId id="261" r:id="rId7"/>
+    <p:sldId id="262" r:id="rId8"/>
+    <p:sldId id="263" r:id="rId9"/>
+    <p:sldId id="264" r:id="rId10"/>
+    <p:sldId id="265" r:id="rId11"/>
   </p:sldIdLst>
   <p:sldSz cx="9144000" cy="6858000" type="screen4x3"/>
   <p:notesSz cx="6858000" cy="9144000"/>
@@ -113,6 +113,22 @@
       </a:defRPr>
     </a:lvl9pPr>
   </p:defaultTextStyle>
+  <p:extLst>
+    <p:ext uri="{EFAFB233-063F-42B5-8137-9DF3F51BA10A}">
+      <p15:sldGuideLst xmlns:p15="http://schemas.microsoft.com/office/powerpoint/2012/main">
+        <p15:guide id="1" orient="horz" pos="2160">
+          <p15:clr>
+            <a:srgbClr val="A4A3A4"/>
+          </p15:clr>
+        </p15:guide>
+        <p15:guide id="2" pos="2880">
+          <p15:clr>
+            <a:srgbClr val="A4A3A4"/>
+          </p15:clr>
+        </p15:guide>
+      </p15:sldGuideLst>
+    </p:ext>
+  </p:extLst>
 </p:presentation>
 </file>
 
@@ -154,10 +170,9 @@
           <a:lstStyle/>
           <a:p>
             <a:r>
-              <a:rPr lang="en-US" smtClean="0"/>
+              <a:rPr lang="en-US"/>
               <a:t>Click to edit Master title style</a:t>
             </a:r>
-            <a:endParaRPr lang="en-US"/>
           </a:p>
         </p:txBody>
       </p:sp>
@@ -273,10 +288,9 @@
           </a:lstStyle>
           <a:p>
             <a:r>
-              <a:rPr lang="en-US" smtClean="0"/>
+              <a:rPr lang="en-US"/>
               <a:t>Click to edit Master subtitle style</a:t>
             </a:r>
-            <a:endParaRPr lang="en-US"/>
           </a:p>
         </p:txBody>
       </p:sp>
@@ -297,7 +311,7 @@
           <a:p>
             <a:fld id="{5BCAD085-E8A6-8845-BD4E-CB4CCA059FC4}" type="datetimeFigureOut">
               <a:rPr lang="en-US" smtClean="0"/>
-              <a:t>1/27/13</a:t>
+              <a:t>10/31/25</a:t>
             </a:fld>
             <a:endParaRPr lang="en-US"/>
           </a:p>
@@ -391,10 +405,9 @@
           <a:lstStyle/>
           <a:p>
             <a:r>
-              <a:rPr lang="en-US" smtClean="0"/>
+              <a:rPr lang="en-US"/>
               <a:t>Click to edit Master title style</a:t>
             </a:r>
-            <a:endParaRPr lang="en-US"/>
           </a:p>
         </p:txBody>
       </p:sp>
@@ -415,38 +428,37 @@
           <a:p>
             <a:pPr lvl="0"/>
             <a:r>
-              <a:rPr lang="en-US" smtClean="0"/>
+              <a:rPr lang="en-US"/>
               <a:t>Click to edit Master text styles</a:t>
             </a:r>
           </a:p>
           <a:p>
             <a:pPr lvl="1"/>
             <a:r>
-              <a:rPr lang="en-US" smtClean="0"/>
+              <a:rPr lang="en-US"/>
               <a:t>Second level</a:t>
             </a:r>
           </a:p>
           <a:p>
             <a:pPr lvl="2"/>
             <a:r>
-              <a:rPr lang="en-US" smtClean="0"/>
+              <a:rPr lang="en-US"/>
               <a:t>Third level</a:t>
             </a:r>
           </a:p>
           <a:p>
             <a:pPr lvl="3"/>
             <a:r>
-              <a:rPr lang="en-US" smtClean="0"/>
+              <a:rPr lang="en-US"/>
               <a:t>Fourth level</a:t>
             </a:r>
           </a:p>
           <a:p>
             <a:pPr lvl="4"/>
             <a:r>
-              <a:rPr lang="en-US" smtClean="0"/>
+              <a:rPr lang="en-US"/>
               <a:t>Fifth level</a:t>
             </a:r>
-            <a:endParaRPr lang="en-US"/>
           </a:p>
         </p:txBody>
       </p:sp>
@@ -467,7 +479,7 @@
           <a:p>
             <a:fld id="{5BCAD085-E8A6-8845-BD4E-CB4CCA059FC4}" type="datetimeFigureOut">
               <a:rPr lang="en-US" smtClean="0"/>
-              <a:t>1/27/13</a:t>
+              <a:t>10/31/25</a:t>
             </a:fld>
             <a:endParaRPr lang="en-US"/>
           </a:p>
@@ -566,10 +578,9 @@
           <a:lstStyle/>
           <a:p>
             <a:r>
-              <a:rPr lang="en-US" smtClean="0"/>
+              <a:rPr lang="en-US"/>
               <a:t>Click to edit Master title style</a:t>
             </a:r>
-            <a:endParaRPr lang="en-US"/>
           </a:p>
         </p:txBody>
       </p:sp>
@@ -595,38 +606,37 @@
           <a:p>
             <a:pPr lvl="0"/>
             <a:r>
-              <a:rPr lang="en-US" smtClean="0"/>
+              <a:rPr lang="en-US"/>
               <a:t>Click to edit Master text styles</a:t>
             </a:r>
           </a:p>
           <a:p>
             <a:pPr lvl="1"/>
             <a:r>
-              <a:rPr lang="en-US" smtClean="0"/>
+              <a:rPr lang="en-US"/>
               <a:t>Second level</a:t>
             </a:r>
           </a:p>
           <a:p>
             <a:pPr lvl="2"/>
             <a:r>
-              <a:rPr lang="en-US" smtClean="0"/>
+              <a:rPr lang="en-US"/>
               <a:t>Third level</a:t>
             </a:r>
           </a:p>
           <a:p>
             <a:pPr lvl="3"/>
             <a:r>
-              <a:rPr lang="en-US" smtClean="0"/>
+              <a:rPr lang="en-US"/>
               <a:t>Fourth level</a:t>
             </a:r>
           </a:p>
           <a:p>
             <a:pPr lvl="4"/>
             <a:r>
-              <a:rPr lang="en-US" smtClean="0"/>
+              <a:rPr lang="en-US"/>
               <a:t>Fifth level</a:t>
             </a:r>
-            <a:endParaRPr lang="en-US"/>
           </a:p>
         </p:txBody>
       </p:sp>
@@ -647,7 +657,7 @@
           <a:p>
             <a:fld id="{5BCAD085-E8A6-8845-BD4E-CB4CCA059FC4}" type="datetimeFigureOut">
               <a:rPr lang="en-US" smtClean="0"/>
-              <a:t>1/27/13</a:t>
+              <a:t>10/31/25</a:t>
             </a:fld>
             <a:endParaRPr lang="en-US"/>
           </a:p>
@@ -741,10 +751,9 @@
           <a:lstStyle/>
           <a:p>
             <a:r>
-              <a:rPr lang="en-US" smtClean="0"/>
+              <a:rPr lang="en-US"/>
               <a:t>Click to edit Master title style</a:t>
             </a:r>
-            <a:endParaRPr lang="en-US"/>
           </a:p>
         </p:txBody>
       </p:sp>
@@ -765,38 +774,37 @@
           <a:p>
             <a:pPr lvl="0"/>
             <a:r>
-              <a:rPr lang="en-US" smtClean="0"/>
+              <a:rPr lang="en-US"/>
               <a:t>Click to edit Master text styles</a:t>
             </a:r>
           </a:p>
           <a:p>
             <a:pPr lvl="1"/>
             <a:r>
-              <a:rPr lang="en-US" smtClean="0"/>
+              <a:rPr lang="en-US"/>
               <a:t>Second level</a:t>
             </a:r>
           </a:p>
           <a:p>
             <a:pPr lvl="2"/>
             <a:r>
-              <a:rPr lang="en-US" smtClean="0"/>
+              <a:rPr lang="en-US"/>
               <a:t>Third level</a:t>
             </a:r>
           </a:p>
           <a:p>
             <a:pPr lvl="3"/>
             <a:r>
-              <a:rPr lang="en-US" smtClean="0"/>
+              <a:rPr lang="en-US"/>
               <a:t>Fourth level</a:t>
             </a:r>
           </a:p>
           <a:p>
             <a:pPr lvl="4"/>
             <a:r>
-              <a:rPr lang="en-US" smtClean="0"/>
+              <a:rPr lang="en-US"/>
               <a:t>Fifth level</a:t>
             </a:r>
-            <a:endParaRPr lang="en-US"/>
           </a:p>
         </p:txBody>
       </p:sp>
@@ -817,7 +825,7 @@
           <a:p>
             <a:fld id="{5BCAD085-E8A6-8845-BD4E-CB4CCA059FC4}" type="datetimeFigureOut">
               <a:rPr lang="en-US" smtClean="0"/>
-              <a:t>1/27/13</a:t>
+              <a:t>10/31/25</a:t>
             </a:fld>
             <a:endParaRPr lang="en-US"/>
           </a:p>
@@ -920,10 +928,9 @@
           </a:lstStyle>
           <a:p>
             <a:r>
-              <a:rPr lang="en-US" smtClean="0"/>
+              <a:rPr lang="en-US"/>
               <a:t>Click to edit Master title style</a:t>
             </a:r>
-            <a:endParaRPr lang="en-US"/>
           </a:p>
         </p:txBody>
       </p:sp>
@@ -1040,7 +1047,7 @@
           <a:p>
             <a:pPr lvl="0"/>
             <a:r>
-              <a:rPr lang="en-US" smtClean="0"/>
+              <a:rPr lang="en-US"/>
               <a:t>Click to edit Master text styles</a:t>
             </a:r>
           </a:p>
@@ -1063,7 +1070,7 @@
           <a:p>
             <a:fld id="{5BCAD085-E8A6-8845-BD4E-CB4CCA059FC4}" type="datetimeFigureOut">
               <a:rPr lang="en-US" smtClean="0"/>
-              <a:t>1/27/13</a:t>
+              <a:t>10/31/25</a:t>
             </a:fld>
             <a:endParaRPr lang="en-US"/>
           </a:p>
@@ -1157,10 +1164,9 @@
           <a:lstStyle/>
           <a:p>
             <a:r>
-              <a:rPr lang="en-US" smtClean="0"/>
+              <a:rPr lang="en-US"/>
               <a:t>Click to edit Master title style</a:t>
             </a:r>
-            <a:endParaRPr lang="en-US"/>
           </a:p>
         </p:txBody>
       </p:sp>
@@ -1214,38 +1220,37 @@
           <a:p>
             <a:pPr lvl="0"/>
             <a:r>
-              <a:rPr lang="en-US" smtClean="0"/>
+              <a:rPr lang="en-US"/>
               <a:t>Click to edit Master text styles</a:t>
             </a:r>
           </a:p>
           <a:p>
             <a:pPr lvl="1"/>
             <a:r>
-              <a:rPr lang="en-US" smtClean="0"/>
+              <a:rPr lang="en-US"/>
               <a:t>Second level</a:t>
             </a:r>
           </a:p>
           <a:p>
             <a:pPr lvl="2"/>
             <a:r>
-              <a:rPr lang="en-US" smtClean="0"/>
+              <a:rPr lang="en-US"/>
               <a:t>Third level</a:t>
             </a:r>
           </a:p>
           <a:p>
             <a:pPr lvl="3"/>
             <a:r>
-              <a:rPr lang="en-US" smtClean="0"/>
+              <a:rPr lang="en-US"/>
               <a:t>Fourth level</a:t>
             </a:r>
           </a:p>
           <a:p>
             <a:pPr lvl="4"/>
             <a:r>
-              <a:rPr lang="en-US" smtClean="0"/>
+              <a:rPr lang="en-US"/>
               <a:t>Fifth level</a:t>
             </a:r>
-            <a:endParaRPr lang="en-US"/>
           </a:p>
         </p:txBody>
       </p:sp>
@@ -1299,38 +1304,37 @@
           <a:p>
             <a:pPr lvl="0"/>
             <a:r>
-              <a:rPr lang="en-US" smtClean="0"/>
+              <a:rPr lang="en-US"/>
               <a:t>Click to edit Master text styles</a:t>
             </a:r>
           </a:p>
           <a:p>
             <a:pPr lvl="1"/>
             <a:r>
-              <a:rPr lang="en-US" smtClean="0"/>
+              <a:rPr lang="en-US"/>
               <a:t>Second level</a:t>
             </a:r>
           </a:p>
           <a:p>
             <a:pPr lvl="2"/>
             <a:r>
-              <a:rPr lang="en-US" smtClean="0"/>
+              <a:rPr lang="en-US"/>
               <a:t>Third level</a:t>
             </a:r>
           </a:p>
           <a:p>
             <a:pPr lvl="3"/>
             <a:r>
-              <a:rPr lang="en-US" smtClean="0"/>
+              <a:rPr lang="en-US"/>
               <a:t>Fourth level</a:t>
             </a:r>
           </a:p>
           <a:p>
             <a:pPr lvl="4"/>
             <a:r>
-              <a:rPr lang="en-US" smtClean="0"/>
+              <a:rPr lang="en-US"/>
               <a:t>Fifth level</a:t>
             </a:r>
-            <a:endParaRPr lang="en-US"/>
           </a:p>
         </p:txBody>
       </p:sp>
@@ -1351,7 +1355,7 @@
           <a:p>
             <a:fld id="{5BCAD085-E8A6-8845-BD4E-CB4CCA059FC4}" type="datetimeFigureOut">
               <a:rPr lang="en-US" smtClean="0"/>
-              <a:t>1/27/13</a:t>
+              <a:t>10/31/25</a:t>
             </a:fld>
             <a:endParaRPr lang="en-US"/>
           </a:p>
@@ -1449,10 +1453,9 @@
           </a:lstStyle>
           <a:p>
             <a:r>
-              <a:rPr lang="en-US" smtClean="0"/>
+              <a:rPr lang="en-US"/>
               <a:t>Click to edit Master title style</a:t>
             </a:r>
-            <a:endParaRPr lang="en-US"/>
           </a:p>
         </p:txBody>
       </p:sp>
@@ -1515,7 +1518,7 @@
           <a:p>
             <a:pPr lvl="0"/>
             <a:r>
-              <a:rPr lang="en-US" smtClean="0"/>
+              <a:rPr lang="en-US"/>
               <a:t>Click to edit Master text styles</a:t>
             </a:r>
           </a:p>
@@ -1571,38 +1574,37 @@
           <a:p>
             <a:pPr lvl="0"/>
             <a:r>
-              <a:rPr lang="en-US" smtClean="0"/>
+              <a:rPr lang="en-US"/>
               <a:t>Click to edit Master text styles</a:t>
             </a:r>
           </a:p>
           <a:p>
             <a:pPr lvl="1"/>
             <a:r>
-              <a:rPr lang="en-US" smtClean="0"/>
+              <a:rPr lang="en-US"/>
               <a:t>Second level</a:t>
             </a:r>
           </a:p>
           <a:p>
             <a:pPr lvl="2"/>
             <a:r>
-              <a:rPr lang="en-US" smtClean="0"/>
+              <a:rPr lang="en-US"/>
               <a:t>Third level</a:t>
             </a:r>
           </a:p>
           <a:p>
             <a:pPr lvl="3"/>
             <a:r>
-              <a:rPr lang="en-US" smtClean="0"/>
+              <a:rPr lang="en-US"/>
               <a:t>Fourth level</a:t>
             </a:r>
           </a:p>
           <a:p>
             <a:pPr lvl="4"/>
             <a:r>
-              <a:rPr lang="en-US" smtClean="0"/>
+              <a:rPr lang="en-US"/>
               <a:t>Fifth level</a:t>
             </a:r>
-            <a:endParaRPr lang="en-US"/>
           </a:p>
         </p:txBody>
       </p:sp>
@@ -1665,7 +1667,7 @@
           <a:p>
             <a:pPr lvl="0"/>
             <a:r>
-              <a:rPr lang="en-US" smtClean="0"/>
+              <a:rPr lang="en-US"/>
               <a:t>Click to edit Master text styles</a:t>
             </a:r>
           </a:p>
@@ -1721,38 +1723,37 @@
           <a:p>
             <a:pPr lvl="0"/>
             <a:r>
-              <a:rPr lang="en-US" smtClean="0"/>
+              <a:rPr lang="en-US"/>
               <a:t>Click to edit Master text styles</a:t>
             </a:r>
           </a:p>
           <a:p>
             <a:pPr lvl="1"/>
             <a:r>
-              <a:rPr lang="en-US" smtClean="0"/>
+              <a:rPr lang="en-US"/>
               <a:t>Second level</a:t>
             </a:r>
           </a:p>
           <a:p>
             <a:pPr lvl="2"/>
             <a:r>
-              <a:rPr lang="en-US" smtClean="0"/>
+              <a:rPr lang="en-US"/>
               <a:t>Third level</a:t>
             </a:r>
           </a:p>
           <a:p>
             <a:pPr lvl="3"/>
             <a:r>
-              <a:rPr lang="en-US" smtClean="0"/>
+              <a:rPr lang="en-US"/>
               <a:t>Fourth level</a:t>
             </a:r>
           </a:p>
           <a:p>
             <a:pPr lvl="4"/>
             <a:r>
-              <a:rPr lang="en-US" smtClean="0"/>
+              <a:rPr lang="en-US"/>
               <a:t>Fifth level</a:t>
             </a:r>
-            <a:endParaRPr lang="en-US"/>
           </a:p>
         </p:txBody>
       </p:sp>
@@ -1773,7 +1774,7 @@
           <a:p>
             <a:fld id="{5BCAD085-E8A6-8845-BD4E-CB4CCA059FC4}" type="datetimeFigureOut">
               <a:rPr lang="en-US" smtClean="0"/>
-              <a:t>1/27/13</a:t>
+              <a:t>10/31/25</a:t>
             </a:fld>
             <a:endParaRPr lang="en-US"/>
           </a:p>
@@ -1867,10 +1868,9 @@
           <a:lstStyle/>
           <a:p>
             <a:r>
-              <a:rPr lang="en-US" smtClean="0"/>
+              <a:rPr lang="en-US"/>
               <a:t>Click to edit Master title style</a:t>
             </a:r>
-            <a:endParaRPr lang="en-US"/>
           </a:p>
         </p:txBody>
       </p:sp>
@@ -1891,7 +1891,7 @@
           <a:p>
             <a:fld id="{5BCAD085-E8A6-8845-BD4E-CB4CCA059FC4}" type="datetimeFigureOut">
               <a:rPr lang="en-US" smtClean="0"/>
-              <a:t>1/27/13</a:t>
+              <a:t>10/31/25</a:t>
             </a:fld>
             <a:endParaRPr lang="en-US"/>
           </a:p>
@@ -1986,7 +1986,7 @@
           <a:p>
             <a:fld id="{5BCAD085-E8A6-8845-BD4E-CB4CCA059FC4}" type="datetimeFigureOut">
               <a:rPr lang="en-US" smtClean="0"/>
-              <a:t>1/27/13</a:t>
+              <a:t>10/31/25</a:t>
             </a:fld>
             <a:endParaRPr lang="en-US"/>
           </a:p>
@@ -2089,10 +2089,9 @@
           </a:lstStyle>
           <a:p>
             <a:r>
-              <a:rPr lang="en-US" smtClean="0"/>
+              <a:rPr lang="en-US"/>
               <a:t>Click to edit Master title style</a:t>
             </a:r>
-            <a:endParaRPr lang="en-US"/>
           </a:p>
         </p:txBody>
       </p:sp>
@@ -2146,38 +2145,37 @@
           <a:p>
             <a:pPr lvl="0"/>
             <a:r>
-              <a:rPr lang="en-US" smtClean="0"/>
+              <a:rPr lang="en-US"/>
               <a:t>Click to edit Master text styles</a:t>
             </a:r>
           </a:p>
           <a:p>
             <a:pPr lvl="1"/>
             <a:r>
-              <a:rPr lang="en-US" smtClean="0"/>
+              <a:rPr lang="en-US"/>
               <a:t>Second level</a:t>
             </a:r>
           </a:p>
           <a:p>
             <a:pPr lvl="2"/>
             <a:r>
-              <a:rPr lang="en-US" smtClean="0"/>
+              <a:rPr lang="en-US"/>
               <a:t>Third level</a:t>
             </a:r>
           </a:p>
           <a:p>
             <a:pPr lvl="3"/>
             <a:r>
-              <a:rPr lang="en-US" smtClean="0"/>
+              <a:rPr lang="en-US"/>
               <a:t>Fourth level</a:t>
             </a:r>
           </a:p>
           <a:p>
             <a:pPr lvl="4"/>
             <a:r>
-              <a:rPr lang="en-US" smtClean="0"/>
+              <a:rPr lang="en-US"/>
               <a:t>Fifth level</a:t>
             </a:r>
-            <a:endParaRPr lang="en-US"/>
           </a:p>
         </p:txBody>
       </p:sp>
@@ -2240,7 +2238,7 @@
           <a:p>
             <a:pPr lvl="0"/>
             <a:r>
-              <a:rPr lang="en-US" smtClean="0"/>
+              <a:rPr lang="en-US"/>
               <a:t>Click to edit Master text styles</a:t>
             </a:r>
           </a:p>
@@ -2263,7 +2261,7 @@
           <a:p>
             <a:fld id="{5BCAD085-E8A6-8845-BD4E-CB4CCA059FC4}" type="datetimeFigureOut">
               <a:rPr lang="en-US" smtClean="0"/>
-              <a:t>1/27/13</a:t>
+              <a:t>10/31/25</a:t>
             </a:fld>
             <a:endParaRPr lang="en-US"/>
           </a:p>
@@ -2366,10 +2364,9 @@
           </a:lstStyle>
           <a:p>
             <a:r>
-              <a:rPr lang="en-US" smtClean="0"/>
+              <a:rPr lang="en-US"/>
               <a:t>Click to edit Master title style</a:t>
             </a:r>
-            <a:endParaRPr lang="en-US"/>
           </a:p>
         </p:txBody>
       </p:sp>
@@ -2493,7 +2490,7 @@
           <a:p>
             <a:pPr lvl="0"/>
             <a:r>
-              <a:rPr lang="en-US" smtClean="0"/>
+              <a:rPr lang="en-US"/>
               <a:t>Click to edit Master text styles</a:t>
             </a:r>
           </a:p>
@@ -2516,7 +2513,7 @@
           <a:p>
             <a:fld id="{5BCAD085-E8A6-8845-BD4E-CB4CCA059FC4}" type="datetimeFigureOut">
               <a:rPr lang="en-US" smtClean="0"/>
-              <a:t>1/27/13</a:t>
+              <a:t>10/31/25</a:t>
             </a:fld>
             <a:endParaRPr lang="en-US"/>
           </a:p>
@@ -2625,10 +2622,9 @@
           <a:lstStyle/>
           <a:p>
             <a:r>
-              <a:rPr lang="en-US" smtClean="0"/>
+              <a:rPr lang="en-US"/>
               <a:t>Click to edit Master title style</a:t>
             </a:r>
-            <a:endParaRPr lang="en-US"/>
           </a:p>
         </p:txBody>
       </p:sp>
@@ -2659,38 +2655,37 @@
           <a:p>
             <a:pPr lvl="0"/>
             <a:r>
-              <a:rPr lang="en-US" smtClean="0"/>
+              <a:rPr lang="en-US"/>
               <a:t>Click to edit Master text styles</a:t>
             </a:r>
           </a:p>
           <a:p>
             <a:pPr lvl="1"/>
             <a:r>
-              <a:rPr lang="en-US" smtClean="0"/>
+              <a:rPr lang="en-US"/>
               <a:t>Second level</a:t>
             </a:r>
           </a:p>
           <a:p>
             <a:pPr lvl="2"/>
             <a:r>
-              <a:rPr lang="en-US" smtClean="0"/>
+              <a:rPr lang="en-US"/>
               <a:t>Third level</a:t>
             </a:r>
           </a:p>
           <a:p>
             <a:pPr lvl="3"/>
             <a:r>
-              <a:rPr lang="en-US" smtClean="0"/>
+              <a:rPr lang="en-US"/>
               <a:t>Fourth level</a:t>
             </a:r>
           </a:p>
           <a:p>
             <a:pPr lvl="4"/>
             <a:r>
-              <a:rPr lang="en-US" smtClean="0"/>
+              <a:rPr lang="en-US"/>
               <a:t>Fifth level</a:t>
             </a:r>
-            <a:endParaRPr lang="en-US"/>
           </a:p>
         </p:txBody>
       </p:sp>
@@ -2729,7 +2724,7 @@
           <a:p>
             <a:fld id="{5BCAD085-E8A6-8845-BD4E-CB4CCA059FC4}" type="datetimeFigureOut">
               <a:rPr lang="en-US" smtClean="0"/>
-              <a:t>1/27/13</a:t>
+              <a:t>10/31/25</a:t>
             </a:fld>
             <a:endParaRPr lang="en-US"/>
           </a:p>
@@ -3088,7 +3083,7 @@
 </file>
 
 <file path=ppt/slides/slide1.xml><?xml version="1.0" encoding="utf-8"?>
-<p:sld xmlns:a="http://schemas.openxmlformats.org/drawingml/2006/main" xmlns:p="http://schemas.openxmlformats.org/presentationml/2006/main" xmlns:r="http://schemas.openxmlformats.org/officeDocument/2006/relationships">
+<p:sld xmlns:a="http://schemas.openxmlformats.org/drawingml/2006/main" xmlns:r="http://schemas.openxmlformats.org/officeDocument/2006/relationships" xmlns:p="http://schemas.openxmlformats.org/presentationml/2006/main">
   <p:cSld>
     <p:bg>
       <p:bgPr>
@@ -3101,7 +3096,7 @@
               <a:srgbClr val="FFFFFF"/>
             </a:gs>
           </a:gsLst>
-          <a:lin scaled="0" ang="18900000"/>
+          <a:lin ang="18900000" scaled="0"/>
         </a:gradFill>
         <a:effectLst/>
       </p:bgPr>
@@ -3112,7 +3107,14 @@
         <p:cNvGrpSpPr/>
         <p:nvPr/>
       </p:nvGrpSpPr>
-      <p:grpSpPr/>
+      <p:grpSpPr>
+        <a:xfrm>
+          <a:off x="0" y="0"/>
+          <a:ext cx="0" cy="0"/>
+          <a:chOff x="0" y="0"/>
+          <a:chExt cx="0" cy="0"/>
+        </a:xfrm>
+      </p:grpSpPr>
       <p:sp>
         <p:nvSpPr>
           <p:cNvPr id="2" name="TextBox 1"/>
@@ -3266,7 +3268,7 @@
 </file>
 
 <file path=ppt/slides/slide10.xml><?xml version="1.0" encoding="utf-8"?>
-<p:sld xmlns:a="http://schemas.openxmlformats.org/drawingml/2006/main" xmlns:p="http://schemas.openxmlformats.org/presentationml/2006/main" xmlns:r="http://schemas.openxmlformats.org/officeDocument/2006/relationships">
+<p:sld xmlns:a="http://schemas.openxmlformats.org/drawingml/2006/main" xmlns:r="http://schemas.openxmlformats.org/officeDocument/2006/relationships" xmlns:p="http://schemas.openxmlformats.org/presentationml/2006/main">
   <p:cSld>
     <p:bg>
       <p:bgPr>
@@ -3279,7 +3281,7 @@
               <a:srgbClr val="F8F9FA"/>
             </a:gs>
           </a:gsLst>
-          <a:lin scaled="0" ang="18900000"/>
+          <a:lin ang="18900000" scaled="0"/>
         </a:gradFill>
         <a:effectLst/>
       </p:bgPr>
@@ -3290,7 +3292,14 @@
         <p:cNvGrpSpPr/>
         <p:nvPr/>
       </p:nvGrpSpPr>
-      <p:grpSpPr/>
+      <p:grpSpPr>
+        <a:xfrm>
+          <a:off x="0" y="0"/>
+          <a:ext cx="0" cy="0"/>
+          <a:chOff x="0" y="0"/>
+          <a:chExt cx="0" cy="0"/>
+        </a:xfrm>
+      </p:grpSpPr>
       <p:sp>
         <p:nvSpPr>
           <p:cNvPr id="2" name="TextBox 1"/>
@@ -3335,8 +3344,8 @@
         </p:nvSpPr>
         <p:spPr>
           <a:xfrm>
-            <a:off x="1097280" y="1645920"/>
-            <a:ext cx="6949440" cy="274320"/>
+            <a:off x="1371600" y="1371600"/>
+            <a:ext cx="6949440" cy="320040"/>
           </a:xfrm>
           <a:prstGeom prst="rect">
             <a:avLst/>
@@ -3358,6 +3367,7 @@
               </a:defRPr>
             </a:pPr>
             <a:r>
+              <a:rPr dirty="0"/>
               <a:t>Gather &amp; Store (50%)</a:t>
             </a:r>
           </a:p>
@@ -3371,8 +3381,8 @@
         </p:nvSpPr>
         <p:spPr>
           <a:xfrm>
-            <a:off x="1371600" y="2011680"/>
-            <a:ext cx="6400800" cy="228600"/>
+            <a:off x="1645920" y="1737360"/>
+            <a:ext cx="6583680" cy="256032"/>
           </a:xfrm>
           <a:prstGeom prst="rect">
             <a:avLst/>
@@ -3407,8 +3417,8 @@
         </p:nvSpPr>
         <p:spPr>
           <a:xfrm>
-            <a:off x="1371600" y="2286000"/>
-            <a:ext cx="6400800" cy="228600"/>
+            <a:off x="1645920" y="2029968"/>
+            <a:ext cx="6583680" cy="256032"/>
           </a:xfrm>
           <a:prstGeom prst="rect">
             <a:avLst/>
@@ -3443,8 +3453,8 @@
         </p:nvSpPr>
         <p:spPr>
           <a:xfrm>
-            <a:off x="1371600" y="2560320"/>
-            <a:ext cx="6400800" cy="228600"/>
+            <a:off x="1645920" y="2322576"/>
+            <a:ext cx="6583680" cy="256032"/>
           </a:xfrm>
           <a:prstGeom prst="rect">
             <a:avLst/>
@@ -3479,8 +3489,8 @@
         </p:nvSpPr>
         <p:spPr>
           <a:xfrm>
-            <a:off x="1097280" y="2971800"/>
-            <a:ext cx="6949440" cy="274320"/>
+            <a:off x="1371600" y="2724912"/>
+            <a:ext cx="6949440" cy="320040"/>
           </a:xfrm>
           <a:prstGeom prst="rect">
             <a:avLst/>
@@ -3515,8 +3525,8 @@
         </p:nvSpPr>
         <p:spPr>
           <a:xfrm>
-            <a:off x="1371600" y="3337560"/>
-            <a:ext cx="6400800" cy="228600"/>
+            <a:off x="1645920" y="3090672"/>
+            <a:ext cx="6583680" cy="256032"/>
           </a:xfrm>
           <a:prstGeom prst="rect">
             <a:avLst/>
@@ -3538,6 +3548,7 @@
               </a:defRPr>
             </a:pPr>
             <a:r>
+              <a:rPr dirty="0"/>
               <a:t>✓ Correct KPI calculations with 95% CI</a:t>
             </a:r>
           </a:p>
@@ -3551,8 +3562,8 @@
         </p:nvSpPr>
         <p:spPr>
           <a:xfrm>
-            <a:off x="1371600" y="3611880"/>
-            <a:ext cx="6400800" cy="228600"/>
+            <a:off x="1645920" y="3383280"/>
+            <a:ext cx="6583680" cy="256032"/>
           </a:xfrm>
           <a:prstGeom prst="rect">
             <a:avLst/>
@@ -3587,8 +3598,8 @@
         </p:nvSpPr>
         <p:spPr>
           <a:xfrm>
-            <a:off x="1371600" y="3886200"/>
-            <a:ext cx="6400800" cy="228600"/>
+            <a:off x="1645920" y="3675888"/>
+            <a:ext cx="6583680" cy="256032"/>
           </a:xfrm>
           <a:prstGeom prst="rect">
             <a:avLst/>
@@ -3623,8 +3634,8 @@
         </p:nvSpPr>
         <p:spPr>
           <a:xfrm>
-            <a:off x="1097280" y="4297680"/>
-            <a:ext cx="6949440" cy="274320"/>
+            <a:off x="1371600" y="4078224"/>
+            <a:ext cx="6949440" cy="320040"/>
           </a:xfrm>
           <a:prstGeom prst="rect">
             <a:avLst/>
@@ -3659,8 +3670,8 @@
         </p:nvSpPr>
         <p:spPr>
           <a:xfrm>
-            <a:off x="1371600" y="4663440"/>
-            <a:ext cx="6400800" cy="228600"/>
+            <a:off x="1645920" y="4443984"/>
+            <a:ext cx="6583680" cy="256032"/>
           </a:xfrm>
           <a:prstGeom prst="rect">
             <a:avLst/>
@@ -3695,8 +3706,8 @@
         </p:nvSpPr>
         <p:spPr>
           <a:xfrm>
-            <a:off x="1371600" y="4937760"/>
-            <a:ext cx="6400800" cy="228600"/>
+            <a:off x="1645920" y="4736592"/>
+            <a:ext cx="6583680" cy="256032"/>
           </a:xfrm>
           <a:prstGeom prst="rect">
             <a:avLst/>
@@ -3718,6 +3729,7 @@
               </a:defRPr>
             </a:pPr>
             <a:r>
+              <a:rPr dirty="0"/>
               <a:t>✓ Professional presentation</a:t>
             </a:r>
           </a:p>
@@ -3731,8 +3743,8 @@
         </p:nvSpPr>
         <p:spPr>
           <a:xfrm>
-            <a:off x="1371600" y="5212080"/>
-            <a:ext cx="6400800" cy="228600"/>
+            <a:off x="1645920" y="5029200"/>
+            <a:ext cx="6583680" cy="256032"/>
           </a:xfrm>
           <a:prstGeom prst="rect">
             <a:avLst/>
@@ -3754,6 +3766,7 @@
               </a:defRPr>
             </a:pPr>
             <a:r>
+              <a:rPr dirty="0"/>
               <a:t>✓ Actionable business recommendations</a:t>
             </a:r>
           </a:p>
@@ -3767,21 +3780,39 @@
         </p:nvSpPr>
         <p:spPr>
           <a:xfrm>
-            <a:off x="1371600" y="5669280"/>
-            <a:ext cx="6400800" cy="640080"/>
+            <a:off x="1371599" y="5519850"/>
+            <a:ext cx="6185807" cy="761207"/>
           </a:xfrm>
           <a:prstGeom prst="roundRect">
             <a:avLst/>
           </a:prstGeom>
-          <a:solidFill>
-            <a:srgbClr val="F8F9FA"/>
-          </a:solidFill>
-          <a:ln w="6350">
-            <a:solidFill>
-              <a:srgbClr val="ECF0F1"/>
-            </a:solidFill>
+          <a:gradFill flip="none" rotWithShape="1">
+            <a:gsLst>
+              <a:gs pos="69000">
+                <a:srgbClr val="CEDCE0"/>
+              </a:gs>
+              <a:gs pos="100000">
+                <a:schemeClr val="accent3">
+                  <a:lumMod val="20000"/>
+                  <a:lumOff val="80000"/>
+                </a:schemeClr>
+              </a:gs>
+            </a:gsLst>
+            <a:path path="circle">
+              <a:fillToRect l="100000" t="100000"/>
+            </a:path>
+            <a:tileRect r="-100000" b="-100000"/>
+          </a:gradFill>
+          <a:ln w="6350" cap="rnd">
+            <a:noFill/>
           </a:ln>
-          <a:effectLst/>
+          <a:effectLst>
+            <a:outerShdw blurRad="386222" dir="3000000" algn="tl" rotWithShape="0">
+              <a:prstClr val="black">
+                <a:alpha val="14955"/>
+              </a:prstClr>
+            </a:outerShdw>
+          </a:effectLst>
         </p:spPr>
         <p:style>
           <a:lnRef idx="1">
@@ -3802,6 +3833,7 @@
           <a:lstStyle/>
           <a:p>
             <a:pPr algn="ctr"/>
+            <a:endParaRPr/>
           </a:p>
         </p:txBody>
       </p:sp>
@@ -3813,8 +3845,45 @@
         </p:nvSpPr>
         <p:spPr>
           <a:xfrm>
-            <a:off x="1371600" y="5760720"/>
-            <a:ext cx="6400800" cy="457200"/>
+            <a:off x="1586593" y="5577287"/>
+            <a:ext cx="5970814" cy="646331"/>
+          </a:xfrm>
+          <a:prstGeom prst="rect">
+            <a:avLst/>
+          </a:prstGeom>
+          <a:noFill/>
+        </p:spPr>
+        <p:txBody>
+          <a:bodyPr wrap="square">
+            <a:spAutoFit/>
+          </a:bodyPr>
+          <a:lstStyle/>
+          <a:p>
+            <a:pPr algn="ctr">
+              <a:defRPr sz="1800" b="1">
+                <a:solidFill>
+                  <a:srgbClr val="2C3E50"/>
+                </a:solidFill>
+                <a:latin typeface="Calibri"/>
+              </a:defRPr>
+            </a:pPr>
+            <a:r>
+              <a:rPr dirty="0"/>
+              <a:t>Production-ready analytics pipeline converting data into $3K+ revenue opportunities</a:t>
+            </a:r>
+          </a:p>
+        </p:txBody>
+      </p:sp>
+      <p:sp>
+        <p:nvSpPr>
+          <p:cNvPr id="17" name="TextBox 16"/>
+          <p:cNvSpPr txBox="1"/>
+          <p:nvPr/>
+        </p:nvSpPr>
+        <p:spPr>
+          <a:xfrm>
+            <a:off x="3200400" y="6400800"/>
+            <a:ext cx="2743200" cy="274320"/>
           </a:xfrm>
           <a:prstGeom prst="rect">
             <a:avLst/>
@@ -3828,42 +3897,6 @@
           <a:lstStyle/>
           <a:p>
             <a:pPr algn="ctr">
-              <a:defRPr sz="1800" b="1">
-                <a:solidFill>
-                  <a:srgbClr val="2C3E50"/>
-                </a:solidFill>
-                <a:latin typeface="Calibri"/>
-              </a:defRPr>
-            </a:pPr>
-            <a:r>
-              <a:t>Production-ready analytics pipeline converting data into $3K+ revenue opportunities</a:t>
-            </a:r>
-          </a:p>
-        </p:txBody>
-      </p:sp>
-      <p:sp>
-        <p:nvSpPr>
-          <p:cNvPr id="17" name="TextBox 16"/>
-          <p:cNvSpPr txBox="1"/>
-          <p:nvPr/>
-        </p:nvSpPr>
-        <p:spPr>
-          <a:xfrm>
-            <a:off x="3200400" y="6400800"/>
-            <a:ext cx="2743200" cy="274320"/>
-          </a:xfrm>
-          <a:prstGeom prst="rect">
-            <a:avLst/>
-          </a:prstGeom>
-          <a:noFill/>
-        </p:spPr>
-        <p:txBody>
-          <a:bodyPr wrap="none">
-            <a:spAutoFit/>
-          </a:bodyPr>
-          <a:lstStyle/>
-          <a:p>
-            <a:pPr algn="ctr">
               <a:defRPr sz="2000">
                 <a:solidFill>
                   <a:srgbClr val="7F8C8D"/>
@@ -3872,6 +3905,7 @@
               </a:defRPr>
             </a:pPr>
             <a:r>
+              <a:rPr dirty="0"/>
               <a:t>Thank you | Questions?</a:t>
             </a:r>
           </a:p>
@@ -3922,7 +3956,7 @@
 </file>
 
 <file path=ppt/slides/slide2.xml><?xml version="1.0" encoding="utf-8"?>
-<p:sld xmlns:a="http://schemas.openxmlformats.org/drawingml/2006/main" xmlns:p="http://schemas.openxmlformats.org/presentationml/2006/main" xmlns:r="http://schemas.openxmlformats.org/officeDocument/2006/relationships">
+<p:sld xmlns:a="http://schemas.openxmlformats.org/drawingml/2006/main" xmlns:r="http://schemas.openxmlformats.org/officeDocument/2006/relationships" xmlns:p="http://schemas.openxmlformats.org/presentationml/2006/main">
   <p:cSld>
     <p:bg>
       <p:bgPr>
@@ -3935,7 +3969,7 @@
               <a:srgbClr val="F8F9FA"/>
             </a:gs>
           </a:gsLst>
-          <a:lin scaled="0" ang="18900000"/>
+          <a:lin ang="18900000" scaled="0"/>
         </a:gradFill>
         <a:effectLst/>
       </p:bgPr>
@@ -3946,7 +3980,14 @@
         <p:cNvGrpSpPr/>
         <p:nvPr/>
       </p:nvGrpSpPr>
-      <p:grpSpPr/>
+      <p:grpSpPr>
+        <a:xfrm>
+          <a:off x="0" y="0"/>
+          <a:ext cx="0" cy="0"/>
+          <a:chOff x="0" y="0"/>
+          <a:chExt cx="0" cy="0"/>
+        </a:xfrm>
+      </p:grpSpPr>
       <p:sp>
         <p:nvSpPr>
           <p:cNvPr id="2" name="TextBox 1"/>
@@ -4026,6 +4067,7 @@
           <a:lstStyle/>
           <a:p>
             <a:pPr algn="ctr"/>
+            <a:endParaRPr/>
           </a:p>
         </p:txBody>
       </p:sp>
@@ -4110,6 +4152,7 @@
           <a:lstStyle/>
           <a:p>
             <a:pPr algn="ctr"/>
+            <a:endParaRPr/>
           </a:p>
         </p:txBody>
       </p:sp>
@@ -4156,6 +4199,7 @@
           <a:lstStyle/>
           <a:p>
             <a:pPr algn="ctr"/>
+            <a:endParaRPr/>
           </a:p>
         </p:txBody>
       </p:sp>
@@ -4240,6 +4284,7 @@
           <a:lstStyle/>
           <a:p>
             <a:pPr algn="ctr"/>
+            <a:endParaRPr/>
           </a:p>
         </p:txBody>
       </p:sp>
@@ -4286,6 +4331,7 @@
           <a:lstStyle/>
           <a:p>
             <a:pPr algn="ctr"/>
+            <a:endParaRPr/>
           </a:p>
         </p:txBody>
       </p:sp>
@@ -4370,6 +4416,7 @@
           <a:lstStyle/>
           <a:p>
             <a:pPr algn="ctr"/>
+            <a:endParaRPr/>
           </a:p>
         </p:txBody>
       </p:sp>
@@ -4416,6 +4463,7 @@
           <a:lstStyle/>
           <a:p>
             <a:pPr algn="ctr"/>
+            <a:endParaRPr/>
           </a:p>
         </p:txBody>
       </p:sp>
@@ -4450,11 +4498,13 @@
               </a:defRPr>
             </a:pPr>
             <a:r>
+              <a:rPr dirty="0"/>
               <a:t>MySQL</a:t>
             </a:r>
           </a:p>
           <a:p>
             <a:r>
+              <a:rPr dirty="0"/>
               <a:t>Database</a:t>
             </a:r>
           </a:p>
@@ -4500,6 +4550,7 @@
           <a:lstStyle/>
           <a:p>
             <a:pPr algn="ctr"/>
+            <a:endParaRPr/>
           </a:p>
         </p:txBody>
       </p:sp>
@@ -4546,6 +4597,7 @@
           <a:lstStyle/>
           <a:p>
             <a:pPr algn="ctr"/>
+            <a:endParaRPr/>
           </a:p>
         </p:txBody>
       </p:sp>
@@ -4734,7 +4786,7 @@
 </file>
 
 <file path=ppt/slides/slide3.xml><?xml version="1.0" encoding="utf-8"?>
-<p:sld xmlns:a="http://schemas.openxmlformats.org/drawingml/2006/main" xmlns:p="http://schemas.openxmlformats.org/presentationml/2006/main" xmlns:r="http://schemas.openxmlformats.org/officeDocument/2006/relationships">
+<p:sld xmlns:a="http://schemas.openxmlformats.org/drawingml/2006/main" xmlns:r="http://schemas.openxmlformats.org/officeDocument/2006/relationships" xmlns:p="http://schemas.openxmlformats.org/presentationml/2006/main">
   <p:cSld>
     <p:bg>
       <p:bgPr>
@@ -4747,7 +4799,7 @@
               <a:srgbClr val="F8F9FA"/>
             </a:gs>
           </a:gsLst>
-          <a:lin scaled="0" ang="18900000"/>
+          <a:lin ang="18900000" scaled="0"/>
         </a:gradFill>
         <a:effectLst/>
       </p:bgPr>
@@ -4758,7 +4810,14 @@
         <p:cNvGrpSpPr/>
         <p:nvPr/>
       </p:nvGrpSpPr>
-      <p:grpSpPr/>
+      <p:grpSpPr>
+        <a:xfrm>
+          <a:off x="0" y="0"/>
+          <a:ext cx="0" cy="0"/>
+          <a:chOff x="0" y="0"/>
+          <a:chExt cx="0" cy="0"/>
+        </a:xfrm>
+      </p:grpSpPr>
       <p:sp>
         <p:nvSpPr>
           <p:cNvPr id="2" name="TextBox 1"/>
@@ -4803,8 +4862,8 @@
         </p:nvSpPr>
         <p:spPr>
           <a:xfrm>
-            <a:off x="914400" y="2011680"/>
-            <a:ext cx="1828800" cy="1417320"/>
+            <a:off x="1371600" y="2011680"/>
+            <a:ext cx="2743200" cy="1508760"/>
           </a:xfrm>
           <a:prstGeom prst="roundRect">
             <a:avLst/>
@@ -4838,6 +4897,7 @@
           <a:lstStyle/>
           <a:p>
             <a:pPr algn="ctr"/>
+            <a:endParaRPr/>
           </a:p>
         </p:txBody>
       </p:sp>
@@ -4849,8 +4909,8 @@
         </p:nvSpPr>
         <p:spPr>
           <a:xfrm>
-            <a:off x="914400" y="2057400"/>
-            <a:ext cx="1828800" cy="274320"/>
+            <a:off x="1371600" y="2084832"/>
+            <a:ext cx="2743200" cy="274320"/>
           </a:xfrm>
           <a:prstGeom prst="rect">
             <a:avLst/>
@@ -4885,8 +4945,8 @@
         </p:nvSpPr>
         <p:spPr>
           <a:xfrm>
-            <a:off x="1005840" y="2377440"/>
-            <a:ext cx="1645920" cy="960120"/>
+            <a:off x="1508760" y="2423160"/>
+            <a:ext cx="2468880" cy="1051560"/>
           </a:xfrm>
           <a:prstGeom prst="rect">
             <a:avLst/>
@@ -4900,7 +4960,7 @@
           <a:lstStyle/>
           <a:p>
             <a:pPr>
-              <a:defRPr sz="1100">
+              <a:defRPr sz="1200">
                 <a:solidFill>
                   <a:srgbClr val="212121"/>
                 </a:solidFill>
@@ -4908,12 +4968,17 @@
               </a:defRPr>
             </a:pPr>
             <a:r>
-              <a:t>user_id (PK)</a:t>
+              <a:rPr dirty="0" err="1"/>
+              <a:t>user_id</a:t>
+            </a:r>
+            <a:r>
+              <a:rPr dirty="0"/>
+              <a:t> (PK)</a:t>
             </a:r>
           </a:p>
           <a:p>
             <a:pPr>
-              <a:defRPr sz="1100">
+              <a:defRPr sz="1200">
                 <a:solidFill>
                   <a:srgbClr val="212121"/>
                 </a:solidFill>
@@ -4921,12 +4986,13 @@
               </a:defRPr>
             </a:pPr>
             <a:r>
+              <a:rPr dirty="0"/>
               <a:t>username</a:t>
             </a:r>
           </a:p>
           <a:p>
             <a:pPr>
-              <a:defRPr sz="1100">
+              <a:defRPr sz="1200">
                 <a:solidFill>
                   <a:srgbClr val="212121"/>
                 </a:solidFill>
@@ -4934,12 +5000,13 @@
               </a:defRPr>
             </a:pPr>
             <a:r>
+              <a:rPr dirty="0"/>
               <a:t>country</a:t>
             </a:r>
           </a:p>
           <a:p>
             <a:pPr>
-              <a:defRPr sz="1100">
+              <a:defRPr sz="1200">
                 <a:solidFill>
                   <a:srgbClr val="212121"/>
                 </a:solidFill>
@@ -4947,12 +5014,13 @@
               </a:defRPr>
             </a:pPr>
             <a:r>
+              <a:rPr dirty="0"/>
               <a:t>age</a:t>
             </a:r>
           </a:p>
           <a:p>
             <a:pPr>
-              <a:defRPr sz="1100">
+              <a:defRPr sz="1200">
                 <a:solidFill>
                   <a:srgbClr val="212121"/>
                 </a:solidFill>
@@ -4960,6 +5028,7 @@
               </a:defRPr>
             </a:pPr>
             <a:r>
+              <a:rPr dirty="0"/>
               <a:t>gender</a:t>
             </a:r>
           </a:p>
@@ -4973,8 +5042,8 @@
         </p:nvSpPr>
         <p:spPr>
           <a:xfrm>
-            <a:off x="3200400" y="2011680"/>
-            <a:ext cx="1828800" cy="1188720"/>
+            <a:off x="5029200" y="2011680"/>
+            <a:ext cx="2743200" cy="1280160"/>
           </a:xfrm>
           <a:prstGeom prst="roundRect">
             <a:avLst/>
@@ -5008,6 +5077,7 @@
           <a:lstStyle/>
           <a:p>
             <a:pPr algn="ctr"/>
+            <a:endParaRPr/>
           </a:p>
         </p:txBody>
       </p:sp>
@@ -5019,8 +5089,8 @@
         </p:nvSpPr>
         <p:spPr>
           <a:xfrm>
-            <a:off x="3200400" y="2057400"/>
-            <a:ext cx="1828800" cy="274320"/>
+            <a:off x="5029200" y="2084832"/>
+            <a:ext cx="2743200" cy="274320"/>
           </a:xfrm>
           <a:prstGeom prst="rect">
             <a:avLst/>
@@ -5055,8 +5125,8 @@
         </p:nvSpPr>
         <p:spPr>
           <a:xfrm>
-            <a:off x="3291840" y="2377440"/>
-            <a:ext cx="1645920" cy="731520"/>
+            <a:off x="5166360" y="2423160"/>
+            <a:ext cx="2468880" cy="822960"/>
           </a:xfrm>
           <a:prstGeom prst="rect">
             <a:avLst/>
@@ -5070,7 +5140,7 @@
           <a:lstStyle/>
           <a:p>
             <a:pPr>
-              <a:defRPr sz="1100">
+              <a:defRPr sz="1200">
                 <a:solidFill>
                   <a:srgbClr val="212121"/>
                 </a:solidFill>
@@ -5083,7 +5153,7 @@
           </a:p>
           <a:p>
             <a:pPr>
-              <a:defRPr sz="1100">
+              <a:defRPr sz="1200">
                 <a:solidFill>
                   <a:srgbClr val="212121"/>
                 </a:solidFill>
@@ -5096,7 +5166,7 @@
           </a:p>
           <a:p>
             <a:pPr>
-              <a:defRPr sz="1100">
+              <a:defRPr sz="1200">
                 <a:solidFill>
                   <a:srgbClr val="212121"/>
                 </a:solidFill>
@@ -5109,7 +5179,7 @@
           </a:p>
           <a:p>
             <a:pPr>
-              <a:defRPr sz="1100">
+              <a:defRPr sz="1200">
                 <a:solidFill>
                   <a:srgbClr val="212121"/>
                 </a:solidFill>
@@ -5130,8 +5200,8 @@
         </p:nvSpPr>
         <p:spPr>
           <a:xfrm>
-            <a:off x="5486400" y="2011680"/>
-            <a:ext cx="1828800" cy="1188720"/>
+            <a:off x="1371600" y="4114800"/>
+            <a:ext cx="2743200" cy="1280160"/>
           </a:xfrm>
           <a:prstGeom prst="roundRect">
             <a:avLst/>
@@ -5165,6 +5235,7 @@
           <a:lstStyle/>
           <a:p>
             <a:pPr algn="ctr"/>
+            <a:endParaRPr/>
           </a:p>
         </p:txBody>
       </p:sp>
@@ -5176,8 +5247,8 @@
         </p:nvSpPr>
         <p:spPr>
           <a:xfrm>
-            <a:off x="5486400" y="2057400"/>
-            <a:ext cx="1828800" cy="274320"/>
+            <a:off x="1371600" y="4187952"/>
+            <a:ext cx="2743200" cy="274320"/>
           </a:xfrm>
           <a:prstGeom prst="rect">
             <a:avLst/>
@@ -5212,8 +5283,8 @@
         </p:nvSpPr>
         <p:spPr>
           <a:xfrm>
-            <a:off x="5577840" y="2377440"/>
-            <a:ext cx="1645920" cy="731520"/>
+            <a:off x="1508760" y="4526280"/>
+            <a:ext cx="2468880" cy="822960"/>
           </a:xfrm>
           <a:prstGeom prst="rect">
             <a:avLst/>
@@ -5227,7 +5298,7 @@
           <a:lstStyle/>
           <a:p>
             <a:pPr>
-              <a:defRPr sz="1100">
+              <a:defRPr sz="1200">
                 <a:solidFill>
                   <a:srgbClr val="212121"/>
                 </a:solidFill>
@@ -5240,7 +5311,7 @@
           </a:p>
           <a:p>
             <a:pPr>
-              <a:defRPr sz="1100">
+              <a:defRPr sz="1200">
                 <a:solidFill>
                   <a:srgbClr val="212121"/>
                 </a:solidFill>
@@ -5253,7 +5324,7 @@
           </a:p>
           <a:p>
             <a:pPr>
-              <a:defRPr sz="1100">
+              <a:defRPr sz="1200">
                 <a:solidFill>
                   <a:srgbClr val="212121"/>
                 </a:solidFill>
@@ -5266,7 +5337,7 @@
           </a:p>
           <a:p>
             <a:pPr>
-              <a:defRPr sz="1100">
+              <a:defRPr sz="1200">
                 <a:solidFill>
                   <a:srgbClr val="212121"/>
                 </a:solidFill>
@@ -5287,8 +5358,8 @@
         </p:nvSpPr>
         <p:spPr>
           <a:xfrm>
-            <a:off x="5486400" y="4389120"/>
-            <a:ext cx="1828800" cy="1188720"/>
+            <a:off x="5029200" y="4114800"/>
+            <a:ext cx="2743200" cy="1280160"/>
           </a:xfrm>
           <a:prstGeom prst="roundRect">
             <a:avLst/>
@@ -5322,6 +5393,7 @@
           <a:lstStyle/>
           <a:p>
             <a:pPr algn="ctr"/>
+            <a:endParaRPr/>
           </a:p>
         </p:txBody>
       </p:sp>
@@ -5333,8 +5405,8 @@
         </p:nvSpPr>
         <p:spPr>
           <a:xfrm>
-            <a:off x="5486400" y="4434840"/>
-            <a:ext cx="1828800" cy="274320"/>
+            <a:off x="5029200" y="4187952"/>
+            <a:ext cx="2743200" cy="274320"/>
           </a:xfrm>
           <a:prstGeom prst="rect">
             <a:avLst/>
@@ -5369,8 +5441,8 @@
         </p:nvSpPr>
         <p:spPr>
           <a:xfrm>
-            <a:off x="5577840" y="4754880"/>
-            <a:ext cx="1645920" cy="731520"/>
+            <a:off x="5166360" y="4526280"/>
+            <a:ext cx="2468880" cy="822960"/>
           </a:xfrm>
           <a:prstGeom prst="rect">
             <a:avLst/>
@@ -5384,7 +5456,7 @@
           <a:lstStyle/>
           <a:p>
             <a:pPr>
-              <a:defRPr sz="1100">
+              <a:defRPr sz="1200">
                 <a:solidFill>
                   <a:srgbClr val="212121"/>
                 </a:solidFill>
@@ -5397,7 +5469,7 @@
           </a:p>
           <a:p>
             <a:pPr>
-              <a:defRPr sz="1100">
+              <a:defRPr sz="1200">
                 <a:solidFill>
                   <a:srgbClr val="212121"/>
                 </a:solidFill>
@@ -5410,7 +5482,7 @@
           </a:p>
           <a:p>
             <a:pPr>
-              <a:defRPr sz="1100">
+              <a:defRPr sz="1200">
                 <a:solidFill>
                   <a:srgbClr val="212121"/>
                 </a:solidFill>
@@ -5423,7 +5495,7 @@
           </a:p>
           <a:p>
             <a:pPr>
-              <a:defRPr sz="1100">
+              <a:defRPr sz="1200">
                 <a:solidFill>
                   <a:srgbClr val="212121"/>
                 </a:solidFill>
@@ -5479,6 +5551,7 @@
           <a:lstStyle/>
           <a:p>
             <a:pPr algn="ctr"/>
+            <a:endParaRPr/>
           </a:p>
         </p:txBody>
       </p:sp>
@@ -5563,7 +5636,7 @@
 </file>
 
 <file path=ppt/slides/slide4.xml><?xml version="1.0" encoding="utf-8"?>
-<p:sld xmlns:a="http://schemas.openxmlformats.org/drawingml/2006/main" xmlns:p="http://schemas.openxmlformats.org/presentationml/2006/main" xmlns:r="http://schemas.openxmlformats.org/officeDocument/2006/relationships">
+<p:sld xmlns:a="http://schemas.openxmlformats.org/drawingml/2006/main" xmlns:r="http://schemas.openxmlformats.org/officeDocument/2006/relationships" xmlns:p="http://schemas.openxmlformats.org/presentationml/2006/main">
   <p:cSld>
     <p:bg>
       <p:bgPr>
@@ -5576,7 +5649,7 @@
               <a:srgbClr val="F8F9FA"/>
             </a:gs>
           </a:gsLst>
-          <a:lin scaled="0" ang="18900000"/>
+          <a:lin ang="18900000" scaled="0"/>
         </a:gradFill>
         <a:effectLst/>
       </p:bgPr>
@@ -5587,7 +5660,14 @@
         <p:cNvGrpSpPr/>
         <p:nvPr/>
       </p:nvGrpSpPr>
-      <p:grpSpPr/>
+      <p:grpSpPr>
+        <a:xfrm>
+          <a:off x="0" y="0"/>
+          <a:ext cx="0" cy="0"/>
+          <a:chOff x="0" y="0"/>
+          <a:chExt cx="0" cy="0"/>
+        </a:xfrm>
+      </p:grpSpPr>
       <p:sp>
         <p:nvSpPr>
           <p:cNvPr id="2" name="TextBox 1"/>
@@ -5667,6 +5747,7 @@
           <a:lstStyle/>
           <a:p>
             <a:pPr algn="ctr"/>
+            <a:endParaRPr/>
           </a:p>
         </p:txBody>
       </p:sp>
@@ -5785,6 +5866,7 @@
           <a:lstStyle/>
           <a:p>
             <a:pPr algn="ctr"/>
+            <a:endParaRPr/>
           </a:p>
         </p:txBody>
       </p:sp>
@@ -5903,6 +5985,7 @@
           <a:lstStyle/>
           <a:p>
             <a:pPr algn="ctr"/>
+            <a:endParaRPr/>
           </a:p>
         </p:txBody>
       </p:sp>
@@ -6158,7 +6241,7 @@
 </file>
 
 <file path=ppt/slides/slide5.xml><?xml version="1.0" encoding="utf-8"?>
-<p:sld xmlns:a="http://schemas.openxmlformats.org/drawingml/2006/main" xmlns:p="http://schemas.openxmlformats.org/presentationml/2006/main" xmlns:r="http://schemas.openxmlformats.org/officeDocument/2006/relationships">
+<p:sld xmlns:a="http://schemas.openxmlformats.org/drawingml/2006/main" xmlns:r="http://schemas.openxmlformats.org/officeDocument/2006/relationships" xmlns:p="http://schemas.openxmlformats.org/presentationml/2006/main">
   <p:cSld>
     <p:bg>
       <p:bgPr>
@@ -6171,7 +6254,7 @@
               <a:srgbClr val="F8F9FA"/>
             </a:gs>
           </a:gsLst>
-          <a:lin scaled="0" ang="18900000"/>
+          <a:lin ang="18900000" scaled="0"/>
         </a:gradFill>
         <a:effectLst/>
       </p:bgPr>
@@ -6182,7 +6265,14 @@
         <p:cNvGrpSpPr/>
         <p:nvPr/>
       </p:nvGrpSpPr>
-      <p:grpSpPr/>
+      <p:grpSpPr>
+        <a:xfrm>
+          <a:off x="0" y="0"/>
+          <a:ext cx="0" cy="0"/>
+          <a:chOff x="0" y="0"/>
+          <a:chExt cx="0" cy="0"/>
+        </a:xfrm>
+      </p:grpSpPr>
       <p:sp>
         <p:nvSpPr>
           <p:cNvPr id="2" name="TextBox 1"/>
@@ -6219,16 +6309,40 @@
           </a:p>
         </p:txBody>
       </p:sp>
-      <p:sp>
-        <p:nvSpPr>
-          <p:cNvPr id="3" name="Rounded Rectangle 2"/>
+      <p:pic>
+        <p:nvPicPr>
+          <p:cNvPr id="3" name="Picture 2" descr="01_dau_trend.png"/>
+          <p:cNvPicPr>
+            <a:picLocks noChangeAspect="1"/>
+          </p:cNvPicPr>
+          <p:nvPr/>
+        </p:nvPicPr>
+        <p:blipFill>
+          <a:blip r:embed="rId2"/>
+          <a:stretch>
+            <a:fillRect/>
+          </a:stretch>
+        </p:blipFill>
+        <p:spPr>
+          <a:xfrm>
+            <a:off x="548640" y="1645920"/>
+            <a:ext cx="5669280" cy="3401568"/>
+          </a:xfrm>
+          <a:prstGeom prst="rect">
+            <a:avLst/>
+          </a:prstGeom>
+        </p:spPr>
+      </p:pic>
+      <p:sp>
+        <p:nvSpPr>
+          <p:cNvPr id="4" name="Rounded Rectangle 3"/>
           <p:cNvSpPr/>
           <p:nvPr/>
         </p:nvSpPr>
         <p:spPr>
           <a:xfrm>
-            <a:off x="6583680" y="1645920"/>
-            <a:ext cx="2011680" cy="1188720"/>
+            <a:off x="6492240" y="1645920"/>
+            <a:ext cx="2194560" cy="1188720"/>
           </a:xfrm>
           <a:prstGeom prst="roundRect">
             <a:avLst/>
@@ -6262,19 +6376,20 @@
           <a:lstStyle/>
           <a:p>
             <a:pPr algn="ctr"/>
-          </a:p>
-        </p:txBody>
-      </p:sp>
-      <p:sp>
-        <p:nvSpPr>
-          <p:cNvPr id="4" name="TextBox 3"/>
+            <a:endParaRPr/>
+          </a:p>
+        </p:txBody>
+      </p:sp>
+      <p:sp>
+        <p:nvSpPr>
+          <p:cNvPr id="5" name="TextBox 4"/>
           <p:cNvSpPr txBox="1"/>
           <p:nvPr/>
         </p:nvSpPr>
         <p:spPr>
           <a:xfrm>
-            <a:off x="6583680" y="1920240"/>
-            <a:ext cx="2011680" cy="731520"/>
+            <a:off x="6492240" y="1920240"/>
+            <a:ext cx="2194560" cy="731520"/>
           </a:xfrm>
           <a:prstGeom prst="rect">
             <a:avLst/>
@@ -6303,14 +6418,14 @@
       </p:sp>
       <p:sp>
         <p:nvSpPr>
-          <p:cNvPr id="5" name="TextBox 4"/>
+          <p:cNvPr id="6" name="TextBox 5"/>
           <p:cNvSpPr txBox="1"/>
           <p:nvPr/>
         </p:nvSpPr>
         <p:spPr>
           <a:xfrm>
-            <a:off x="6583680" y="2743200"/>
-            <a:ext cx="2011680" cy="365760"/>
+            <a:off x="7072166" y="2449286"/>
+            <a:ext cx="1034707" cy="584775"/>
           </a:xfrm>
           <a:prstGeom prst="rect">
             <a:avLst/>
@@ -6332,11 +6447,18 @@
               </a:defRPr>
             </a:pPr>
             <a:r>
+              <a:rPr dirty="0"/>
               <a:t>Mean DAU</a:t>
             </a:r>
           </a:p>
           <a:p>
-            <a:r>
+            <a:pPr algn="ctr"/>
+            <a:r>
+              <a:rPr lang="en-US" dirty="0"/>
+              <a:t> </a:t>
+            </a:r>
+            <a:r>
+              <a:rPr dirty="0"/>
               <a:t>[8.6-9.6]</a:t>
             </a:r>
           </a:p>
@@ -6344,14 +6466,14 @@
       </p:sp>
       <p:sp>
         <p:nvSpPr>
-          <p:cNvPr id="6" name="Rounded Rectangle 5"/>
+          <p:cNvPr id="7" name="Rounded Rectangle 6"/>
           <p:cNvSpPr/>
           <p:nvPr/>
         </p:nvSpPr>
         <p:spPr>
           <a:xfrm>
-            <a:off x="6583680" y="3108960"/>
-            <a:ext cx="2011680" cy="1188720"/>
+            <a:off x="6492240" y="3108960"/>
+            <a:ext cx="2194560" cy="1188720"/>
           </a:xfrm>
           <a:prstGeom prst="roundRect">
             <a:avLst/>
@@ -6385,19 +6507,20 @@
           <a:lstStyle/>
           <a:p>
             <a:pPr algn="ctr"/>
-          </a:p>
-        </p:txBody>
-      </p:sp>
-      <p:sp>
-        <p:nvSpPr>
-          <p:cNvPr id="7" name="TextBox 6"/>
+            <a:endParaRPr/>
+          </a:p>
+        </p:txBody>
+      </p:sp>
+      <p:sp>
+        <p:nvSpPr>
+          <p:cNvPr id="8" name="TextBox 7"/>
           <p:cNvSpPr txBox="1"/>
           <p:nvPr/>
         </p:nvSpPr>
         <p:spPr>
           <a:xfrm>
-            <a:off x="6583680" y="3383280"/>
-            <a:ext cx="2011680" cy="731520"/>
+            <a:off x="6492240" y="3383280"/>
+            <a:ext cx="2194560" cy="731520"/>
           </a:xfrm>
           <a:prstGeom prst="rect">
             <a:avLst/>
@@ -6426,14 +6549,14 @@
       </p:sp>
       <p:sp>
         <p:nvSpPr>
-          <p:cNvPr id="8" name="TextBox 7"/>
+          <p:cNvPr id="9" name="TextBox 8"/>
           <p:cNvSpPr txBox="1"/>
           <p:nvPr/>
         </p:nvSpPr>
         <p:spPr>
           <a:xfrm>
-            <a:off x="6583680" y="4206240"/>
-            <a:ext cx="2011680" cy="365760"/>
+            <a:off x="6929724" y="3931920"/>
+            <a:ext cx="1319592" cy="584775"/>
           </a:xfrm>
           <a:prstGeom prst="rect">
             <a:avLst/>
@@ -6455,11 +6578,18 @@
               </a:defRPr>
             </a:pPr>
             <a:r>
+              <a:rPr dirty="0"/>
               <a:t>Mean MAU</a:t>
             </a:r>
           </a:p>
           <a:p>
-            <a:r>
+            <a:pPr algn="ctr"/>
+            <a:r>
+              <a:rPr lang="en-US" dirty="0"/>
+              <a:t>  </a:t>
+            </a:r>
+            <a:r>
+              <a:rPr dirty="0"/>
               <a:t>[82.8-94.7]</a:t>
             </a:r>
           </a:p>
@@ -6467,14 +6597,14 @@
       </p:sp>
       <p:sp>
         <p:nvSpPr>
-          <p:cNvPr id="9" name="Rounded Rectangle 8"/>
+          <p:cNvPr id="10" name="Rounded Rectangle 9"/>
           <p:cNvSpPr/>
           <p:nvPr/>
         </p:nvSpPr>
         <p:spPr>
           <a:xfrm>
-            <a:off x="6583680" y="4572000"/>
-            <a:ext cx="2011680" cy="1188720"/>
+            <a:off x="6492240" y="4572000"/>
+            <a:ext cx="2194560" cy="1188720"/>
           </a:xfrm>
           <a:prstGeom prst="roundRect">
             <a:avLst/>
@@ -6508,19 +6638,20 @@
           <a:lstStyle/>
           <a:p>
             <a:pPr algn="ctr"/>
-          </a:p>
-        </p:txBody>
-      </p:sp>
-      <p:sp>
-        <p:nvSpPr>
-          <p:cNvPr id="10" name="TextBox 9"/>
+            <a:endParaRPr/>
+          </a:p>
+        </p:txBody>
+      </p:sp>
+      <p:sp>
+        <p:nvSpPr>
+          <p:cNvPr id="11" name="TextBox 10"/>
           <p:cNvSpPr txBox="1"/>
           <p:nvPr/>
         </p:nvSpPr>
         <p:spPr>
           <a:xfrm>
-            <a:off x="6583680" y="4846320"/>
-            <a:ext cx="2011680" cy="731520"/>
+            <a:off x="6492240" y="4846320"/>
+            <a:ext cx="2194560" cy="731520"/>
           </a:xfrm>
           <a:prstGeom prst="rect">
             <a:avLst/>
@@ -6549,14 +6680,14 @@
       </p:sp>
       <p:sp>
         <p:nvSpPr>
-          <p:cNvPr id="11" name="TextBox 10"/>
+          <p:cNvPr id="12" name="TextBox 11"/>
           <p:cNvSpPr txBox="1"/>
           <p:nvPr/>
         </p:nvSpPr>
         <p:spPr>
           <a:xfrm>
-            <a:off x="6583680" y="5669280"/>
-            <a:ext cx="2011680" cy="365760"/>
+            <a:off x="7142923" y="5486400"/>
+            <a:ext cx="893193" cy="584775"/>
           </a:xfrm>
           <a:prstGeom prst="rect">
             <a:avLst/>
@@ -6578,40 +6709,19 @@
               </a:defRPr>
             </a:pPr>
             <a:r>
+              <a:rPr dirty="0"/>
               <a:t>Stickiness</a:t>
             </a:r>
           </a:p>
           <a:p>
-            <a:r>
+            <a:pPr algn="ctr"/>
+            <a:r>
+              <a:rPr dirty="0"/>
               <a:t>Ratio</a:t>
             </a:r>
           </a:p>
         </p:txBody>
       </p:sp>
-      <p:pic>
-        <p:nvPicPr>
-          <p:cNvPr id="12" name="Picture 11" descr="01_dau_trend.png"/>
-          <p:cNvPicPr>
-            <a:picLocks noChangeAspect="1"/>
-          </p:cNvPicPr>
-          <p:nvPr/>
-        </p:nvPicPr>
-        <p:blipFill>
-          <a:blip r:embed="rId2"/>
-          <a:stretch>
-            <a:fillRect/>
-          </a:stretch>
-        </p:blipFill>
-        <p:spPr>
-          <a:xfrm>
-            <a:off x="640080" y="1645920"/>
-            <a:ext cx="5486400" cy="3291840"/>
-          </a:xfrm>
-          <a:prstGeom prst="rect">
-            <a:avLst/>
-          </a:prstGeom>
-        </p:spPr>
-      </p:pic>
       <p:sp>
         <p:nvSpPr>
           <p:cNvPr id="13" name="TextBox 12"/>
@@ -6693,7 +6803,7 @@
 </file>
 
 <file path=ppt/slides/slide6.xml><?xml version="1.0" encoding="utf-8"?>
-<p:sld xmlns:a="http://schemas.openxmlformats.org/drawingml/2006/main" xmlns:p="http://schemas.openxmlformats.org/presentationml/2006/main" xmlns:r="http://schemas.openxmlformats.org/officeDocument/2006/relationships">
+<p:sld xmlns:a="http://schemas.openxmlformats.org/drawingml/2006/main" xmlns:r="http://schemas.openxmlformats.org/officeDocument/2006/relationships" xmlns:p="http://schemas.openxmlformats.org/presentationml/2006/main">
   <p:cSld>
     <p:bg>
       <p:bgPr>
@@ -6706,7 +6816,7 @@
               <a:srgbClr val="F8F9FA"/>
             </a:gs>
           </a:gsLst>
-          <a:lin scaled="0" ang="18900000"/>
+          <a:lin ang="18900000" scaled="0"/>
         </a:gradFill>
         <a:effectLst/>
       </p:bgPr>
@@ -6717,7 +6827,14 @@
         <p:cNvGrpSpPr/>
         <p:nvPr/>
       </p:nvGrpSpPr>
-      <p:grpSpPr/>
+      <p:grpSpPr>
+        <a:xfrm>
+          <a:off x="0" y="0"/>
+          <a:ext cx="0" cy="0"/>
+          <a:chOff x="0" y="0"/>
+          <a:chExt cx="0" cy="0"/>
+        </a:xfrm>
+      </p:grpSpPr>
       <p:sp>
         <p:nvSpPr>
           <p:cNvPr id="2" name="TextBox 1"/>
@@ -6727,7 +6844,7 @@
         <p:spPr>
           <a:xfrm>
             <a:off x="457200" y="457200"/>
-            <a:ext cx="8229600" cy="914400"/>
+            <a:ext cx="8229600" cy="707886"/>
           </a:xfrm>
           <a:prstGeom prst="rect">
             <a:avLst/>
@@ -6762,8 +6879,8 @@
         </p:nvSpPr>
         <p:spPr>
           <a:xfrm>
-            <a:off x="1828800" y="1371600"/>
-            <a:ext cx="5486400" cy="822960"/>
+            <a:off x="1645918" y="1371600"/>
+            <a:ext cx="6400799" cy="731520"/>
           </a:xfrm>
           <a:prstGeom prst="roundRect">
             <a:avLst/>
@@ -6797,6 +6914,7 @@
           <a:lstStyle/>
           <a:p>
             <a:pPr algn="ctr"/>
+            <a:endParaRPr/>
           </a:p>
         </p:txBody>
       </p:sp>
@@ -6808,8 +6926,8 @@
         </p:nvSpPr>
         <p:spPr>
           <a:xfrm>
-            <a:off x="1828800" y="1508760"/>
-            <a:ext cx="5486400" cy="548640"/>
+            <a:off x="1645919" y="1463040"/>
+            <a:ext cx="6400799" cy="492443"/>
           </a:xfrm>
           <a:prstGeom prst="rect">
             <a:avLst/>
@@ -6817,13 +6935,13 @@
           <a:noFill/>
         </p:spPr>
         <p:txBody>
-          <a:bodyPr wrap="none">
+          <a:bodyPr wrap="square">
             <a:spAutoFit/>
           </a:bodyPr>
           <a:lstStyle/>
           <a:p>
             <a:pPr algn="ctr">
-              <a:defRPr sz="2800" b="1">
+              <a:defRPr sz="2600" b="1">
                 <a:solidFill>
                   <a:srgbClr val="FFFFFF"/>
                 </a:solidFill>
@@ -6831,6 +6949,7 @@
               </a:defRPr>
             </a:pPr>
             <a:r>
+              <a:rPr dirty="0"/>
               <a:t>65.6% D7 Retention - 3-4x Industry Average</a:t>
             </a:r>
           </a:p>
@@ -6852,7 +6971,7 @@
         </p:blipFill>
         <p:spPr>
           <a:xfrm>
-            <a:off x="1371600" y="2560320"/>
+            <a:off x="1645918" y="2309634"/>
             <a:ext cx="6400800" cy="3840480"/>
           </a:xfrm>
           <a:prstGeom prst="rect">
@@ -6891,6 +7010,7 @@
               </a:defRPr>
             </a:pPr>
             <a:r>
+              <a:rPr dirty="0"/>
               <a:t>Exceptional product-market fit - users who try, stay</a:t>
             </a:r>
           </a:p>
@@ -6941,7 +7061,7 @@
 </file>
 
 <file path=ppt/slides/slide7.xml><?xml version="1.0" encoding="utf-8"?>
-<p:sld xmlns:a="http://schemas.openxmlformats.org/drawingml/2006/main" xmlns:p="http://schemas.openxmlformats.org/presentationml/2006/main" xmlns:r="http://schemas.openxmlformats.org/officeDocument/2006/relationships">
+<p:sld xmlns:a="http://schemas.openxmlformats.org/drawingml/2006/main" xmlns:r="http://schemas.openxmlformats.org/officeDocument/2006/relationships" xmlns:p="http://schemas.openxmlformats.org/presentationml/2006/main">
   <p:cSld>
     <p:bg>
       <p:bgPr>
@@ -6954,7 +7074,7 @@
               <a:srgbClr val="F8F9FA"/>
             </a:gs>
           </a:gsLst>
-          <a:lin scaled="0" ang="18900000"/>
+          <a:lin ang="18900000" scaled="0"/>
         </a:gradFill>
         <a:effectLst/>
       </p:bgPr>
@@ -6965,7 +7085,14 @@
         <p:cNvGrpSpPr/>
         <p:nvPr/>
       </p:nvGrpSpPr>
-      <p:grpSpPr/>
+      <p:grpSpPr>
+        <a:xfrm>
+          <a:off x="0" y="0"/>
+          <a:ext cx="0" cy="0"/>
+          <a:chOff x="0" y="0"/>
+          <a:chExt cx="0" cy="0"/>
+        </a:xfrm>
+      </p:grpSpPr>
       <p:sp>
         <p:nvSpPr>
           <p:cNvPr id="2" name="TextBox 1"/>
@@ -7010,8 +7137,8 @@
         </p:nvSpPr>
         <p:spPr>
           <a:xfrm>
-            <a:off x="914400" y="1463040"/>
-            <a:ext cx="1645920" cy="914400"/>
+            <a:off x="1097280" y="1463040"/>
+            <a:ext cx="1554480" cy="1005840"/>
           </a:xfrm>
           <a:prstGeom prst="roundRect">
             <a:avLst/>
@@ -7045,6 +7172,7 @@
           <a:lstStyle/>
           <a:p>
             <a:pPr algn="ctr"/>
+            <a:endParaRPr/>
           </a:p>
         </p:txBody>
       </p:sp>
@@ -7056,8 +7184,8 @@
         </p:nvSpPr>
         <p:spPr>
           <a:xfrm>
-            <a:off x="914400" y="1737360"/>
-            <a:ext cx="1645920" cy="731520"/>
+            <a:off x="1097280" y="1737360"/>
+            <a:ext cx="1554480" cy="731520"/>
           </a:xfrm>
           <a:prstGeom prst="rect">
             <a:avLst/>
@@ -7079,6 +7207,7 @@
               </a:defRPr>
             </a:pPr>
             <a:r>
+              <a:rPr dirty="0"/>
               <a:t>$10.86</a:t>
             </a:r>
           </a:p>
@@ -7092,8 +7221,8 @@
         </p:nvSpPr>
         <p:spPr>
           <a:xfrm>
-            <a:off x="914400" y="2560320"/>
-            <a:ext cx="1645920" cy="365760"/>
+            <a:off x="1097280" y="2560320"/>
+            <a:ext cx="1554480" cy="365760"/>
           </a:xfrm>
           <a:prstGeom prst="rect">
             <a:avLst/>
@@ -7128,8 +7257,8 @@
         </p:nvSpPr>
         <p:spPr>
           <a:xfrm>
-            <a:off x="3017520" y="1463040"/>
-            <a:ext cx="1645920" cy="914400"/>
+            <a:off x="2926080" y="1463040"/>
+            <a:ext cx="1554480" cy="1005840"/>
           </a:xfrm>
           <a:prstGeom prst="roundRect">
             <a:avLst/>
@@ -7163,6 +7292,7 @@
           <a:lstStyle/>
           <a:p>
             <a:pPr algn="ctr"/>
+            <a:endParaRPr/>
           </a:p>
         </p:txBody>
       </p:sp>
@@ -7174,8 +7304,8 @@
         </p:nvSpPr>
         <p:spPr>
           <a:xfrm>
-            <a:off x="3017520" y="1737360"/>
-            <a:ext cx="1645920" cy="731520"/>
+            <a:off x="2926080" y="1737360"/>
+            <a:ext cx="1554480" cy="731520"/>
           </a:xfrm>
           <a:prstGeom prst="rect">
             <a:avLst/>
@@ -7210,8 +7340,8 @@
         </p:nvSpPr>
         <p:spPr>
           <a:xfrm>
-            <a:off x="3017520" y="2560320"/>
-            <a:ext cx="1645920" cy="365760"/>
+            <a:off x="2926080" y="2560320"/>
+            <a:ext cx="1554480" cy="365760"/>
           </a:xfrm>
           <a:prstGeom prst="rect">
             <a:avLst/>
@@ -7246,8 +7376,8 @@
         </p:nvSpPr>
         <p:spPr>
           <a:xfrm>
-            <a:off x="5120640" y="1463040"/>
-            <a:ext cx="1645920" cy="914400"/>
+            <a:off x="4754880" y="1463040"/>
+            <a:ext cx="1554480" cy="1005840"/>
           </a:xfrm>
           <a:prstGeom prst="roundRect">
             <a:avLst/>
@@ -7281,6 +7411,7 @@
           <a:lstStyle/>
           <a:p>
             <a:pPr algn="ctr"/>
+            <a:endParaRPr/>
           </a:p>
         </p:txBody>
       </p:sp>
@@ -7292,8 +7423,8 @@
         </p:nvSpPr>
         <p:spPr>
           <a:xfrm>
-            <a:off x="5120640" y="1737360"/>
-            <a:ext cx="1645920" cy="731520"/>
+            <a:off x="4754880" y="1737360"/>
+            <a:ext cx="1554480" cy="731520"/>
           </a:xfrm>
           <a:prstGeom prst="rect">
             <a:avLst/>
@@ -7328,8 +7459,8 @@
         </p:nvSpPr>
         <p:spPr>
           <a:xfrm>
-            <a:off x="5120640" y="2560320"/>
-            <a:ext cx="1645920" cy="365760"/>
+            <a:off x="4754880" y="2560320"/>
+            <a:ext cx="1554480" cy="365760"/>
           </a:xfrm>
           <a:prstGeom prst="rect">
             <a:avLst/>
@@ -7364,8 +7495,8 @@
         </p:nvSpPr>
         <p:spPr>
           <a:xfrm>
-            <a:off x="7223760" y="1463040"/>
-            <a:ext cx="1645920" cy="914400"/>
+            <a:off x="6583680" y="1463040"/>
+            <a:ext cx="1554480" cy="1005840"/>
           </a:xfrm>
           <a:prstGeom prst="roundRect">
             <a:avLst/>
@@ -7399,6 +7530,7 @@
           <a:lstStyle/>
           <a:p>
             <a:pPr algn="ctr"/>
+            <a:endParaRPr/>
           </a:p>
         </p:txBody>
       </p:sp>
@@ -7410,8 +7542,8 @@
         </p:nvSpPr>
         <p:spPr>
           <a:xfrm>
-            <a:off x="7223760" y="1737360"/>
-            <a:ext cx="1645920" cy="731520"/>
+            <a:off x="6583680" y="1737360"/>
+            <a:ext cx="1554480" cy="731520"/>
           </a:xfrm>
           <a:prstGeom prst="rect">
             <a:avLst/>
@@ -7446,8 +7578,8 @@
         </p:nvSpPr>
         <p:spPr>
           <a:xfrm>
-            <a:off x="7223760" y="2560320"/>
-            <a:ext cx="1645920" cy="365760"/>
+            <a:off x="6583680" y="2560320"/>
+            <a:ext cx="1554480" cy="365760"/>
           </a:xfrm>
           <a:prstGeom prst="rect">
             <a:avLst/>
@@ -7490,8 +7622,8 @@
         </p:blipFill>
         <p:spPr>
           <a:xfrm>
-            <a:off x="1371600" y="2926080"/>
-            <a:ext cx="6400800" cy="3840480"/>
+            <a:off x="1737360" y="3017520"/>
+            <a:ext cx="5486400" cy="3291840"/>
           </a:xfrm>
           <a:prstGeom prst="rect">
             <a:avLst/>
@@ -7579,7 +7711,7 @@
 </file>
 
 <file path=ppt/slides/slide8.xml><?xml version="1.0" encoding="utf-8"?>
-<p:sld xmlns:a="http://schemas.openxmlformats.org/drawingml/2006/main" xmlns:p="http://schemas.openxmlformats.org/presentationml/2006/main" xmlns:r="http://schemas.openxmlformats.org/officeDocument/2006/relationships">
+<p:sld xmlns:a="http://schemas.openxmlformats.org/drawingml/2006/main" xmlns:r="http://schemas.openxmlformats.org/officeDocument/2006/relationships" xmlns:p="http://schemas.openxmlformats.org/presentationml/2006/main">
   <p:cSld>
     <p:bg>
       <p:bgPr>
@@ -7592,7 +7724,7 @@
               <a:srgbClr val="F8F9FA"/>
             </a:gs>
           </a:gsLst>
-          <a:lin scaled="0" ang="18900000"/>
+          <a:lin ang="18900000" scaled="0"/>
         </a:gradFill>
         <a:effectLst/>
       </p:bgPr>
@@ -7603,7 +7735,14 @@
         <p:cNvGrpSpPr/>
         <p:nvPr/>
       </p:nvGrpSpPr>
-      <p:grpSpPr/>
+      <p:grpSpPr>
+        <a:xfrm>
+          <a:off x="0" y="0"/>
+          <a:ext cx="0" cy="0"/>
+          <a:chOff x="0" y="0"/>
+          <a:chExt cx="0" cy="0"/>
+        </a:xfrm>
+      </p:grpSpPr>
       <p:sp>
         <p:nvSpPr>
           <p:cNvPr id="2" name="TextBox 1"/>
@@ -7656,8 +7795,8 @@
         </p:blipFill>
         <p:spPr>
           <a:xfrm>
-            <a:off x="640080" y="1645920"/>
-            <a:ext cx="5029200" cy="3017520"/>
+            <a:off x="548640" y="1645920"/>
+            <a:ext cx="5303520" cy="3182112"/>
           </a:xfrm>
           <a:prstGeom prst="rect">
             <a:avLst/>
@@ -7672,8 +7811,8 @@
         </p:nvSpPr>
         <p:spPr>
           <a:xfrm>
-            <a:off x="5943600" y="1645920"/>
-            <a:ext cx="2743200" cy="4389120"/>
+            <a:off x="6035040" y="1645920"/>
+            <a:ext cx="2834640" cy="4480560"/>
           </a:xfrm>
           <a:prstGeom prst="roundRect">
             <a:avLst/>
@@ -7707,6 +7846,7 @@
           <a:lstStyle/>
           <a:p>
             <a:pPr algn="ctr"/>
+            <a:endParaRPr/>
           </a:p>
         </p:txBody>
       </p:sp>
@@ -7718,8 +7858,8 @@
         </p:nvSpPr>
         <p:spPr>
           <a:xfrm>
-            <a:off x="6126480" y="1828800"/>
-            <a:ext cx="2377440" cy="3931920"/>
+            <a:off x="6172200" y="1920240"/>
+            <a:ext cx="2560320" cy="3931920"/>
           </a:xfrm>
           <a:prstGeom prst="rect">
             <a:avLst/>
@@ -7734,9 +7874,9 @@
           <a:p>
             <a:pPr>
               <a:spcAft>
-                <a:spcPts val="600"/>
+                <a:spcPts val="800"/>
               </a:spcAft>
-              <a:defRPr b="1" sz="1600">
+              <a:defRPr sz="1600" b="1">
                 <a:solidFill>
                   <a:srgbClr val="3498DB"/>
                 </a:solidFill>
@@ -7750,9 +7890,9 @@
           <a:p>
             <a:pPr>
               <a:spcAft>
-                <a:spcPts val="600"/>
+                <a:spcPts val="800"/>
               </a:spcAft>
-              <a:defRPr sz="1400">
+              <a:defRPr sz="1500">
                 <a:solidFill>
                   <a:srgbClr val="212121"/>
                 </a:solidFill>
@@ -7766,9 +7906,9 @@
           <a:p>
             <a:pPr>
               <a:spcAft>
-                <a:spcPts val="600"/>
+                <a:spcPts val="800"/>
               </a:spcAft>
-              <a:defRPr sz="1400">
+              <a:defRPr sz="1500">
                 <a:solidFill>
                   <a:srgbClr val="212121"/>
                 </a:solidFill>
@@ -7782,22 +7922,23 @@
           <a:p>
             <a:pPr>
               <a:spcAft>
-                <a:spcPts val="600"/>
+                <a:spcPts val="800"/>
               </a:spcAft>
-              <a:defRPr sz="1400">
+              <a:defRPr sz="1500">
                 <a:solidFill>
                   <a:srgbClr val="212121"/>
                 </a:solidFill>
                 <a:latin typeface="Calibri"/>
               </a:defRPr>
             </a:pPr>
+            <a:endParaRPr/>
           </a:p>
           <a:p>
             <a:pPr>
               <a:spcAft>
-                <a:spcPts val="600"/>
+                <a:spcPts val="800"/>
               </a:spcAft>
-              <a:defRPr b="1" sz="1600">
+              <a:defRPr sz="1600" b="1">
                 <a:solidFill>
                   <a:srgbClr val="3498DB"/>
                 </a:solidFill>
@@ -7811,9 +7952,9 @@
           <a:p>
             <a:pPr>
               <a:spcAft>
-                <a:spcPts val="600"/>
+                <a:spcPts val="800"/>
               </a:spcAft>
-              <a:defRPr sz="1400">
+              <a:defRPr sz="1500">
                 <a:solidFill>
                   <a:srgbClr val="212121"/>
                 </a:solidFill>
@@ -7827,22 +7968,23 @@
           <a:p>
             <a:pPr>
               <a:spcAft>
-                <a:spcPts val="600"/>
+                <a:spcPts val="800"/>
               </a:spcAft>
-              <a:defRPr sz="1400">
+              <a:defRPr sz="1500">
                 <a:solidFill>
                   <a:srgbClr val="212121"/>
                 </a:solidFill>
                 <a:latin typeface="Calibri"/>
               </a:defRPr>
             </a:pPr>
+            <a:endParaRPr/>
           </a:p>
           <a:p>
             <a:pPr>
               <a:spcAft>
-                <a:spcPts val="600"/>
+                <a:spcPts val="800"/>
               </a:spcAft>
-              <a:defRPr b="1" sz="1600">
+              <a:defRPr sz="1600" b="1">
                 <a:solidFill>
                   <a:srgbClr val="3498DB"/>
                 </a:solidFill>
@@ -7856,9 +7998,9 @@
           <a:p>
             <a:pPr>
               <a:spcAft>
-                <a:spcPts val="600"/>
+                <a:spcPts val="800"/>
               </a:spcAft>
-              <a:defRPr sz="1400">
+              <a:defRPr sz="1500">
                 <a:solidFill>
                   <a:srgbClr val="212121"/>
                 </a:solidFill>
@@ -7916,7 +8058,7 @@
 </file>
 
 <file path=ppt/slides/slide9.xml><?xml version="1.0" encoding="utf-8"?>
-<p:sld xmlns:a="http://schemas.openxmlformats.org/drawingml/2006/main" xmlns:p="http://schemas.openxmlformats.org/presentationml/2006/main" xmlns:r="http://schemas.openxmlformats.org/officeDocument/2006/relationships">
+<p:sld xmlns:a="http://schemas.openxmlformats.org/drawingml/2006/main" xmlns:r="http://schemas.openxmlformats.org/officeDocument/2006/relationships" xmlns:p="http://schemas.openxmlformats.org/presentationml/2006/main">
   <p:cSld>
     <p:bg>
       <p:bgPr>
@@ -7929,7 +8071,7 @@
               <a:srgbClr val="F8F9FA"/>
             </a:gs>
           </a:gsLst>
-          <a:lin scaled="0" ang="18900000"/>
+          <a:lin ang="18900000" scaled="0"/>
         </a:gradFill>
         <a:effectLst/>
       </p:bgPr>
@@ -7940,7 +8082,14 @@
         <p:cNvGrpSpPr/>
         <p:nvPr/>
       </p:nvGrpSpPr>
-      <p:grpSpPr/>
+      <p:grpSpPr>
+        <a:xfrm>
+          <a:off x="0" y="0"/>
+          <a:ext cx="0" cy="0"/>
+          <a:chOff x="0" y="0"/>
+          <a:chExt cx="0" cy="0"/>
+        </a:xfrm>
+      </p:grpSpPr>
       <p:sp>
         <p:nvSpPr>
           <p:cNvPr id="2" name="TextBox 1"/>
@@ -7985,7 +8134,7 @@
         </p:nvSpPr>
         <p:spPr>
           <a:xfrm>
-            <a:off x="1097280" y="1828800"/>
+            <a:off x="1097280" y="2011680"/>
             <a:ext cx="6949440" cy="3200400"/>
           </a:xfrm>
           <a:prstGeom prst="rect">
@@ -8014,6 +8163,7 @@
               </a:defRPr>
             </a:pPr>
             <a:r>
+              <a:rPr dirty="0"/>
               <a:t>65.6% retention → Protect core gameplay loop (3-4x industry avg)</a:t>
             </a:r>
           </a:p>
@@ -8033,6 +8183,7 @@
               </a:defRPr>
             </a:pPr>
             <a:r>
+              <a:rPr dirty="0"/>
               <a:t>51.5% conversion → Focus on ARPPU growth, not conversion</a:t>
             </a:r>
           </a:p>
@@ -8052,6 +8203,7 @@
               </a:defRPr>
             </a:pPr>
             <a:r>
+              <a:rPr dirty="0"/>
               <a:t>Diamond Pack dominance → Expand $50-$100 premium tier</a:t>
             </a:r>
           </a:p>
@@ -8071,6 +8223,7 @@
               </a:defRPr>
             </a:pPr>
             <a:r>
+              <a:rPr dirty="0"/>
               <a:t>Geographic winners → Target Ireland, Suriname, Brazil for UA</a:t>
             </a:r>
           </a:p>
@@ -8084,21 +8237,42 @@
         </p:nvSpPr>
         <p:spPr>
           <a:xfrm>
-            <a:off x="1371600" y="5303520"/>
-            <a:ext cx="6400800" cy="914400"/>
+            <a:off x="1371599" y="5486400"/>
+            <a:ext cx="6531429" cy="914400"/>
           </a:xfrm>
           <a:prstGeom prst="roundRect">
             <a:avLst/>
           </a:prstGeom>
-          <a:solidFill>
-            <a:srgbClr val="E67E22"/>
-          </a:solidFill>
+          <a:gradFill flip="none" rotWithShape="1">
+            <a:gsLst>
+              <a:gs pos="0">
+                <a:schemeClr val="accent6">
+                  <a:lumMod val="86000"/>
+                  <a:lumOff val="14000"/>
+                </a:schemeClr>
+              </a:gs>
+              <a:gs pos="99000">
+                <a:schemeClr val="accent4">
+                  <a:lumMod val="52000"/>
+                  <a:lumOff val="48000"/>
+                </a:schemeClr>
+              </a:gs>
+            </a:gsLst>
+            <a:path path="circle">
+              <a:fillToRect l="100000" t="100000"/>
+            </a:path>
+            <a:tileRect r="-100000" b="-100000"/>
+          </a:gradFill>
           <a:ln w="6350">
-            <a:solidFill>
-              <a:srgbClr val="ECF0F1"/>
-            </a:solidFill>
+            <a:noFill/>
           </a:ln>
-          <a:effectLst/>
+          <a:effectLst>
+            <a:outerShdw blurRad="535990" sx="98000" sy="98000" algn="ctr" rotWithShape="0">
+              <a:prstClr val="black">
+                <a:alpha val="18347"/>
+              </a:prstClr>
+            </a:outerShdw>
+          </a:effectLst>
         </p:spPr>
         <p:style>
           <a:lnRef idx="1">
@@ -8119,6 +8293,7 @@
           <a:lstStyle/>
           <a:p>
             <a:pPr algn="ctr"/>
+            <a:endParaRPr/>
           </a:p>
         </p:txBody>
       </p:sp>
@@ -8130,7 +8305,7 @@
         </p:nvSpPr>
         <p:spPr>
           <a:xfrm>
-            <a:off x="1371600" y="5486400"/>
+            <a:off x="1371600" y="5577840"/>
             <a:ext cx="6400800" cy="548640"/>
           </a:xfrm>
           <a:prstGeom prst="rect">
@@ -8139,7 +8314,7 @@
           <a:noFill/>
         </p:spPr>
         <p:txBody>
-          <a:bodyPr wrap="none">
+          <a:bodyPr wrap="square">
             <a:spAutoFit/>
           </a:bodyPr>
           <a:lstStyle/>
@@ -8153,6 +8328,7 @@
               </a:defRPr>
             </a:pPr>
             <a:r>
+              <a:rPr dirty="0"/>
               <a:t>Action: Scale premium monetization for +31% revenue potential</a:t>
             </a:r>
           </a:p>

</xml_diff>

<commit_message>
Fixed a R issue related to Age group
</commit_message>
<xml_diff>
--- a/Delivery 1 KPIs/Deliverables/Game_Analytics_Presentation.pptx
+++ b/Delivery 1 KPIs/Deliverables/Game_Analytics_Presentation.pptx
@@ -2,7 +2,7 @@
 <file path=ppt/presentation.xml><?xml version="1.0" encoding="utf-8"?>
 <p:presentation xmlns:a="http://schemas.openxmlformats.org/drawingml/2006/main" xmlns:r="http://schemas.openxmlformats.org/officeDocument/2006/relationships" xmlns:p="http://schemas.openxmlformats.org/presentationml/2006/main" saveSubsetFonts="1" autoCompressPictures="0">
   <p:sldMasterIdLst>
-    <p:sldMasterId id="2147483648" r:id="rId1"/>
+    <p:sldMasterId id="2147483672" r:id="rId1"/>
   </p:sldMasterIdLst>
   <p:sldIdLst>
     <p:sldId id="256" r:id="rId2"/>
@@ -15,6 +15,7 @@
     <p:sldId id="263" r:id="rId9"/>
     <p:sldId id="264" r:id="rId10"/>
     <p:sldId id="265" r:id="rId11"/>
+    <p:sldId id="267" r:id="rId12"/>
   </p:sldIdLst>
   <p:sldSz cx="9144000" cy="6858000" type="screen4x3"/>
   <p:notesSz cx="6858000" cy="9144000"/>
@@ -161,18 +162,23 @@
         </p:nvSpPr>
         <p:spPr>
           <a:xfrm>
-            <a:off x="685800" y="2130425"/>
-            <a:ext cx="7772400" cy="1470025"/>
-          </a:xfrm>
-        </p:spPr>
-        <p:txBody>
-          <a:bodyPr/>
-          <a:lstStyle/>
+            <a:off x="685800" y="1122363"/>
+            <a:ext cx="7772400" cy="2387600"/>
+          </a:xfrm>
+        </p:spPr>
+        <p:txBody>
+          <a:bodyPr anchor="b"/>
+          <a:lstStyle>
+            <a:lvl1pPr algn="ctr">
+              <a:defRPr sz="6000"/>
+            </a:lvl1pPr>
+          </a:lstStyle>
           <a:p>
             <a:r>
               <a:rPr lang="en-US"/>
               <a:t>Click to edit Master title style</a:t>
             </a:r>
+            <a:endParaRPr lang="en-US" dirty="0"/>
           </a:p>
         </p:txBody>
       </p:sp>
@@ -188,8 +194,8 @@
         </p:nvSpPr>
         <p:spPr>
           <a:xfrm>
-            <a:off x="1371600" y="3886200"/>
-            <a:ext cx="6400800" cy="1752600"/>
+            <a:off x="1143000" y="3602038"/>
+            <a:ext cx="6858000" cy="1655762"/>
           </a:xfrm>
         </p:spPr>
         <p:txBody>
@@ -197,93 +203,39 @@
           <a:lstStyle>
             <a:lvl1pPr marL="0" indent="0" algn="ctr">
               <a:buNone/>
-              <a:defRPr>
-                <a:solidFill>
-                  <a:schemeClr val="tx1">
-                    <a:tint val="75000"/>
-                  </a:schemeClr>
-                </a:solidFill>
-              </a:defRPr>
+              <a:defRPr sz="2400"/>
             </a:lvl1pPr>
             <a:lvl2pPr marL="457200" indent="0" algn="ctr">
               <a:buNone/>
-              <a:defRPr>
-                <a:solidFill>
-                  <a:schemeClr val="tx1">
-                    <a:tint val="75000"/>
-                  </a:schemeClr>
-                </a:solidFill>
-              </a:defRPr>
+              <a:defRPr sz="2000"/>
             </a:lvl2pPr>
             <a:lvl3pPr marL="914400" indent="0" algn="ctr">
               <a:buNone/>
-              <a:defRPr>
-                <a:solidFill>
-                  <a:schemeClr val="tx1">
-                    <a:tint val="75000"/>
-                  </a:schemeClr>
-                </a:solidFill>
-              </a:defRPr>
+              <a:defRPr sz="1800"/>
             </a:lvl3pPr>
             <a:lvl4pPr marL="1371600" indent="0" algn="ctr">
               <a:buNone/>
-              <a:defRPr>
-                <a:solidFill>
-                  <a:schemeClr val="tx1">
-                    <a:tint val="75000"/>
-                  </a:schemeClr>
-                </a:solidFill>
-              </a:defRPr>
+              <a:defRPr sz="1600"/>
             </a:lvl4pPr>
             <a:lvl5pPr marL="1828800" indent="0" algn="ctr">
               <a:buNone/>
-              <a:defRPr>
-                <a:solidFill>
-                  <a:schemeClr val="tx1">
-                    <a:tint val="75000"/>
-                  </a:schemeClr>
-                </a:solidFill>
-              </a:defRPr>
+              <a:defRPr sz="1600"/>
             </a:lvl5pPr>
             <a:lvl6pPr marL="2286000" indent="0" algn="ctr">
               <a:buNone/>
-              <a:defRPr>
-                <a:solidFill>
-                  <a:schemeClr val="tx1">
-                    <a:tint val="75000"/>
-                  </a:schemeClr>
-                </a:solidFill>
-              </a:defRPr>
+              <a:defRPr sz="1600"/>
             </a:lvl6pPr>
             <a:lvl7pPr marL="2743200" indent="0" algn="ctr">
               <a:buNone/>
-              <a:defRPr>
-                <a:solidFill>
-                  <a:schemeClr val="tx1">
-                    <a:tint val="75000"/>
-                  </a:schemeClr>
-                </a:solidFill>
-              </a:defRPr>
+              <a:defRPr sz="1600"/>
             </a:lvl7pPr>
             <a:lvl8pPr marL="3200400" indent="0" algn="ctr">
               <a:buNone/>
-              <a:defRPr>
-                <a:solidFill>
-                  <a:schemeClr val="tx1">
-                    <a:tint val="75000"/>
-                  </a:schemeClr>
-                </a:solidFill>
-              </a:defRPr>
+              <a:defRPr sz="1600"/>
             </a:lvl8pPr>
             <a:lvl9pPr marL="3657600" indent="0" algn="ctr">
               <a:buNone/>
-              <a:defRPr>
-                <a:solidFill>
-                  <a:schemeClr val="tx1">
-                    <a:tint val="75000"/>
-                  </a:schemeClr>
-                </a:solidFill>
-              </a:defRPr>
+              <a:defRPr sz="1600"/>
             </a:lvl9pPr>
           </a:lstStyle>
           <a:p>
@@ -291,6 +243,7 @@
               <a:rPr lang="en-US"/>
               <a:t>Click to edit Master subtitle style</a:t>
             </a:r>
+            <a:endParaRPr lang="en-US" dirty="0"/>
           </a:p>
         </p:txBody>
       </p:sp>
@@ -311,7 +264,7 @@
           <a:p>
             <a:fld id="{5BCAD085-E8A6-8845-BD4E-CB4CCA059FC4}" type="datetimeFigureOut">
               <a:rPr lang="en-US" smtClean="0"/>
-              <a:t>10/31/25</a:t>
+              <a:t>11/5/25</a:t>
             </a:fld>
             <a:endParaRPr lang="en-US"/>
           </a:p>
@@ -362,7 +315,7 @@
     </p:spTree>
     <p:extLst>
       <p:ext uri="{BB962C8B-B14F-4D97-AF65-F5344CB8AC3E}">
-        <p14:creationId xmlns:p14="http://schemas.microsoft.com/office/powerpoint/2010/main" val="3168075583"/>
+        <p14:creationId xmlns:p14="http://schemas.microsoft.com/office/powerpoint/2010/main" val="1992155572"/>
       </p:ext>
     </p:extLst>
   </p:cSld>
@@ -408,6 +361,7 @@
               <a:rPr lang="en-US"/>
               <a:t>Click to edit Master title style</a:t>
             </a:r>
+            <a:endParaRPr lang="en-US" dirty="0"/>
           </a:p>
         </p:txBody>
       </p:sp>
@@ -459,6 +413,7 @@
               <a:rPr lang="en-US"/>
               <a:t>Fifth level</a:t>
             </a:r>
+            <a:endParaRPr lang="en-US" dirty="0"/>
           </a:p>
         </p:txBody>
       </p:sp>
@@ -479,7 +434,7 @@
           <a:p>
             <a:fld id="{5BCAD085-E8A6-8845-BD4E-CB4CCA059FC4}" type="datetimeFigureOut">
               <a:rPr lang="en-US" smtClean="0"/>
-              <a:t>10/31/25</a:t>
+              <a:t>11/5/25</a:t>
             </a:fld>
             <a:endParaRPr lang="en-US"/>
           </a:p>
@@ -530,7 +485,7 @@
     </p:spTree>
     <p:extLst>
       <p:ext uri="{BB962C8B-B14F-4D97-AF65-F5344CB8AC3E}">
-        <p14:creationId xmlns:p14="http://schemas.microsoft.com/office/powerpoint/2010/main" val="2910927964"/>
+        <p14:creationId xmlns:p14="http://schemas.microsoft.com/office/powerpoint/2010/main" val="3133240125"/>
       </p:ext>
     </p:extLst>
   </p:cSld>
@@ -569,8 +524,8 @@
         </p:nvSpPr>
         <p:spPr>
           <a:xfrm>
-            <a:off x="6629400" y="274638"/>
-            <a:ext cx="2057400" cy="5851525"/>
+            <a:off x="6543675" y="365125"/>
+            <a:ext cx="1971675" cy="5811838"/>
           </a:xfrm>
         </p:spPr>
         <p:txBody>
@@ -581,6 +536,7 @@
               <a:rPr lang="en-US"/>
               <a:t>Click to edit Master title style</a:t>
             </a:r>
+            <a:endParaRPr lang="en-US" dirty="0"/>
           </a:p>
         </p:txBody>
       </p:sp>
@@ -596,8 +552,8 @@
         </p:nvSpPr>
         <p:spPr>
           <a:xfrm>
-            <a:off x="457200" y="274638"/>
-            <a:ext cx="6019800" cy="5851525"/>
+            <a:off x="628650" y="365125"/>
+            <a:ext cx="5800725" cy="5811838"/>
           </a:xfrm>
         </p:spPr>
         <p:txBody>
@@ -637,6 +593,7 @@
               <a:rPr lang="en-US"/>
               <a:t>Fifth level</a:t>
             </a:r>
+            <a:endParaRPr lang="en-US" dirty="0"/>
           </a:p>
         </p:txBody>
       </p:sp>
@@ -657,7 +614,7 @@
           <a:p>
             <a:fld id="{5BCAD085-E8A6-8845-BD4E-CB4CCA059FC4}" type="datetimeFigureOut">
               <a:rPr lang="en-US" smtClean="0"/>
-              <a:t>10/31/25</a:t>
+              <a:t>11/5/25</a:t>
             </a:fld>
             <a:endParaRPr lang="en-US"/>
           </a:p>
@@ -708,7 +665,7 @@
     </p:spTree>
     <p:extLst>
       <p:ext uri="{BB962C8B-B14F-4D97-AF65-F5344CB8AC3E}">
-        <p14:creationId xmlns:p14="http://schemas.microsoft.com/office/powerpoint/2010/main" val="3612223792"/>
+        <p14:creationId xmlns:p14="http://schemas.microsoft.com/office/powerpoint/2010/main" val="1458261002"/>
       </p:ext>
     </p:extLst>
   </p:cSld>
@@ -754,6 +711,7 @@
               <a:rPr lang="en-US"/>
               <a:t>Click to edit Master title style</a:t>
             </a:r>
+            <a:endParaRPr lang="en-US" dirty="0"/>
           </a:p>
         </p:txBody>
       </p:sp>
@@ -805,6 +763,7 @@
               <a:rPr lang="en-US"/>
               <a:t>Fifth level</a:t>
             </a:r>
+            <a:endParaRPr lang="en-US" dirty="0"/>
           </a:p>
         </p:txBody>
       </p:sp>
@@ -825,7 +784,7 @@
           <a:p>
             <a:fld id="{5BCAD085-E8A6-8845-BD4E-CB4CCA059FC4}" type="datetimeFigureOut">
               <a:rPr lang="en-US" smtClean="0"/>
-              <a:t>10/31/25</a:t>
+              <a:t>11/5/25</a:t>
             </a:fld>
             <a:endParaRPr lang="en-US"/>
           </a:p>
@@ -876,7 +835,7 @@
     </p:spTree>
     <p:extLst>
       <p:ext uri="{BB962C8B-B14F-4D97-AF65-F5344CB8AC3E}">
-        <p14:creationId xmlns:p14="http://schemas.microsoft.com/office/powerpoint/2010/main" val="2614314258"/>
+        <p14:creationId xmlns:p14="http://schemas.microsoft.com/office/powerpoint/2010/main" val="233140951"/>
       </p:ext>
     </p:extLst>
   </p:cSld>
@@ -915,15 +874,15 @@
         </p:nvSpPr>
         <p:spPr>
           <a:xfrm>
-            <a:off x="722313" y="4406900"/>
-            <a:ext cx="7772400" cy="1362075"/>
-          </a:xfrm>
-        </p:spPr>
-        <p:txBody>
-          <a:bodyPr anchor="t"/>
+            <a:off x="623888" y="1709739"/>
+            <a:ext cx="7886700" cy="2852737"/>
+          </a:xfrm>
+        </p:spPr>
+        <p:txBody>
+          <a:bodyPr anchor="b"/>
           <a:lstStyle>
-            <a:lvl1pPr algn="l">
-              <a:defRPr sz="4000" b="1" cap="all"/>
+            <a:lvl1pPr>
+              <a:defRPr sz="6000"/>
             </a:lvl1pPr>
           </a:lstStyle>
           <a:p>
@@ -931,6 +890,7 @@
               <a:rPr lang="en-US"/>
               <a:t>Click to edit Master title style</a:t>
             </a:r>
+            <a:endParaRPr lang="en-US" dirty="0"/>
           </a:p>
         </p:txBody>
       </p:sp>
@@ -946,15 +906,23 @@
         </p:nvSpPr>
         <p:spPr>
           <a:xfrm>
-            <a:off x="722313" y="2906713"/>
-            <a:ext cx="7772400" cy="1500187"/>
-          </a:xfrm>
-        </p:spPr>
-        <p:txBody>
-          <a:bodyPr anchor="b"/>
+            <a:off x="623888" y="4589464"/>
+            <a:ext cx="7886700" cy="1500187"/>
+          </a:xfrm>
+        </p:spPr>
+        <p:txBody>
+          <a:bodyPr/>
           <a:lstStyle>
             <a:lvl1pPr marL="0" indent="0">
               <a:buNone/>
+              <a:defRPr sz="2400">
+                <a:solidFill>
+                  <a:schemeClr val="tx1"/>
+                </a:solidFill>
+              </a:defRPr>
+            </a:lvl1pPr>
+            <a:lvl2pPr marL="457200" indent="0">
+              <a:buNone/>
               <a:defRPr sz="2000">
                 <a:solidFill>
                   <a:schemeClr val="tx1">
@@ -962,8 +930,8 @@
                   </a:schemeClr>
                 </a:solidFill>
               </a:defRPr>
-            </a:lvl1pPr>
-            <a:lvl2pPr marL="457200" indent="0">
+            </a:lvl2pPr>
+            <a:lvl3pPr marL="914400" indent="0">
               <a:buNone/>
               <a:defRPr sz="1800">
                 <a:solidFill>
@@ -972,8 +940,8 @@
                   </a:schemeClr>
                 </a:solidFill>
               </a:defRPr>
-            </a:lvl2pPr>
-            <a:lvl3pPr marL="914400" indent="0">
+            </a:lvl3pPr>
+            <a:lvl4pPr marL="1371600" indent="0">
               <a:buNone/>
               <a:defRPr sz="1600">
                 <a:solidFill>
@@ -982,60 +950,50 @@
                   </a:schemeClr>
                 </a:solidFill>
               </a:defRPr>
-            </a:lvl3pPr>
-            <a:lvl4pPr marL="1371600" indent="0">
+            </a:lvl4pPr>
+            <a:lvl5pPr marL="1828800" indent="0">
               <a:buNone/>
-              <a:defRPr sz="1400">
+              <a:defRPr sz="1600">
                 <a:solidFill>
                   <a:schemeClr val="tx1">
                     <a:tint val="75000"/>
                   </a:schemeClr>
                 </a:solidFill>
               </a:defRPr>
-            </a:lvl4pPr>
-            <a:lvl5pPr marL="1828800" indent="0">
+            </a:lvl5pPr>
+            <a:lvl6pPr marL="2286000" indent="0">
               <a:buNone/>
-              <a:defRPr sz="1400">
+              <a:defRPr sz="1600">
                 <a:solidFill>
                   <a:schemeClr val="tx1">
                     <a:tint val="75000"/>
                   </a:schemeClr>
                 </a:solidFill>
               </a:defRPr>
-            </a:lvl5pPr>
-            <a:lvl6pPr marL="2286000" indent="0">
+            </a:lvl6pPr>
+            <a:lvl7pPr marL="2743200" indent="0">
               <a:buNone/>
-              <a:defRPr sz="1400">
+              <a:defRPr sz="1600">
                 <a:solidFill>
                   <a:schemeClr val="tx1">
                     <a:tint val="75000"/>
                   </a:schemeClr>
                 </a:solidFill>
               </a:defRPr>
-            </a:lvl6pPr>
-            <a:lvl7pPr marL="2743200" indent="0">
+            </a:lvl7pPr>
+            <a:lvl8pPr marL="3200400" indent="0">
               <a:buNone/>
-              <a:defRPr sz="1400">
+              <a:defRPr sz="1600">
                 <a:solidFill>
                   <a:schemeClr val="tx1">
                     <a:tint val="75000"/>
                   </a:schemeClr>
                 </a:solidFill>
               </a:defRPr>
-            </a:lvl7pPr>
-            <a:lvl8pPr marL="3200400" indent="0">
-              <a:buNone/>
-              <a:defRPr sz="1400">
-                <a:solidFill>
-                  <a:schemeClr val="tx1">
-                    <a:tint val="75000"/>
-                  </a:schemeClr>
-                </a:solidFill>
-              </a:defRPr>
             </a:lvl8pPr>
             <a:lvl9pPr marL="3657600" indent="0">
               <a:buNone/>
-              <a:defRPr sz="1400">
+              <a:defRPr sz="1600">
                 <a:solidFill>
                   <a:schemeClr val="tx1">
                     <a:tint val="75000"/>
@@ -1070,7 +1028,7 @@
           <a:p>
             <a:fld id="{5BCAD085-E8A6-8845-BD4E-CB4CCA059FC4}" type="datetimeFigureOut">
               <a:rPr lang="en-US" smtClean="0"/>
-              <a:t>10/31/25</a:t>
+              <a:t>11/5/25</a:t>
             </a:fld>
             <a:endParaRPr lang="en-US"/>
           </a:p>
@@ -1121,7 +1079,7 @@
     </p:spTree>
     <p:extLst>
       <p:ext uri="{BB962C8B-B14F-4D97-AF65-F5344CB8AC3E}">
-        <p14:creationId xmlns:p14="http://schemas.microsoft.com/office/powerpoint/2010/main" val="960648375"/>
+        <p14:creationId xmlns:p14="http://schemas.microsoft.com/office/powerpoint/2010/main" val="2876504379"/>
       </p:ext>
     </p:extLst>
   </p:cSld>
@@ -1167,6 +1125,7 @@
               <a:rPr lang="en-US"/>
               <a:t>Click to edit Master title style</a:t>
             </a:r>
+            <a:endParaRPr lang="en-US" dirty="0"/>
           </a:p>
         </p:txBody>
       </p:sp>
@@ -1182,41 +1141,13 @@
         </p:nvSpPr>
         <p:spPr>
           <a:xfrm>
-            <a:off x="457200" y="1600200"/>
-            <a:ext cx="4038600" cy="4525963"/>
+            <a:off x="628650" y="1825625"/>
+            <a:ext cx="3886200" cy="4351338"/>
           </a:xfrm>
         </p:spPr>
         <p:txBody>
           <a:bodyPr/>
-          <a:lstStyle>
-            <a:lvl1pPr>
-              <a:defRPr sz="2800"/>
-            </a:lvl1pPr>
-            <a:lvl2pPr>
-              <a:defRPr sz="2400"/>
-            </a:lvl2pPr>
-            <a:lvl3pPr>
-              <a:defRPr sz="2000"/>
-            </a:lvl3pPr>
-            <a:lvl4pPr>
-              <a:defRPr sz="1800"/>
-            </a:lvl4pPr>
-            <a:lvl5pPr>
-              <a:defRPr sz="1800"/>
-            </a:lvl5pPr>
-            <a:lvl6pPr>
-              <a:defRPr sz="1800"/>
-            </a:lvl6pPr>
-            <a:lvl7pPr>
-              <a:defRPr sz="1800"/>
-            </a:lvl7pPr>
-            <a:lvl8pPr>
-              <a:defRPr sz="1800"/>
-            </a:lvl8pPr>
-            <a:lvl9pPr>
-              <a:defRPr sz="1800"/>
-            </a:lvl9pPr>
-          </a:lstStyle>
+          <a:lstStyle/>
           <a:p>
             <a:pPr lvl="0"/>
             <a:r>
@@ -1251,6 +1182,7 @@
               <a:rPr lang="en-US"/>
               <a:t>Fifth level</a:t>
             </a:r>
+            <a:endParaRPr lang="en-US" dirty="0"/>
           </a:p>
         </p:txBody>
       </p:sp>
@@ -1266,41 +1198,13 @@
         </p:nvSpPr>
         <p:spPr>
           <a:xfrm>
-            <a:off x="4648200" y="1600200"/>
-            <a:ext cx="4038600" cy="4525963"/>
+            <a:off x="4629150" y="1825625"/>
+            <a:ext cx="3886200" cy="4351338"/>
           </a:xfrm>
         </p:spPr>
         <p:txBody>
           <a:bodyPr/>
-          <a:lstStyle>
-            <a:lvl1pPr>
-              <a:defRPr sz="2800"/>
-            </a:lvl1pPr>
-            <a:lvl2pPr>
-              <a:defRPr sz="2400"/>
-            </a:lvl2pPr>
-            <a:lvl3pPr>
-              <a:defRPr sz="2000"/>
-            </a:lvl3pPr>
-            <a:lvl4pPr>
-              <a:defRPr sz="1800"/>
-            </a:lvl4pPr>
-            <a:lvl5pPr>
-              <a:defRPr sz="1800"/>
-            </a:lvl5pPr>
-            <a:lvl6pPr>
-              <a:defRPr sz="1800"/>
-            </a:lvl6pPr>
-            <a:lvl7pPr>
-              <a:defRPr sz="1800"/>
-            </a:lvl7pPr>
-            <a:lvl8pPr>
-              <a:defRPr sz="1800"/>
-            </a:lvl8pPr>
-            <a:lvl9pPr>
-              <a:defRPr sz="1800"/>
-            </a:lvl9pPr>
-          </a:lstStyle>
+          <a:lstStyle/>
           <a:p>
             <a:pPr lvl="0"/>
             <a:r>
@@ -1335,6 +1239,7 @@
               <a:rPr lang="en-US"/>
               <a:t>Fifth level</a:t>
             </a:r>
+            <a:endParaRPr lang="en-US" dirty="0"/>
           </a:p>
         </p:txBody>
       </p:sp>
@@ -1355,7 +1260,7 @@
           <a:p>
             <a:fld id="{5BCAD085-E8A6-8845-BD4E-CB4CCA059FC4}" type="datetimeFigureOut">
               <a:rPr lang="en-US" smtClean="0"/>
-              <a:t>10/31/25</a:t>
+              <a:t>11/5/25</a:t>
             </a:fld>
             <a:endParaRPr lang="en-US"/>
           </a:p>
@@ -1406,7 +1311,7 @@
     </p:spTree>
     <p:extLst>
       <p:ext uri="{BB962C8B-B14F-4D97-AF65-F5344CB8AC3E}">
-        <p14:creationId xmlns:p14="http://schemas.microsoft.com/office/powerpoint/2010/main" val="2782244947"/>
+        <p14:creationId xmlns:p14="http://schemas.microsoft.com/office/powerpoint/2010/main" val="3567583067"/>
       </p:ext>
     </p:extLst>
   </p:cSld>
@@ -1443,19 +1348,21 @@
             <p:ph type="title"/>
           </p:nvPr>
         </p:nvSpPr>
-        <p:spPr/>
+        <p:spPr>
+          <a:xfrm>
+            <a:off x="629841" y="365126"/>
+            <a:ext cx="7886700" cy="1325563"/>
+          </a:xfrm>
+        </p:spPr>
         <p:txBody>
           <a:bodyPr/>
-          <a:lstStyle>
-            <a:lvl1pPr>
-              <a:defRPr/>
-            </a:lvl1pPr>
-          </a:lstStyle>
+          <a:lstStyle/>
           <a:p>
             <a:r>
               <a:rPr lang="en-US"/>
               <a:t>Click to edit Master title style</a:t>
             </a:r>
+            <a:endParaRPr lang="en-US" dirty="0"/>
           </a:p>
         </p:txBody>
       </p:sp>
@@ -1471,8 +1378,8 @@
         </p:nvSpPr>
         <p:spPr>
           <a:xfrm>
-            <a:off x="457200" y="1535113"/>
-            <a:ext cx="4040188" cy="639762"/>
+            <a:off x="629842" y="1681163"/>
+            <a:ext cx="3868340" cy="823912"/>
           </a:xfrm>
         </p:spPr>
         <p:txBody>
@@ -1536,41 +1443,13 @@
         </p:nvSpPr>
         <p:spPr>
           <a:xfrm>
-            <a:off x="457200" y="2174875"/>
-            <a:ext cx="4040188" cy="3951288"/>
+            <a:off x="629842" y="2505075"/>
+            <a:ext cx="3868340" cy="3684588"/>
           </a:xfrm>
         </p:spPr>
         <p:txBody>
           <a:bodyPr/>
-          <a:lstStyle>
-            <a:lvl1pPr>
-              <a:defRPr sz="2400"/>
-            </a:lvl1pPr>
-            <a:lvl2pPr>
-              <a:defRPr sz="2000"/>
-            </a:lvl2pPr>
-            <a:lvl3pPr>
-              <a:defRPr sz="1800"/>
-            </a:lvl3pPr>
-            <a:lvl4pPr>
-              <a:defRPr sz="1600"/>
-            </a:lvl4pPr>
-            <a:lvl5pPr>
-              <a:defRPr sz="1600"/>
-            </a:lvl5pPr>
-            <a:lvl6pPr>
-              <a:defRPr sz="1600"/>
-            </a:lvl6pPr>
-            <a:lvl7pPr>
-              <a:defRPr sz="1600"/>
-            </a:lvl7pPr>
-            <a:lvl8pPr>
-              <a:defRPr sz="1600"/>
-            </a:lvl8pPr>
-            <a:lvl9pPr>
-              <a:defRPr sz="1600"/>
-            </a:lvl9pPr>
-          </a:lstStyle>
+          <a:lstStyle/>
           <a:p>
             <a:pPr lvl="0"/>
             <a:r>
@@ -1605,6 +1484,7 @@
               <a:rPr lang="en-US"/>
               <a:t>Fifth level</a:t>
             </a:r>
+            <a:endParaRPr lang="en-US" dirty="0"/>
           </a:p>
         </p:txBody>
       </p:sp>
@@ -1620,8 +1500,8 @@
         </p:nvSpPr>
         <p:spPr>
           <a:xfrm>
-            <a:off x="4645025" y="1535113"/>
-            <a:ext cx="4041775" cy="639762"/>
+            <a:off x="4629150" y="1681163"/>
+            <a:ext cx="3887391" cy="823912"/>
           </a:xfrm>
         </p:spPr>
         <p:txBody>
@@ -1685,41 +1565,13 @@
         </p:nvSpPr>
         <p:spPr>
           <a:xfrm>
-            <a:off x="4645025" y="2174875"/>
-            <a:ext cx="4041775" cy="3951288"/>
+            <a:off x="4629150" y="2505075"/>
+            <a:ext cx="3887391" cy="3684588"/>
           </a:xfrm>
         </p:spPr>
         <p:txBody>
           <a:bodyPr/>
-          <a:lstStyle>
-            <a:lvl1pPr>
-              <a:defRPr sz="2400"/>
-            </a:lvl1pPr>
-            <a:lvl2pPr>
-              <a:defRPr sz="2000"/>
-            </a:lvl2pPr>
-            <a:lvl3pPr>
-              <a:defRPr sz="1800"/>
-            </a:lvl3pPr>
-            <a:lvl4pPr>
-              <a:defRPr sz="1600"/>
-            </a:lvl4pPr>
-            <a:lvl5pPr>
-              <a:defRPr sz="1600"/>
-            </a:lvl5pPr>
-            <a:lvl6pPr>
-              <a:defRPr sz="1600"/>
-            </a:lvl6pPr>
-            <a:lvl7pPr>
-              <a:defRPr sz="1600"/>
-            </a:lvl7pPr>
-            <a:lvl8pPr>
-              <a:defRPr sz="1600"/>
-            </a:lvl8pPr>
-            <a:lvl9pPr>
-              <a:defRPr sz="1600"/>
-            </a:lvl9pPr>
-          </a:lstStyle>
+          <a:lstStyle/>
           <a:p>
             <a:pPr lvl="0"/>
             <a:r>
@@ -1754,6 +1606,7 @@
               <a:rPr lang="en-US"/>
               <a:t>Fifth level</a:t>
             </a:r>
+            <a:endParaRPr lang="en-US" dirty="0"/>
           </a:p>
         </p:txBody>
       </p:sp>
@@ -1774,7 +1627,7 @@
           <a:p>
             <a:fld id="{5BCAD085-E8A6-8845-BD4E-CB4CCA059FC4}" type="datetimeFigureOut">
               <a:rPr lang="en-US" smtClean="0"/>
-              <a:t>10/31/25</a:t>
+              <a:t>11/5/25</a:t>
             </a:fld>
             <a:endParaRPr lang="en-US"/>
           </a:p>
@@ -1825,7 +1678,7 @@
     </p:spTree>
     <p:extLst>
       <p:ext uri="{BB962C8B-B14F-4D97-AF65-F5344CB8AC3E}">
-        <p14:creationId xmlns:p14="http://schemas.microsoft.com/office/powerpoint/2010/main" val="990158736"/>
+        <p14:creationId xmlns:p14="http://schemas.microsoft.com/office/powerpoint/2010/main" val="3771555836"/>
       </p:ext>
     </p:extLst>
   </p:cSld>
@@ -1871,6 +1724,7 @@
               <a:rPr lang="en-US"/>
               <a:t>Click to edit Master title style</a:t>
             </a:r>
+            <a:endParaRPr lang="en-US" dirty="0"/>
           </a:p>
         </p:txBody>
       </p:sp>
@@ -1891,7 +1745,7 @@
           <a:p>
             <a:fld id="{5BCAD085-E8A6-8845-BD4E-CB4CCA059FC4}" type="datetimeFigureOut">
               <a:rPr lang="en-US" smtClean="0"/>
-              <a:t>10/31/25</a:t>
+              <a:t>11/5/25</a:t>
             </a:fld>
             <a:endParaRPr lang="en-US"/>
           </a:p>
@@ -1942,7 +1796,7 @@
     </p:spTree>
     <p:extLst>
       <p:ext uri="{BB962C8B-B14F-4D97-AF65-F5344CB8AC3E}">
-        <p14:creationId xmlns:p14="http://schemas.microsoft.com/office/powerpoint/2010/main" val="727027711"/>
+        <p14:creationId xmlns:p14="http://schemas.microsoft.com/office/powerpoint/2010/main" val="2344694448"/>
       </p:ext>
     </p:extLst>
   </p:cSld>
@@ -1986,7 +1840,7 @@
           <a:p>
             <a:fld id="{5BCAD085-E8A6-8845-BD4E-CB4CCA059FC4}" type="datetimeFigureOut">
               <a:rPr lang="en-US" smtClean="0"/>
-              <a:t>10/31/25</a:t>
+              <a:t>11/5/25</a:t>
             </a:fld>
             <a:endParaRPr lang="en-US"/>
           </a:p>
@@ -2037,7 +1891,7 @@
     </p:spTree>
     <p:extLst>
       <p:ext uri="{BB962C8B-B14F-4D97-AF65-F5344CB8AC3E}">
-        <p14:creationId xmlns:p14="http://schemas.microsoft.com/office/powerpoint/2010/main" val="1212999818"/>
+        <p14:creationId xmlns:p14="http://schemas.microsoft.com/office/powerpoint/2010/main" val="186806828"/>
       </p:ext>
     </p:extLst>
   </p:cSld>
@@ -2076,15 +1930,15 @@
         </p:nvSpPr>
         <p:spPr>
           <a:xfrm>
-            <a:off x="457200" y="273050"/>
-            <a:ext cx="3008313" cy="1162050"/>
+            <a:off x="629841" y="457200"/>
+            <a:ext cx="2949178" cy="1600200"/>
           </a:xfrm>
         </p:spPr>
         <p:txBody>
           <a:bodyPr anchor="b"/>
           <a:lstStyle>
-            <a:lvl1pPr algn="l">
-              <a:defRPr sz="2000" b="1"/>
+            <a:lvl1pPr>
+              <a:defRPr sz="3200"/>
             </a:lvl1pPr>
           </a:lstStyle>
           <a:p>
@@ -2092,6 +1946,7 @@
               <a:rPr lang="en-US"/>
               <a:t>Click to edit Master title style</a:t>
             </a:r>
+            <a:endParaRPr lang="en-US" dirty="0"/>
           </a:p>
         </p:txBody>
       </p:sp>
@@ -2107,8 +1962,8 @@
         </p:nvSpPr>
         <p:spPr>
           <a:xfrm>
-            <a:off x="3575050" y="273050"/>
-            <a:ext cx="5111750" cy="5853113"/>
+            <a:off x="3887391" y="987426"/>
+            <a:ext cx="4629150" cy="4873625"/>
           </a:xfrm>
         </p:spPr>
         <p:txBody>
@@ -2176,6 +2031,7 @@
               <a:rPr lang="en-US"/>
               <a:t>Fifth level</a:t>
             </a:r>
+            <a:endParaRPr lang="en-US" dirty="0"/>
           </a:p>
         </p:txBody>
       </p:sp>
@@ -2191,8 +2047,8 @@
         </p:nvSpPr>
         <p:spPr>
           <a:xfrm>
-            <a:off x="457200" y="1435100"/>
-            <a:ext cx="3008313" cy="4691063"/>
+            <a:off x="629841" y="2057400"/>
+            <a:ext cx="2949178" cy="3811588"/>
           </a:xfrm>
         </p:spPr>
         <p:txBody>
@@ -2200,39 +2056,39 @@
           <a:lstStyle>
             <a:lvl1pPr marL="0" indent="0">
               <a:buNone/>
-              <a:defRPr sz="1400"/>
+              <a:defRPr sz="1600"/>
             </a:lvl1pPr>
             <a:lvl2pPr marL="457200" indent="0">
               <a:buNone/>
-              <a:defRPr sz="1200"/>
+              <a:defRPr sz="1400"/>
             </a:lvl2pPr>
             <a:lvl3pPr marL="914400" indent="0">
               <a:buNone/>
-              <a:defRPr sz="1000"/>
+              <a:defRPr sz="1200"/>
             </a:lvl3pPr>
             <a:lvl4pPr marL="1371600" indent="0">
               <a:buNone/>
-              <a:defRPr sz="900"/>
+              <a:defRPr sz="1000"/>
             </a:lvl4pPr>
             <a:lvl5pPr marL="1828800" indent="0">
               <a:buNone/>
-              <a:defRPr sz="900"/>
+              <a:defRPr sz="1000"/>
             </a:lvl5pPr>
             <a:lvl6pPr marL="2286000" indent="0">
               <a:buNone/>
-              <a:defRPr sz="900"/>
+              <a:defRPr sz="1000"/>
             </a:lvl6pPr>
             <a:lvl7pPr marL="2743200" indent="0">
               <a:buNone/>
-              <a:defRPr sz="900"/>
+              <a:defRPr sz="1000"/>
             </a:lvl7pPr>
             <a:lvl8pPr marL="3200400" indent="0">
               <a:buNone/>
-              <a:defRPr sz="900"/>
+              <a:defRPr sz="1000"/>
             </a:lvl8pPr>
             <a:lvl9pPr marL="3657600" indent="0">
               <a:buNone/>
-              <a:defRPr sz="900"/>
+              <a:defRPr sz="1000"/>
             </a:lvl9pPr>
           </a:lstStyle>
           <a:p>
@@ -2261,7 +2117,7 @@
           <a:p>
             <a:fld id="{5BCAD085-E8A6-8845-BD4E-CB4CCA059FC4}" type="datetimeFigureOut">
               <a:rPr lang="en-US" smtClean="0"/>
-              <a:t>10/31/25</a:t>
+              <a:t>11/5/25</a:t>
             </a:fld>
             <a:endParaRPr lang="en-US"/>
           </a:p>
@@ -2312,7 +2168,7 @@
     </p:spTree>
     <p:extLst>
       <p:ext uri="{BB962C8B-B14F-4D97-AF65-F5344CB8AC3E}">
-        <p14:creationId xmlns:p14="http://schemas.microsoft.com/office/powerpoint/2010/main" val="1840726560"/>
+        <p14:creationId xmlns:p14="http://schemas.microsoft.com/office/powerpoint/2010/main" val="2559511036"/>
       </p:ext>
     </p:extLst>
   </p:cSld>
@@ -2351,15 +2207,15 @@
         </p:nvSpPr>
         <p:spPr>
           <a:xfrm>
-            <a:off x="1792288" y="4800600"/>
-            <a:ext cx="5486400" cy="566738"/>
+            <a:off x="629841" y="457200"/>
+            <a:ext cx="2949178" cy="1600200"/>
           </a:xfrm>
         </p:spPr>
         <p:txBody>
           <a:bodyPr anchor="b"/>
           <a:lstStyle>
-            <a:lvl1pPr algn="l">
-              <a:defRPr sz="2000" b="1"/>
+            <a:lvl1pPr>
+              <a:defRPr sz="3200"/>
             </a:lvl1pPr>
           </a:lstStyle>
           <a:p>
@@ -2367,6 +2223,7 @@
               <a:rPr lang="en-US"/>
               <a:t>Click to edit Master title style</a:t>
             </a:r>
+            <a:endParaRPr lang="en-US" dirty="0"/>
           </a:p>
         </p:txBody>
       </p:sp>
@@ -2374,7 +2231,7 @@
         <p:nvSpPr>
           <p:cNvPr id="3" name="Picture Placeholder 2"/>
           <p:cNvSpPr>
-            <a:spLocks noGrp="1"/>
+            <a:spLocks noGrp="1" noChangeAspect="1"/>
           </p:cNvSpPr>
           <p:nvPr>
             <p:ph type="pic" idx="1"/>
@@ -2382,12 +2239,12 @@
         </p:nvSpPr>
         <p:spPr>
           <a:xfrm>
-            <a:off x="1792288" y="612775"/>
-            <a:ext cx="5486400" cy="4114800"/>
-          </a:xfrm>
-        </p:spPr>
-        <p:txBody>
-          <a:bodyPr/>
+            <a:off x="3887391" y="987426"/>
+            <a:ext cx="4629150" cy="4873625"/>
+          </a:xfrm>
+        </p:spPr>
+        <p:txBody>
+          <a:bodyPr anchor="t"/>
           <a:lstStyle>
             <a:lvl1pPr marL="0" indent="0">
               <a:buNone/>
@@ -2427,7 +2284,11 @@
             </a:lvl9pPr>
           </a:lstStyle>
           <a:p>
-            <a:endParaRPr lang="en-US"/>
+            <a:r>
+              <a:rPr lang="en-US"/>
+              <a:t>Click icon to add picture</a:t>
+            </a:r>
+            <a:endParaRPr lang="en-US" dirty="0"/>
           </a:p>
         </p:txBody>
       </p:sp>
@@ -2443,8 +2304,8 @@
         </p:nvSpPr>
         <p:spPr>
           <a:xfrm>
-            <a:off x="1792288" y="5367338"/>
-            <a:ext cx="5486400" cy="804862"/>
+            <a:off x="629841" y="2057400"/>
+            <a:ext cx="2949178" cy="3811588"/>
           </a:xfrm>
         </p:spPr>
         <p:txBody>
@@ -2452,39 +2313,39 @@
           <a:lstStyle>
             <a:lvl1pPr marL="0" indent="0">
               <a:buNone/>
-              <a:defRPr sz="1400"/>
+              <a:defRPr sz="1600"/>
             </a:lvl1pPr>
             <a:lvl2pPr marL="457200" indent="0">
               <a:buNone/>
-              <a:defRPr sz="1200"/>
+              <a:defRPr sz="1400"/>
             </a:lvl2pPr>
             <a:lvl3pPr marL="914400" indent="0">
               <a:buNone/>
-              <a:defRPr sz="1000"/>
+              <a:defRPr sz="1200"/>
             </a:lvl3pPr>
             <a:lvl4pPr marL="1371600" indent="0">
               <a:buNone/>
-              <a:defRPr sz="900"/>
+              <a:defRPr sz="1000"/>
             </a:lvl4pPr>
             <a:lvl5pPr marL="1828800" indent="0">
               <a:buNone/>
-              <a:defRPr sz="900"/>
+              <a:defRPr sz="1000"/>
             </a:lvl5pPr>
             <a:lvl6pPr marL="2286000" indent="0">
               <a:buNone/>
-              <a:defRPr sz="900"/>
+              <a:defRPr sz="1000"/>
             </a:lvl6pPr>
             <a:lvl7pPr marL="2743200" indent="0">
               <a:buNone/>
-              <a:defRPr sz="900"/>
+              <a:defRPr sz="1000"/>
             </a:lvl7pPr>
             <a:lvl8pPr marL="3200400" indent="0">
               <a:buNone/>
-              <a:defRPr sz="900"/>
+              <a:defRPr sz="1000"/>
             </a:lvl8pPr>
             <a:lvl9pPr marL="3657600" indent="0">
               <a:buNone/>
-              <a:defRPr sz="900"/>
+              <a:defRPr sz="1000"/>
             </a:lvl9pPr>
           </a:lstStyle>
           <a:p>
@@ -2513,7 +2374,7 @@
           <a:p>
             <a:fld id="{5BCAD085-E8A6-8845-BD4E-CB4CCA059FC4}" type="datetimeFigureOut">
               <a:rPr lang="en-US" smtClean="0"/>
-              <a:t>10/31/25</a:t>
+              <a:t>11/5/25</a:t>
             </a:fld>
             <a:endParaRPr lang="en-US"/>
           </a:p>
@@ -2564,7 +2425,7 @@
     </p:spTree>
     <p:extLst>
       <p:ext uri="{BB962C8B-B14F-4D97-AF65-F5344CB8AC3E}">
-        <p14:creationId xmlns:p14="http://schemas.microsoft.com/office/powerpoint/2010/main" val="3889236939"/>
+        <p14:creationId xmlns:p14="http://schemas.microsoft.com/office/powerpoint/2010/main" val="2233107376"/>
       </p:ext>
     </p:extLst>
   </p:cSld>
@@ -2608,8 +2469,8 @@
         </p:nvSpPr>
         <p:spPr>
           <a:xfrm>
-            <a:off x="457200" y="274638"/>
-            <a:ext cx="8229600" cy="1143000"/>
+            <a:off x="628650" y="365126"/>
+            <a:ext cx="7886700" cy="1325563"/>
           </a:xfrm>
           <a:prstGeom prst="rect">
             <a:avLst/>
@@ -2625,6 +2486,7 @@
               <a:rPr lang="en-US"/>
               <a:t>Click to edit Master title style</a:t>
             </a:r>
+            <a:endParaRPr lang="en-US" dirty="0"/>
           </a:p>
         </p:txBody>
       </p:sp>
@@ -2640,8 +2502,8 @@
         </p:nvSpPr>
         <p:spPr>
           <a:xfrm>
-            <a:off x="457200" y="1600200"/>
-            <a:ext cx="8229600" cy="4525963"/>
+            <a:off x="628650" y="1825625"/>
+            <a:ext cx="7886700" cy="4351338"/>
           </a:xfrm>
           <a:prstGeom prst="rect">
             <a:avLst/>
@@ -2686,6 +2548,7 @@
               <a:rPr lang="en-US"/>
               <a:t>Fifth level</a:t>
             </a:r>
+            <a:endParaRPr lang="en-US" dirty="0"/>
           </a:p>
         </p:txBody>
       </p:sp>
@@ -2701,8 +2564,8 @@
         </p:nvSpPr>
         <p:spPr>
           <a:xfrm>
-            <a:off x="457200" y="6356350"/>
-            <a:ext cx="2133600" cy="365125"/>
+            <a:off x="628650" y="6356351"/>
+            <a:ext cx="2057400" cy="365125"/>
           </a:xfrm>
           <a:prstGeom prst="rect">
             <a:avLst/>
@@ -2724,7 +2587,7 @@
           <a:p>
             <a:fld id="{5BCAD085-E8A6-8845-BD4E-CB4CCA059FC4}" type="datetimeFigureOut">
               <a:rPr lang="en-US" smtClean="0"/>
-              <a:t>10/31/25</a:t>
+              <a:t>11/5/25</a:t>
             </a:fld>
             <a:endParaRPr lang="en-US"/>
           </a:p>
@@ -2742,8 +2605,8 @@
         </p:nvSpPr>
         <p:spPr>
           <a:xfrm>
-            <a:off x="3124200" y="6356350"/>
-            <a:ext cx="2895600" cy="365125"/>
+            <a:off x="3028950" y="6356351"/>
+            <a:ext cx="3086100" cy="365125"/>
           </a:xfrm>
           <a:prstGeom prst="rect">
             <a:avLst/>
@@ -2779,8 +2642,8 @@
         </p:nvSpPr>
         <p:spPr>
           <a:xfrm>
-            <a:off x="6553200" y="6356350"/>
-            <a:ext cx="2133600" cy="365125"/>
+            <a:off x="6457950" y="6356351"/>
+            <a:ext cx="2057400" cy="365125"/>
           </a:xfrm>
           <a:prstGeom prst="rect">
             <a:avLst/>
@@ -2811,27 +2674,30 @@
     </p:spTree>
     <p:extLst>
       <p:ext uri="{BB962C8B-B14F-4D97-AF65-F5344CB8AC3E}">
-        <p14:creationId xmlns:p14="http://schemas.microsoft.com/office/powerpoint/2010/main" val="2209977519"/>
+        <p14:creationId xmlns:p14="http://schemas.microsoft.com/office/powerpoint/2010/main" val="3180325865"/>
       </p:ext>
     </p:extLst>
   </p:cSld>
   <p:clrMap bg1="lt1" tx1="dk1" bg2="lt2" tx2="dk2" accent1="accent1" accent2="accent2" accent3="accent3" accent4="accent4" accent5="accent5" accent6="accent6" hlink="hlink" folHlink="folHlink"/>
   <p:sldLayoutIdLst>
-    <p:sldLayoutId id="2147483649" r:id="rId1"/>
-    <p:sldLayoutId id="2147483650" r:id="rId2"/>
-    <p:sldLayoutId id="2147483651" r:id="rId3"/>
-    <p:sldLayoutId id="2147483652" r:id="rId4"/>
-    <p:sldLayoutId id="2147483653" r:id="rId5"/>
-    <p:sldLayoutId id="2147483654" r:id="rId6"/>
-    <p:sldLayoutId id="2147483655" r:id="rId7"/>
-    <p:sldLayoutId id="2147483656" r:id="rId8"/>
-    <p:sldLayoutId id="2147483657" r:id="rId9"/>
-    <p:sldLayoutId id="2147483658" r:id="rId10"/>
-    <p:sldLayoutId id="2147483659" r:id="rId11"/>
+    <p:sldLayoutId id="2147483673" r:id="rId1"/>
+    <p:sldLayoutId id="2147483674" r:id="rId2"/>
+    <p:sldLayoutId id="2147483675" r:id="rId3"/>
+    <p:sldLayoutId id="2147483676" r:id="rId4"/>
+    <p:sldLayoutId id="2147483677" r:id="rId5"/>
+    <p:sldLayoutId id="2147483678" r:id="rId6"/>
+    <p:sldLayoutId id="2147483679" r:id="rId7"/>
+    <p:sldLayoutId id="2147483680" r:id="rId8"/>
+    <p:sldLayoutId id="2147483681" r:id="rId9"/>
+    <p:sldLayoutId id="2147483682" r:id="rId10"/>
+    <p:sldLayoutId id="2147483683" r:id="rId11"/>
   </p:sldLayoutIdLst>
   <p:txStyles>
     <p:titleStyle>
-      <a:lvl1pPr algn="ctr" defTabSz="457200" rtl="0" eaLnBrk="1" latinLnBrk="0" hangingPunct="1">
+      <a:lvl1pPr algn="l" defTabSz="914400" rtl="0" eaLnBrk="1" latinLnBrk="0" hangingPunct="1">
+        <a:lnSpc>
+          <a:spcPct val="90000"/>
+        </a:lnSpc>
         <a:spcBef>
           <a:spcPct val="0"/>
         </a:spcBef>
@@ -2847,13 +2713,16 @@
       </a:lvl1pPr>
     </p:titleStyle>
     <p:bodyStyle>
-      <a:lvl1pPr marL="342900" indent="-342900" algn="l" defTabSz="457200" rtl="0" eaLnBrk="1" latinLnBrk="0" hangingPunct="1">
+      <a:lvl1pPr marL="228600" indent="-228600" algn="l" defTabSz="914400" rtl="0" eaLnBrk="1" latinLnBrk="0" hangingPunct="1">
+        <a:lnSpc>
+          <a:spcPct val="90000"/>
+        </a:lnSpc>
         <a:spcBef>
-          <a:spcPct val="20000"/>
+          <a:spcPts val="1000"/>
         </a:spcBef>
-        <a:buFont typeface="Arial"/>
+        <a:buFont typeface="Arial" panose="020B0604020202020204" pitchFamily="34" charset="0"/>
         <a:buChar char="•"/>
-        <a:defRPr sz="3200" kern="1200">
+        <a:defRPr sz="2800" kern="1200">
           <a:solidFill>
             <a:schemeClr val="tx1"/>
           </a:solidFill>
@@ -2862,26 +2731,14 @@
           <a:cs typeface="+mn-cs"/>
         </a:defRPr>
       </a:lvl1pPr>
-      <a:lvl2pPr marL="742950" indent="-285750" algn="l" defTabSz="457200" rtl="0" eaLnBrk="1" latinLnBrk="0" hangingPunct="1">
+      <a:lvl2pPr marL="685800" indent="-228600" algn="l" defTabSz="914400" rtl="0" eaLnBrk="1" latinLnBrk="0" hangingPunct="1">
+        <a:lnSpc>
+          <a:spcPct val="90000"/>
+        </a:lnSpc>
         <a:spcBef>
-          <a:spcPct val="20000"/>
+          <a:spcPts val="500"/>
         </a:spcBef>
-        <a:buFont typeface="Arial"/>
-        <a:buChar char="–"/>
-        <a:defRPr sz="2800" kern="1200">
-          <a:solidFill>
-            <a:schemeClr val="tx1"/>
-          </a:solidFill>
-          <a:latin typeface="+mn-lt"/>
-          <a:ea typeface="+mn-ea"/>
-          <a:cs typeface="+mn-cs"/>
-        </a:defRPr>
-      </a:lvl2pPr>
-      <a:lvl3pPr marL="1143000" indent="-228600" algn="l" defTabSz="457200" rtl="0" eaLnBrk="1" latinLnBrk="0" hangingPunct="1">
-        <a:spcBef>
-          <a:spcPct val="20000"/>
-        </a:spcBef>
-        <a:buFont typeface="Arial"/>
+        <a:buFont typeface="Arial" panose="020B0604020202020204" pitchFamily="34" charset="0"/>
         <a:buChar char="•"/>
         <a:defRPr sz="2400" kern="1200">
           <a:solidFill>
@@ -2891,42 +2748,15 @@
           <a:ea typeface="+mn-ea"/>
           <a:cs typeface="+mn-cs"/>
         </a:defRPr>
-      </a:lvl3pPr>
-      <a:lvl4pPr marL="1600200" indent="-228600" algn="l" defTabSz="457200" rtl="0" eaLnBrk="1" latinLnBrk="0" hangingPunct="1">
+      </a:lvl2pPr>
+      <a:lvl3pPr marL="1143000" indent="-228600" algn="l" defTabSz="914400" rtl="0" eaLnBrk="1" latinLnBrk="0" hangingPunct="1">
+        <a:lnSpc>
+          <a:spcPct val="90000"/>
+        </a:lnSpc>
         <a:spcBef>
-          <a:spcPct val="20000"/>
+          <a:spcPts val="500"/>
         </a:spcBef>
-        <a:buFont typeface="Arial"/>
-        <a:buChar char="–"/>
-        <a:defRPr sz="2000" kern="1200">
-          <a:solidFill>
-            <a:schemeClr val="tx1"/>
-          </a:solidFill>
-          <a:latin typeface="+mn-lt"/>
-          <a:ea typeface="+mn-ea"/>
-          <a:cs typeface="+mn-cs"/>
-        </a:defRPr>
-      </a:lvl4pPr>
-      <a:lvl5pPr marL="2057400" indent="-228600" algn="l" defTabSz="457200" rtl="0" eaLnBrk="1" latinLnBrk="0" hangingPunct="1">
-        <a:spcBef>
-          <a:spcPct val="20000"/>
-        </a:spcBef>
-        <a:buFont typeface="Arial"/>
-        <a:buChar char="»"/>
-        <a:defRPr sz="2000" kern="1200">
-          <a:solidFill>
-            <a:schemeClr val="tx1"/>
-          </a:solidFill>
-          <a:latin typeface="+mn-lt"/>
-          <a:ea typeface="+mn-ea"/>
-          <a:cs typeface="+mn-cs"/>
-        </a:defRPr>
-      </a:lvl5pPr>
-      <a:lvl6pPr marL="2514600" indent="-228600" algn="l" defTabSz="457200" rtl="0" eaLnBrk="1" latinLnBrk="0" hangingPunct="1">
-        <a:spcBef>
-          <a:spcPct val="20000"/>
-        </a:spcBef>
-        <a:buFont typeface="Arial"/>
+        <a:buFont typeface="Arial" panose="020B0604020202020204" pitchFamily="34" charset="0"/>
         <a:buChar char="•"/>
         <a:defRPr sz="2000" kern="1200">
           <a:solidFill>
@@ -2936,14 +2766,71 @@
           <a:ea typeface="+mn-ea"/>
           <a:cs typeface="+mn-cs"/>
         </a:defRPr>
+      </a:lvl3pPr>
+      <a:lvl4pPr marL="1600200" indent="-228600" algn="l" defTabSz="914400" rtl="0" eaLnBrk="1" latinLnBrk="0" hangingPunct="1">
+        <a:lnSpc>
+          <a:spcPct val="90000"/>
+        </a:lnSpc>
+        <a:spcBef>
+          <a:spcPts val="500"/>
+        </a:spcBef>
+        <a:buFont typeface="Arial" panose="020B0604020202020204" pitchFamily="34" charset="0"/>
+        <a:buChar char="•"/>
+        <a:defRPr sz="1800" kern="1200">
+          <a:solidFill>
+            <a:schemeClr val="tx1"/>
+          </a:solidFill>
+          <a:latin typeface="+mn-lt"/>
+          <a:ea typeface="+mn-ea"/>
+          <a:cs typeface="+mn-cs"/>
+        </a:defRPr>
+      </a:lvl4pPr>
+      <a:lvl5pPr marL="2057400" indent="-228600" algn="l" defTabSz="914400" rtl="0" eaLnBrk="1" latinLnBrk="0" hangingPunct="1">
+        <a:lnSpc>
+          <a:spcPct val="90000"/>
+        </a:lnSpc>
+        <a:spcBef>
+          <a:spcPts val="500"/>
+        </a:spcBef>
+        <a:buFont typeface="Arial" panose="020B0604020202020204" pitchFamily="34" charset="0"/>
+        <a:buChar char="•"/>
+        <a:defRPr sz="1800" kern="1200">
+          <a:solidFill>
+            <a:schemeClr val="tx1"/>
+          </a:solidFill>
+          <a:latin typeface="+mn-lt"/>
+          <a:ea typeface="+mn-ea"/>
+          <a:cs typeface="+mn-cs"/>
+        </a:defRPr>
+      </a:lvl5pPr>
+      <a:lvl6pPr marL="2514600" indent="-228600" algn="l" defTabSz="914400" rtl="0" eaLnBrk="1" latinLnBrk="0" hangingPunct="1">
+        <a:lnSpc>
+          <a:spcPct val="90000"/>
+        </a:lnSpc>
+        <a:spcBef>
+          <a:spcPts val="500"/>
+        </a:spcBef>
+        <a:buFont typeface="Arial" panose="020B0604020202020204" pitchFamily="34" charset="0"/>
+        <a:buChar char="•"/>
+        <a:defRPr sz="1800" kern="1200">
+          <a:solidFill>
+            <a:schemeClr val="tx1"/>
+          </a:solidFill>
+          <a:latin typeface="+mn-lt"/>
+          <a:ea typeface="+mn-ea"/>
+          <a:cs typeface="+mn-cs"/>
+        </a:defRPr>
       </a:lvl6pPr>
-      <a:lvl7pPr marL="2971800" indent="-228600" algn="l" defTabSz="457200" rtl="0" eaLnBrk="1" latinLnBrk="0" hangingPunct="1">
+      <a:lvl7pPr marL="2971800" indent="-228600" algn="l" defTabSz="914400" rtl="0" eaLnBrk="1" latinLnBrk="0" hangingPunct="1">
+        <a:lnSpc>
+          <a:spcPct val="90000"/>
+        </a:lnSpc>
         <a:spcBef>
-          <a:spcPct val="20000"/>
+          <a:spcPts val="500"/>
         </a:spcBef>
-        <a:buFont typeface="Arial"/>
+        <a:buFont typeface="Arial" panose="020B0604020202020204" pitchFamily="34" charset="0"/>
         <a:buChar char="•"/>
-        <a:defRPr sz="2000" kern="1200">
+        <a:defRPr sz="1800" kern="1200">
           <a:solidFill>
             <a:schemeClr val="tx1"/>
           </a:solidFill>
@@ -2952,13 +2839,16 @@
           <a:cs typeface="+mn-cs"/>
         </a:defRPr>
       </a:lvl7pPr>
-      <a:lvl8pPr marL="3429000" indent="-228600" algn="l" defTabSz="457200" rtl="0" eaLnBrk="1" latinLnBrk="0" hangingPunct="1">
+      <a:lvl8pPr marL="3429000" indent="-228600" algn="l" defTabSz="914400" rtl="0" eaLnBrk="1" latinLnBrk="0" hangingPunct="1">
+        <a:lnSpc>
+          <a:spcPct val="90000"/>
+        </a:lnSpc>
         <a:spcBef>
-          <a:spcPct val="20000"/>
+          <a:spcPts val="500"/>
         </a:spcBef>
-        <a:buFont typeface="Arial"/>
+        <a:buFont typeface="Arial" panose="020B0604020202020204" pitchFamily="34" charset="0"/>
         <a:buChar char="•"/>
-        <a:defRPr sz="2000" kern="1200">
+        <a:defRPr sz="1800" kern="1200">
           <a:solidFill>
             <a:schemeClr val="tx1"/>
           </a:solidFill>
@@ -2967,13 +2857,16 @@
           <a:cs typeface="+mn-cs"/>
         </a:defRPr>
       </a:lvl8pPr>
-      <a:lvl9pPr marL="3886200" indent="-228600" algn="l" defTabSz="457200" rtl="0" eaLnBrk="1" latinLnBrk="0" hangingPunct="1">
+      <a:lvl9pPr marL="3886200" indent="-228600" algn="l" defTabSz="914400" rtl="0" eaLnBrk="1" latinLnBrk="0" hangingPunct="1">
+        <a:lnSpc>
+          <a:spcPct val="90000"/>
+        </a:lnSpc>
         <a:spcBef>
-          <a:spcPct val="20000"/>
+          <a:spcPts val="500"/>
         </a:spcBef>
-        <a:buFont typeface="Arial"/>
+        <a:buFont typeface="Arial" panose="020B0604020202020204" pitchFamily="34" charset="0"/>
         <a:buChar char="•"/>
-        <a:defRPr sz="2000" kern="1200">
+        <a:defRPr sz="1800" kern="1200">
           <a:solidFill>
             <a:schemeClr val="tx1"/>
           </a:solidFill>
@@ -2987,7 +2880,7 @@
       <a:defPPr>
         <a:defRPr lang="en-US"/>
       </a:defPPr>
-      <a:lvl1pPr marL="0" algn="l" defTabSz="457200" rtl="0" eaLnBrk="1" latinLnBrk="0" hangingPunct="1">
+      <a:lvl1pPr marL="0" algn="l" defTabSz="914400" rtl="0" eaLnBrk="1" latinLnBrk="0" hangingPunct="1">
         <a:defRPr sz="1800" kern="1200">
           <a:solidFill>
             <a:schemeClr val="tx1"/>
@@ -2997,7 +2890,7 @@
           <a:cs typeface="+mn-cs"/>
         </a:defRPr>
       </a:lvl1pPr>
-      <a:lvl2pPr marL="457200" algn="l" defTabSz="457200" rtl="0" eaLnBrk="1" latinLnBrk="0" hangingPunct="1">
+      <a:lvl2pPr marL="457200" algn="l" defTabSz="914400" rtl="0" eaLnBrk="1" latinLnBrk="0" hangingPunct="1">
         <a:defRPr sz="1800" kern="1200">
           <a:solidFill>
             <a:schemeClr val="tx1"/>
@@ -3007,7 +2900,7 @@
           <a:cs typeface="+mn-cs"/>
         </a:defRPr>
       </a:lvl2pPr>
-      <a:lvl3pPr marL="914400" algn="l" defTabSz="457200" rtl="0" eaLnBrk="1" latinLnBrk="0" hangingPunct="1">
+      <a:lvl3pPr marL="914400" algn="l" defTabSz="914400" rtl="0" eaLnBrk="1" latinLnBrk="0" hangingPunct="1">
         <a:defRPr sz="1800" kern="1200">
           <a:solidFill>
             <a:schemeClr val="tx1"/>
@@ -3017,7 +2910,7 @@
           <a:cs typeface="+mn-cs"/>
         </a:defRPr>
       </a:lvl3pPr>
-      <a:lvl4pPr marL="1371600" algn="l" defTabSz="457200" rtl="0" eaLnBrk="1" latinLnBrk="0" hangingPunct="1">
+      <a:lvl4pPr marL="1371600" algn="l" defTabSz="914400" rtl="0" eaLnBrk="1" latinLnBrk="0" hangingPunct="1">
         <a:defRPr sz="1800" kern="1200">
           <a:solidFill>
             <a:schemeClr val="tx1"/>
@@ -3027,7 +2920,7 @@
           <a:cs typeface="+mn-cs"/>
         </a:defRPr>
       </a:lvl4pPr>
-      <a:lvl5pPr marL="1828800" algn="l" defTabSz="457200" rtl="0" eaLnBrk="1" latinLnBrk="0" hangingPunct="1">
+      <a:lvl5pPr marL="1828800" algn="l" defTabSz="914400" rtl="0" eaLnBrk="1" latinLnBrk="0" hangingPunct="1">
         <a:defRPr sz="1800" kern="1200">
           <a:solidFill>
             <a:schemeClr val="tx1"/>
@@ -3037,7 +2930,7 @@
           <a:cs typeface="+mn-cs"/>
         </a:defRPr>
       </a:lvl5pPr>
-      <a:lvl6pPr marL="2286000" algn="l" defTabSz="457200" rtl="0" eaLnBrk="1" latinLnBrk="0" hangingPunct="1">
+      <a:lvl6pPr marL="2286000" algn="l" defTabSz="914400" rtl="0" eaLnBrk="1" latinLnBrk="0" hangingPunct="1">
         <a:defRPr sz="1800" kern="1200">
           <a:solidFill>
             <a:schemeClr val="tx1"/>
@@ -3047,7 +2940,7 @@
           <a:cs typeface="+mn-cs"/>
         </a:defRPr>
       </a:lvl6pPr>
-      <a:lvl7pPr marL="2743200" algn="l" defTabSz="457200" rtl="0" eaLnBrk="1" latinLnBrk="0" hangingPunct="1">
+      <a:lvl7pPr marL="2743200" algn="l" defTabSz="914400" rtl="0" eaLnBrk="1" latinLnBrk="0" hangingPunct="1">
         <a:defRPr sz="1800" kern="1200">
           <a:solidFill>
             <a:schemeClr val="tx1"/>
@@ -3057,7 +2950,7 @@
           <a:cs typeface="+mn-cs"/>
         </a:defRPr>
       </a:lvl7pPr>
-      <a:lvl8pPr marL="3200400" algn="l" defTabSz="457200" rtl="0" eaLnBrk="1" latinLnBrk="0" hangingPunct="1">
+      <a:lvl8pPr marL="3200400" algn="l" defTabSz="914400" rtl="0" eaLnBrk="1" latinLnBrk="0" hangingPunct="1">
         <a:defRPr sz="1800" kern="1200">
           <a:solidFill>
             <a:schemeClr val="tx1"/>
@@ -3067,7 +2960,7 @@
           <a:cs typeface="+mn-cs"/>
         </a:defRPr>
       </a:lvl8pPr>
-      <a:lvl9pPr marL="3657600" algn="l" defTabSz="457200" rtl="0" eaLnBrk="1" latinLnBrk="0" hangingPunct="1">
+      <a:lvl9pPr marL="3657600" algn="l" defTabSz="914400" rtl="0" eaLnBrk="1" latinLnBrk="0" hangingPunct="1">
         <a:defRPr sz="1800" kern="1200">
           <a:solidFill>
             <a:schemeClr val="tx1"/>
@@ -3085,22 +2978,6 @@
 <file path=ppt/slides/slide1.xml><?xml version="1.0" encoding="utf-8"?>
 <p:sld xmlns:a="http://schemas.openxmlformats.org/drawingml/2006/main" xmlns:r="http://schemas.openxmlformats.org/officeDocument/2006/relationships" xmlns:p="http://schemas.openxmlformats.org/presentationml/2006/main">
   <p:cSld>
-    <p:bg>
-      <p:bgPr>
-        <a:gradFill rotWithShape="1">
-          <a:gsLst>
-            <a:gs pos="0">
-              <a:srgbClr val="F8F9FA"/>
-            </a:gs>
-            <a:gs pos="100000">
-              <a:srgbClr val="FFFFFF"/>
-            </a:gs>
-          </a:gsLst>
-          <a:lin ang="18900000" scaled="0"/>
-        </a:gradFill>
-        <a:effectLst/>
-      </p:bgPr>
-    </p:bg>
     <p:spTree>
       <p:nvGrpSpPr>
         <p:cNvPr id="1" name=""/>
@@ -3146,6 +3023,7 @@
               </a:defRPr>
             </a:pPr>
             <a:r>
+              <a:rPr dirty="0"/>
               <a:t>Game Analytics Pipeline</a:t>
             </a:r>
           </a:p>
@@ -3270,22 +3148,6 @@
 <file path=ppt/slides/slide10.xml><?xml version="1.0" encoding="utf-8"?>
 <p:sld xmlns:a="http://schemas.openxmlformats.org/drawingml/2006/main" xmlns:r="http://schemas.openxmlformats.org/officeDocument/2006/relationships" xmlns:p="http://schemas.openxmlformats.org/presentationml/2006/main">
   <p:cSld>
-    <p:bg>
-      <p:bgPr>
-        <a:gradFill rotWithShape="1">
-          <a:gsLst>
-            <a:gs pos="0">
-              <a:srgbClr val="FFFFFF"/>
-            </a:gs>
-            <a:gs pos="100000">
-              <a:srgbClr val="F8F9FA"/>
-            </a:gs>
-          </a:gsLst>
-          <a:lin ang="18900000" scaled="0"/>
-        </a:gradFill>
-        <a:effectLst/>
-      </p:bgPr>
-    </p:bg>
     <p:spTree>
       <p:nvGrpSpPr>
         <p:cNvPr id="1" name=""/>
@@ -3309,7 +3171,7 @@
         <p:spPr>
           <a:xfrm>
             <a:off x="457200" y="457200"/>
-            <a:ext cx="8229600" cy="914400"/>
+            <a:ext cx="8229600" cy="707886"/>
           </a:xfrm>
           <a:prstGeom prst="rect">
             <a:avLst/>
@@ -3331,7 +3193,8 @@
               </a:defRPr>
             </a:pPr>
             <a:r>
-              <a:t>Evaluation &amp; Conclusion</a:t>
+              <a:rPr dirty="0"/>
+              <a:t>Conclusion</a:t>
             </a:r>
           </a:p>
         </p:txBody>
@@ -3344,8 +3207,8 @@
         </p:nvSpPr>
         <p:spPr>
           <a:xfrm>
-            <a:off x="1371600" y="1371600"/>
-            <a:ext cx="6949440" cy="320040"/>
+            <a:off x="1057275" y="1363773"/>
+            <a:ext cx="1670137" cy="369332"/>
           </a:xfrm>
           <a:prstGeom prst="rect">
             <a:avLst/>
@@ -3368,7 +3231,7 @@
             </a:pPr>
             <a:r>
               <a:rPr dirty="0"/>
-              <a:t>Gather &amp; Store (50%)</a:t>
+              <a:t>Gather &amp; Store</a:t>
             </a:r>
           </a:p>
         </p:txBody>
@@ -3381,8 +3244,8 @@
         </p:nvSpPr>
         <p:spPr>
           <a:xfrm>
-            <a:off x="1645920" y="1737360"/>
-            <a:ext cx="6583680" cy="256032"/>
+            <a:off x="1331595" y="1729533"/>
+            <a:ext cx="3128998" cy="338554"/>
           </a:xfrm>
           <a:prstGeom prst="rect">
             <a:avLst/>
@@ -3404,7 +3267,37 @@
               </a:defRPr>
             </a:pPr>
             <a:r>
-              <a:t>✓ Normalized DB with proper indexes</a:t>
+              <a:rPr dirty="0">
+                <a:solidFill>
+                  <a:schemeClr val="tx1">
+                    <a:lumMod val="85000"/>
+                    <a:lumOff val="15000"/>
+                  </a:schemeClr>
+                </a:solidFill>
+              </a:rPr>
+              <a:t>Normalized DB with</a:t>
+            </a:r>
+            <a:r>
+              <a:rPr lang="en-US" dirty="0">
+                <a:solidFill>
+                  <a:schemeClr val="tx1">
+                    <a:lumMod val="85000"/>
+                    <a:lumOff val="15000"/>
+                  </a:schemeClr>
+                </a:solidFill>
+              </a:rPr>
+              <a:t> </a:t>
+            </a:r>
+            <a:r>
+              <a:rPr dirty="0">
+                <a:solidFill>
+                  <a:schemeClr val="tx1">
+                    <a:lumMod val="85000"/>
+                    <a:lumOff val="15000"/>
+                  </a:schemeClr>
+                </a:solidFill>
+              </a:rPr>
+              <a:t>proper indexes</a:t>
             </a:r>
           </a:p>
         </p:txBody>
@@ -3417,8 +3310,8 @@
         </p:nvSpPr>
         <p:spPr>
           <a:xfrm>
-            <a:off x="1645920" y="2029968"/>
-            <a:ext cx="6583680" cy="256032"/>
+            <a:off x="1331595" y="2022141"/>
+            <a:ext cx="3340723" cy="338554"/>
           </a:xfrm>
           <a:prstGeom prst="rect">
             <a:avLst/>
@@ -3440,7 +3333,15 @@
               </a:defRPr>
             </a:pPr>
             <a:r>
-              <a:t>✓ Non-intrusive async data transmission</a:t>
+              <a:rPr dirty="0">
+                <a:solidFill>
+                  <a:schemeClr val="tx1">
+                    <a:lumMod val="95000"/>
+                    <a:lumOff val="5000"/>
+                  </a:schemeClr>
+                </a:solidFill>
+              </a:rPr>
+              <a:t>Non-intrusive async data transmission</a:t>
             </a:r>
           </a:p>
         </p:txBody>
@@ -3453,8 +3354,8 @@
         </p:nvSpPr>
         <p:spPr>
           <a:xfrm>
-            <a:off x="1645920" y="2322576"/>
-            <a:ext cx="6583680" cy="256032"/>
+            <a:off x="1331595" y="2314749"/>
+            <a:ext cx="2916055" cy="338554"/>
           </a:xfrm>
           <a:prstGeom prst="rect">
             <a:avLst/>
@@ -3476,7 +3377,15 @@
               </a:defRPr>
             </a:pPr>
             <a:r>
-              <a:t>✓ SOLID principles &amp; modular code</a:t>
+              <a:rPr dirty="0">
+                <a:solidFill>
+                  <a:schemeClr val="tx1">
+                    <a:lumMod val="95000"/>
+                    <a:lumOff val="5000"/>
+                  </a:schemeClr>
+                </a:solidFill>
+              </a:rPr>
+              <a:t>SOLID principles &amp; modular code</a:t>
             </a:r>
           </a:p>
         </p:txBody>
@@ -3489,8 +3398,8 @@
         </p:nvSpPr>
         <p:spPr>
           <a:xfrm>
-            <a:off x="1371600" y="2724912"/>
-            <a:ext cx="6949440" cy="320040"/>
+            <a:off x="1057275" y="2717085"/>
+            <a:ext cx="1051442" cy="369332"/>
           </a:xfrm>
           <a:prstGeom prst="rect">
             <a:avLst/>
@@ -3512,7 +3421,8 @@
               </a:defRPr>
             </a:pPr>
             <a:r>
-              <a:t>Analytics (30%)</a:t>
+              <a:rPr dirty="0"/>
+              <a:t>Analytics</a:t>
             </a:r>
           </a:p>
         </p:txBody>
@@ -3525,8 +3435,8 @@
         </p:nvSpPr>
         <p:spPr>
           <a:xfrm>
-            <a:off x="1645920" y="3090672"/>
-            <a:ext cx="6583680" cy="256032"/>
+            <a:off x="1331595" y="3082845"/>
+            <a:ext cx="3163110" cy="338554"/>
           </a:xfrm>
           <a:prstGeom prst="rect">
             <a:avLst/>
@@ -3548,8 +3458,15 @@
               </a:defRPr>
             </a:pPr>
             <a:r>
-              <a:rPr dirty="0"/>
-              <a:t>✓ Correct KPI calculations with 95% CI</a:t>
+              <a:rPr dirty="0">
+                <a:solidFill>
+                  <a:schemeClr val="tx1">
+                    <a:lumMod val="95000"/>
+                    <a:lumOff val="5000"/>
+                  </a:schemeClr>
+                </a:solidFill>
+              </a:rPr>
+              <a:t>Correct KPI calculations with 95% CI</a:t>
             </a:r>
           </a:p>
         </p:txBody>
@@ -3562,8 +3479,8 @@
         </p:nvSpPr>
         <p:spPr>
           <a:xfrm>
-            <a:off x="1645920" y="3383280"/>
-            <a:ext cx="6583680" cy="256032"/>
+            <a:off x="1331595" y="3375453"/>
+            <a:ext cx="3164136" cy="338554"/>
           </a:xfrm>
           <a:prstGeom prst="rect">
             <a:avLst/>
@@ -3585,7 +3502,15 @@
               </a:defRPr>
             </a:pPr>
             <a:r>
-              <a:t>✓ Statistical rigor &amp; hypothesis testing</a:t>
+              <a:rPr dirty="0">
+                <a:solidFill>
+                  <a:schemeClr val="tx1">
+                    <a:lumMod val="95000"/>
+                    <a:lumOff val="5000"/>
+                  </a:schemeClr>
+                </a:solidFill>
+              </a:rPr>
+              <a:t>Statistical rigor &amp; hypothesis testing</a:t>
             </a:r>
           </a:p>
         </p:txBody>
@@ -3598,8 +3523,8 @@
         </p:nvSpPr>
         <p:spPr>
           <a:xfrm>
-            <a:off x="1645920" y="3675888"/>
-            <a:ext cx="6583680" cy="256032"/>
+            <a:off x="1331595" y="3668061"/>
+            <a:ext cx="2701189" cy="338554"/>
           </a:xfrm>
           <a:prstGeom prst="rect">
             <a:avLst/>
@@ -3621,7 +3546,15 @@
               </a:defRPr>
             </a:pPr>
             <a:r>
-              <a:t>✓ Efficient, reusable SQL queries</a:t>
+              <a:rPr dirty="0">
+                <a:solidFill>
+                  <a:schemeClr val="tx1">
+                    <a:lumMod val="95000"/>
+                    <a:lumOff val="5000"/>
+                  </a:schemeClr>
+                </a:solidFill>
+              </a:rPr>
+              <a:t>Efficient, reusable SQL queries</a:t>
             </a:r>
           </a:p>
         </p:txBody>
@@ -3634,8 +3567,8 @@
         </p:nvSpPr>
         <p:spPr>
           <a:xfrm>
-            <a:off x="1371600" y="4078224"/>
-            <a:ext cx="6949440" cy="320040"/>
+            <a:off x="1057275" y="4070397"/>
+            <a:ext cx="1123834" cy="369332"/>
           </a:xfrm>
           <a:prstGeom prst="rect">
             <a:avLst/>
@@ -3657,7 +3590,8 @@
               </a:defRPr>
             </a:pPr>
             <a:r>
-              <a:t>Reporting (20%)</a:t>
+              <a:rPr dirty="0"/>
+              <a:t>Reporting</a:t>
             </a:r>
           </a:p>
         </p:txBody>
@@ -3670,8 +3604,8 @@
         </p:nvSpPr>
         <p:spPr>
           <a:xfrm>
-            <a:off x="1645920" y="4443984"/>
-            <a:ext cx="6583680" cy="256032"/>
+            <a:off x="1331595" y="4436157"/>
+            <a:ext cx="2626809" cy="338554"/>
           </a:xfrm>
           <a:prstGeom prst="rect">
             <a:avLst/>
@@ -3693,7 +3627,15 @@
               </a:defRPr>
             </a:pPr>
             <a:r>
-              <a:t>✓ Clear visualizations &amp; insights</a:t>
+              <a:rPr dirty="0">
+                <a:solidFill>
+                  <a:schemeClr val="tx1">
+                    <a:lumMod val="95000"/>
+                    <a:lumOff val="5000"/>
+                  </a:schemeClr>
+                </a:solidFill>
+              </a:rPr>
+              <a:t>Clear visualizations &amp; insights</a:t>
             </a:r>
           </a:p>
         </p:txBody>
@@ -3706,8 +3648,8 @@
         </p:nvSpPr>
         <p:spPr>
           <a:xfrm>
-            <a:off x="1645920" y="4736592"/>
-            <a:ext cx="6583680" cy="256032"/>
+            <a:off x="1331595" y="4728765"/>
+            <a:ext cx="2303964" cy="338554"/>
           </a:xfrm>
           <a:prstGeom prst="rect">
             <a:avLst/>
@@ -3729,8 +3671,15 @@
               </a:defRPr>
             </a:pPr>
             <a:r>
-              <a:rPr dirty="0"/>
-              <a:t>✓ Professional presentation</a:t>
+              <a:rPr dirty="0">
+                <a:solidFill>
+                  <a:schemeClr val="tx1">
+                    <a:lumMod val="95000"/>
+                    <a:lumOff val="5000"/>
+                  </a:schemeClr>
+                </a:solidFill>
+              </a:rPr>
+              <a:t>Professional presentation</a:t>
             </a:r>
           </a:p>
         </p:txBody>
@@ -3743,8 +3692,8 @@
         </p:nvSpPr>
         <p:spPr>
           <a:xfrm>
-            <a:off x="1645920" y="5029200"/>
-            <a:ext cx="6583680" cy="256032"/>
+            <a:off x="1331595" y="5021373"/>
+            <a:ext cx="3398751" cy="338554"/>
           </a:xfrm>
           <a:prstGeom prst="rect">
             <a:avLst/>
@@ -3766,8 +3715,15 @@
               </a:defRPr>
             </a:pPr>
             <a:r>
-              <a:rPr dirty="0"/>
-              <a:t>✓ Actionable business recommendations</a:t>
+              <a:rPr dirty="0">
+                <a:solidFill>
+                  <a:schemeClr val="tx1">
+                    <a:lumMod val="95000"/>
+                    <a:lumOff val="5000"/>
+                  </a:schemeClr>
+                </a:solidFill>
+              </a:rPr>
+              <a:t>Actionable business recommendations</a:t>
             </a:r>
           </a:p>
         </p:txBody>
@@ -3780,7 +3736,7 @@
         </p:nvSpPr>
         <p:spPr>
           <a:xfrm>
-            <a:off x="1371599" y="5519850"/>
+            <a:off x="1371599" y="5639593"/>
             <a:ext cx="6185807" cy="761207"/>
           </a:xfrm>
           <a:prstGeom prst="roundRect">
@@ -3789,7 +3745,10 @@
           <a:gradFill flip="none" rotWithShape="1">
             <a:gsLst>
               <a:gs pos="69000">
-                <a:srgbClr val="CEDCE0"/>
+                <a:srgbClr val="CEDCE0">
+                  <a:lumMod val="38000"/>
+                  <a:lumOff val="62000"/>
+                </a:srgbClr>
               </a:gs>
               <a:gs pos="100000">
                 <a:schemeClr val="accent3">
@@ -3845,7 +3804,7 @@
         </p:nvSpPr>
         <p:spPr>
           <a:xfrm>
-            <a:off x="1586593" y="5577287"/>
+            <a:off x="1586593" y="5697030"/>
             <a:ext cx="5970814" cy="646331"/>
           </a:xfrm>
           <a:prstGeom prst="rect">
@@ -3876,14 +3835,14 @@
       </p:sp>
       <p:sp>
         <p:nvSpPr>
-          <p:cNvPr id="17" name="TextBox 16"/>
+          <p:cNvPr id="18" name="TextBox 17"/>
           <p:cNvSpPr txBox="1"/>
           <p:nvPr/>
         </p:nvSpPr>
         <p:spPr>
           <a:xfrm>
-            <a:off x="3200400" y="6400800"/>
-            <a:ext cx="2743200" cy="274320"/>
+            <a:off x="8229600" y="6492240"/>
+            <a:ext cx="731520" cy="274320"/>
           </a:xfrm>
           <a:prstGeom prst="rect">
             <a:avLst/>
@@ -3896,8 +3855,8 @@
           </a:bodyPr>
           <a:lstStyle/>
           <a:p>
-            <a:pPr algn="ctr">
-              <a:defRPr sz="2000">
+            <a:pPr algn="r">
+              <a:defRPr sz="1000">
                 <a:solidFill>
                   <a:srgbClr val="7F8C8D"/>
                 </a:solidFill>
@@ -3905,22 +3864,27 @@
               </a:defRPr>
             </a:pPr>
             <a:r>
-              <a:rPr dirty="0"/>
-              <a:t>Thank you | Questions?</a:t>
-            </a:r>
-          </a:p>
-        </p:txBody>
-      </p:sp>
-      <p:sp>
-        <p:nvSpPr>
-          <p:cNvPr id="18" name="TextBox 17"/>
+              <a:t>10/10</a:t>
+            </a:r>
+          </a:p>
+        </p:txBody>
+      </p:sp>
+      <p:sp>
+        <p:nvSpPr>
+          <p:cNvPr id="19" name="TextBox 18">
+            <a:extLst>
+              <a:ext uri="{FF2B5EF4-FFF2-40B4-BE49-F238E27FC236}">
+                <a16:creationId xmlns:a16="http://schemas.microsoft.com/office/drawing/2014/main" id="{6EB603CE-20D5-E94A-9EAE-FA9613383EB1}"/>
+              </a:ext>
+            </a:extLst>
+          </p:cNvPr>
           <p:cNvSpPr txBox="1"/>
           <p:nvPr/>
         </p:nvSpPr>
         <p:spPr>
           <a:xfrm>
-            <a:off x="8229600" y="6492240"/>
-            <a:ext cx="731520" cy="274320"/>
+            <a:off x="4730346" y="1363773"/>
+            <a:ext cx="2068643" cy="369332"/>
           </a:xfrm>
           <a:prstGeom prst="rect">
             <a:avLst/>
@@ -3933,16 +3897,277 @@
           </a:bodyPr>
           <a:lstStyle/>
           <a:p>
-            <a:pPr algn="r">
-              <a:defRPr sz="1000">
-                <a:solidFill>
-                  <a:srgbClr val="7F8C8D"/>
+            <a:pPr>
+              <a:defRPr sz="1800" b="1">
+                <a:solidFill>
+                  <a:srgbClr val="3498DB"/>
                 </a:solidFill>
                 <a:latin typeface="Calibri"/>
               </a:defRPr>
             </a:pPr>
             <a:r>
-              <a:t>10/10</a:t>
+              <a:rPr lang="en-US" dirty="0"/>
+              <a:t>Pipeline Limitations</a:t>
+            </a:r>
+            <a:endParaRPr dirty="0"/>
+          </a:p>
+        </p:txBody>
+      </p:sp>
+      <p:sp>
+        <p:nvSpPr>
+          <p:cNvPr id="20" name="TextBox 19">
+            <a:extLst>
+              <a:ext uri="{FF2B5EF4-FFF2-40B4-BE49-F238E27FC236}">
+                <a16:creationId xmlns:a16="http://schemas.microsoft.com/office/drawing/2014/main" id="{732C7852-E14E-D3DE-D61A-829CECB02F12}"/>
+              </a:ext>
+            </a:extLst>
+          </p:cNvPr>
+          <p:cNvSpPr txBox="1"/>
+          <p:nvPr/>
+        </p:nvSpPr>
+        <p:spPr>
+          <a:xfrm>
+            <a:off x="5067674" y="1901844"/>
+            <a:ext cx="2913202" cy="374571"/>
+          </a:xfrm>
+          <a:prstGeom prst="roundRect">
+            <a:avLst/>
+          </a:prstGeom>
+          <a:solidFill>
+            <a:srgbClr val="D5F5FF"/>
+          </a:solidFill>
+          <a:effectLst>
+            <a:outerShdw blurRad="214469" dist="50800" dir="5400000" sx="104000" sy="104000" algn="ctr" rotWithShape="0">
+              <a:srgbClr val="000000">
+                <a:alpha val="3877"/>
+              </a:srgbClr>
+            </a:outerShdw>
+            <a:softEdge rad="0"/>
+          </a:effectLst>
+        </p:spPr>
+        <p:txBody>
+          <a:bodyPr wrap="square" rtlCol="0">
+            <a:spAutoFit/>
+          </a:bodyPr>
+          <a:lstStyle/>
+          <a:p>
+            <a:pPr>
+              <a:spcAft>
+                <a:spcPts val="600"/>
+              </a:spcAft>
+            </a:pPr>
+            <a:r>
+              <a:rPr lang="en-US" sz="1600" dirty="0">
+                <a:latin typeface="Calibri" panose="020F0502020204030204" pitchFamily="34" charset="0"/>
+                <a:cs typeface="Calibri" panose="020F0502020204030204" pitchFamily="34" charset="0"/>
+              </a:rPr>
+              <a:t>Simulated data</a:t>
+            </a:r>
+          </a:p>
+        </p:txBody>
+      </p:sp>
+      <p:sp>
+        <p:nvSpPr>
+          <p:cNvPr id="27" name="TextBox 26">
+            <a:extLst>
+              <a:ext uri="{FF2B5EF4-FFF2-40B4-BE49-F238E27FC236}">
+                <a16:creationId xmlns:a16="http://schemas.microsoft.com/office/drawing/2014/main" id="{94E598E0-BD47-4581-C83D-041603DB522F}"/>
+              </a:ext>
+            </a:extLst>
+          </p:cNvPr>
+          <p:cNvSpPr txBox="1"/>
+          <p:nvPr/>
+        </p:nvSpPr>
+        <p:spPr>
+          <a:xfrm>
+            <a:off x="5078350" y="2565455"/>
+            <a:ext cx="2913202" cy="374571"/>
+          </a:xfrm>
+          <a:prstGeom prst="roundRect">
+            <a:avLst/>
+          </a:prstGeom>
+          <a:solidFill>
+            <a:srgbClr val="D5F5FF"/>
+          </a:solidFill>
+          <a:effectLst>
+            <a:outerShdw blurRad="214469" dist="50800" dir="5400000" sx="104000" sy="104000" algn="ctr" rotWithShape="0">
+              <a:srgbClr val="000000">
+                <a:alpha val="3877"/>
+              </a:srgbClr>
+            </a:outerShdw>
+            <a:softEdge rad="0"/>
+          </a:effectLst>
+        </p:spPr>
+        <p:txBody>
+          <a:bodyPr wrap="square" rtlCol="0">
+            <a:spAutoFit/>
+          </a:bodyPr>
+          <a:lstStyle/>
+          <a:p>
+            <a:pPr>
+              <a:spcAft>
+                <a:spcPts val="600"/>
+              </a:spcAft>
+            </a:pPr>
+            <a:r>
+              <a:rPr lang="en-US" sz="1600" dirty="0">
+                <a:latin typeface="Calibri" panose="020F0502020204030204" pitchFamily="34" charset="0"/>
+                <a:cs typeface="Calibri" panose="020F0502020204030204" pitchFamily="34" charset="0"/>
+              </a:rPr>
+              <a:t>Sample size of 100 users/cycle</a:t>
+            </a:r>
+          </a:p>
+        </p:txBody>
+      </p:sp>
+      <p:sp>
+        <p:nvSpPr>
+          <p:cNvPr id="28" name="TextBox 27">
+            <a:extLst>
+              <a:ext uri="{FF2B5EF4-FFF2-40B4-BE49-F238E27FC236}">
+                <a16:creationId xmlns:a16="http://schemas.microsoft.com/office/drawing/2014/main" id="{78B66A16-2734-11C7-7D32-10D6A3B9DEB7}"/>
+              </a:ext>
+            </a:extLst>
+          </p:cNvPr>
+          <p:cNvSpPr txBox="1"/>
+          <p:nvPr/>
+        </p:nvSpPr>
+        <p:spPr>
+          <a:xfrm>
+            <a:off x="5078350" y="3231069"/>
+            <a:ext cx="2913202" cy="374571"/>
+          </a:xfrm>
+          <a:prstGeom prst="roundRect">
+            <a:avLst/>
+          </a:prstGeom>
+          <a:solidFill>
+            <a:srgbClr val="D5F5FF"/>
+          </a:solidFill>
+          <a:effectLst>
+            <a:outerShdw blurRad="214469" dist="50800" dir="5400000" sx="104000" sy="104000" algn="ctr" rotWithShape="0">
+              <a:srgbClr val="000000">
+                <a:alpha val="3877"/>
+              </a:srgbClr>
+            </a:outerShdw>
+            <a:softEdge rad="0"/>
+          </a:effectLst>
+        </p:spPr>
+        <p:txBody>
+          <a:bodyPr wrap="square" rtlCol="0">
+            <a:spAutoFit/>
+          </a:bodyPr>
+          <a:lstStyle/>
+          <a:p>
+            <a:r>
+              <a:rPr lang="en-US" sz="1600" dirty="0">
+                <a:latin typeface="Calibri" panose="020F0502020204030204" pitchFamily="34" charset="0"/>
+                <a:cs typeface="Calibri" panose="020F0502020204030204" pitchFamily="34" charset="0"/>
+              </a:rPr>
+              <a:t>Short time window</a:t>
+            </a:r>
+          </a:p>
+        </p:txBody>
+      </p:sp>
+      <p:sp>
+        <p:nvSpPr>
+          <p:cNvPr id="30" name="TextBox 29">
+            <a:extLst>
+              <a:ext uri="{FF2B5EF4-FFF2-40B4-BE49-F238E27FC236}">
+                <a16:creationId xmlns:a16="http://schemas.microsoft.com/office/drawing/2014/main" id="{F6F75267-589E-6672-C9C4-6141595738AD}"/>
+              </a:ext>
+            </a:extLst>
+          </p:cNvPr>
+          <p:cNvSpPr txBox="1"/>
+          <p:nvPr/>
+        </p:nvSpPr>
+        <p:spPr>
+          <a:xfrm>
+            <a:off x="5067674" y="3898132"/>
+            <a:ext cx="2913202" cy="374571"/>
+          </a:xfrm>
+          <a:prstGeom prst="roundRect">
+            <a:avLst/>
+          </a:prstGeom>
+          <a:solidFill>
+            <a:srgbClr val="D5F5FF"/>
+          </a:solidFill>
+          <a:effectLst>
+            <a:outerShdw blurRad="214469" dist="50800" dir="5400000" sx="104000" sy="104000" algn="ctr" rotWithShape="0">
+              <a:srgbClr val="000000">
+                <a:alpha val="3877"/>
+              </a:srgbClr>
+            </a:outerShdw>
+            <a:softEdge rad="0"/>
+          </a:effectLst>
+        </p:spPr>
+        <p:txBody>
+          <a:bodyPr wrap="square" rtlCol="0">
+            <a:spAutoFit/>
+          </a:bodyPr>
+          <a:lstStyle/>
+          <a:p>
+            <a:r>
+              <a:rPr lang="en-US" sz="1600" dirty="0">
+                <a:latin typeface="Calibri" panose="020F0502020204030204" pitchFamily="34" charset="0"/>
+                <a:cs typeface="Calibri" panose="020F0502020204030204" pitchFamily="34" charset="0"/>
+              </a:rPr>
+              <a:t>No experimental design</a:t>
+            </a:r>
+          </a:p>
+        </p:txBody>
+      </p:sp>
+      <p:sp>
+        <p:nvSpPr>
+          <p:cNvPr id="31" name="TextBox 30">
+            <a:extLst>
+              <a:ext uri="{FF2B5EF4-FFF2-40B4-BE49-F238E27FC236}">
+                <a16:creationId xmlns:a16="http://schemas.microsoft.com/office/drawing/2014/main" id="{BDAC7177-44C5-9ACE-ABFB-987176137427}"/>
+              </a:ext>
+            </a:extLst>
+          </p:cNvPr>
+          <p:cNvSpPr txBox="1"/>
+          <p:nvPr/>
+        </p:nvSpPr>
+        <p:spPr>
+          <a:xfrm>
+            <a:off x="5067674" y="4565555"/>
+            <a:ext cx="2913202" cy="646986"/>
+          </a:xfrm>
+          <a:prstGeom prst="roundRect">
+            <a:avLst/>
+          </a:prstGeom>
+          <a:solidFill>
+            <a:srgbClr val="D5F5FF"/>
+          </a:solidFill>
+          <a:effectLst>
+            <a:outerShdw blurRad="214469" dist="50800" dir="5400000" sx="104000" sy="104000" algn="ctr" rotWithShape="0">
+              <a:srgbClr val="000000">
+                <a:alpha val="3877"/>
+              </a:srgbClr>
+            </a:outerShdw>
+            <a:softEdge rad="0"/>
+          </a:effectLst>
+        </p:spPr>
+        <p:txBody>
+          <a:bodyPr wrap="square" rtlCol="0">
+            <a:spAutoFit/>
+          </a:bodyPr>
+          <a:lstStyle/>
+          <a:p>
+            <a:pPr lvl="0">
+              <a:spcAft>
+                <a:spcPts val="600"/>
+              </a:spcAft>
+              <a:defRPr/>
+            </a:pPr>
+            <a:r>
+              <a:rPr lang="en-US" sz="1600" dirty="0">
+                <a:solidFill>
+                  <a:prstClr val="black"/>
+                </a:solidFill>
+                <a:latin typeface="Calibri" panose="020F0502020204030204" pitchFamily="34" charset="0"/>
+                <a:cs typeface="Calibri" panose="020F0502020204030204" pitchFamily="34" charset="0"/>
+              </a:rPr>
+              <a:t>Retention metrics limited by simulation time constraints</a:t>
             </a:r>
           </a:p>
         </p:txBody>
@@ -3955,25 +4180,9 @@
 </p:sld>
 </file>
 
-<file path=ppt/slides/slide2.xml><?xml version="1.0" encoding="utf-8"?>
+<file path=ppt/slides/slide11.xml><?xml version="1.0" encoding="utf-8"?>
 <p:sld xmlns:a="http://schemas.openxmlformats.org/drawingml/2006/main" xmlns:r="http://schemas.openxmlformats.org/officeDocument/2006/relationships" xmlns:p="http://schemas.openxmlformats.org/presentationml/2006/main">
   <p:cSld>
-    <p:bg>
-      <p:bgPr>
-        <a:gradFill rotWithShape="1">
-          <a:gsLst>
-            <a:gs pos="0">
-              <a:srgbClr val="FFFFFF"/>
-            </a:gs>
-            <a:gs pos="100000">
-              <a:srgbClr val="F8F9FA"/>
-            </a:gs>
-          </a:gsLst>
-          <a:lin ang="18900000" scaled="0"/>
-        </a:gradFill>
-        <a:effectLst/>
-      </p:bgPr>
-    </p:bg>
     <p:spTree>
       <p:nvGrpSpPr>
         <p:cNvPr id="1" name=""/>
@@ -3990,63 +4199,144 @@
       </p:grpSpPr>
       <p:sp>
         <p:nvSpPr>
-          <p:cNvPr id="2" name="TextBox 1"/>
-          <p:cNvSpPr txBox="1"/>
-          <p:nvPr/>
-        </p:nvSpPr>
-        <p:spPr>
-          <a:xfrm>
-            <a:off x="457200" y="457200"/>
-            <a:ext cx="8229600" cy="914400"/>
-          </a:xfrm>
-          <a:prstGeom prst="rect">
-            <a:avLst/>
-          </a:prstGeom>
-          <a:noFill/>
-        </p:spPr>
-        <p:txBody>
-          <a:bodyPr wrap="square">
-            <a:spAutoFit/>
+          <p:cNvPr id="2" name="Title 1">
+            <a:extLst>
+              <a:ext uri="{FF2B5EF4-FFF2-40B4-BE49-F238E27FC236}">
+                <a16:creationId xmlns:a16="http://schemas.microsoft.com/office/drawing/2014/main" id="{150B6BCC-C0F4-1EDE-65C9-17502ADA0DA8}"/>
+              </a:ext>
+            </a:extLst>
+          </p:cNvPr>
+          <p:cNvSpPr>
+            <a:spLocks noGrp="1"/>
+          </p:cNvSpPr>
+          <p:nvPr>
+            <p:ph type="ctrTitle"/>
+          </p:nvPr>
+        </p:nvSpPr>
+        <p:spPr>
+          <a:xfrm>
+            <a:off x="685800" y="2571749"/>
+            <a:ext cx="7772400" cy="993775"/>
+          </a:xfrm>
+        </p:spPr>
+        <p:txBody>
+          <a:bodyPr>
+            <a:normAutofit/>
           </a:bodyPr>
           <a:lstStyle/>
           <a:p>
-            <a:pPr algn="ctr">
-              <a:defRPr sz="4000" b="1">
-                <a:solidFill>
-                  <a:srgbClr val="2C3E50"/>
-                </a:solidFill>
-                <a:latin typeface="Calibri"/>
-              </a:defRPr>
-            </a:pPr>
-            <a:r>
-              <a:t>Pipeline Architecture</a:t>
-            </a:r>
-          </a:p>
-        </p:txBody>
-      </p:sp>
-      <p:sp>
-        <p:nvSpPr>
-          <p:cNvPr id="3" name="Rounded Rectangle 2"/>
+            <a:r>
+              <a:rPr lang="en-US" dirty="0">
+                <a:solidFill>
+                  <a:srgbClr val="002060"/>
+                </a:solidFill>
+                <a:latin typeface="+mn-lt"/>
+                <a:ea typeface="Apple Symbols" panose="02000000000000000000" pitchFamily="2" charset="-79"/>
+                <a:cs typeface="Apple Symbols" panose="02000000000000000000" pitchFamily="2" charset="-79"/>
+              </a:rPr>
+              <a:t>thank you</a:t>
+            </a:r>
+          </a:p>
+        </p:txBody>
+      </p:sp>
+    </p:spTree>
+    <p:extLst>
+      <p:ext uri="{BB962C8B-B14F-4D97-AF65-F5344CB8AC3E}">
+        <p14:creationId xmlns:p14="http://schemas.microsoft.com/office/powerpoint/2010/main" val="3661961531"/>
+      </p:ext>
+    </p:extLst>
+  </p:cSld>
+  <p:clrMapOvr>
+    <a:masterClrMapping/>
+  </p:clrMapOvr>
+</p:sld>
+</file>
+
+<file path=ppt/slides/slide2.xml><?xml version="1.0" encoding="utf-8"?>
+<p:sld xmlns:a="http://schemas.openxmlformats.org/drawingml/2006/main" xmlns:r="http://schemas.openxmlformats.org/officeDocument/2006/relationships" xmlns:p="http://schemas.openxmlformats.org/presentationml/2006/main">
+  <p:cSld>
+    <p:spTree>
+      <p:nvGrpSpPr>
+        <p:cNvPr id="1" name=""/>
+        <p:cNvGrpSpPr/>
+        <p:nvPr/>
+      </p:nvGrpSpPr>
+      <p:grpSpPr>
+        <a:xfrm>
+          <a:off x="0" y="0"/>
+          <a:ext cx="0" cy="0"/>
+          <a:chOff x="0" y="0"/>
+          <a:chExt cx="0" cy="0"/>
+        </a:xfrm>
+      </p:grpSpPr>
+      <p:sp>
+        <p:nvSpPr>
+          <p:cNvPr id="22" name="Rounded Rectangle 21">
+            <a:extLst>
+              <a:ext uri="{FF2B5EF4-FFF2-40B4-BE49-F238E27FC236}">
+                <a16:creationId xmlns:a16="http://schemas.microsoft.com/office/drawing/2014/main" id="{2C6FA2A3-5E89-FC2E-736F-2AEC5929A28C}"/>
+              </a:ext>
+            </a:extLst>
+          </p:cNvPr>
           <p:cNvSpPr/>
           <p:nvPr/>
         </p:nvSpPr>
         <p:spPr>
           <a:xfrm>
-            <a:off x="731520" y="2286000"/>
+            <a:off x="7040880" y="2286000"/>
             <a:ext cx="1188720" cy="914400"/>
           </a:xfrm>
           <a:prstGeom prst="roundRect">
             <a:avLst/>
           </a:prstGeom>
           <a:solidFill>
-            <a:srgbClr val="FFFFFF"/>
+            <a:srgbClr val="F9FFEF"/>
           </a:solidFill>
           <a:ln w="6350">
-            <a:solidFill>
-              <a:srgbClr val="ECF0F1"/>
-            </a:solidFill>
+            <a:gradFill flip="none" rotWithShape="1">
+              <a:gsLst>
+                <a:gs pos="0">
+                  <a:schemeClr val="accent1">
+                    <a:lumMod val="5000"/>
+                    <a:lumOff val="95000"/>
+                  </a:schemeClr>
+                </a:gs>
+                <a:gs pos="74000">
+                  <a:schemeClr val="accent1">
+                    <a:lumMod val="45000"/>
+                    <a:lumOff val="55000"/>
+                  </a:schemeClr>
+                </a:gs>
+                <a:gs pos="83000">
+                  <a:schemeClr val="accent1">
+                    <a:lumMod val="45000"/>
+                    <a:lumOff val="55000"/>
+                  </a:schemeClr>
+                </a:gs>
+                <a:gs pos="100000">
+                  <a:schemeClr val="accent1">
+                    <a:lumMod val="30000"/>
+                    <a:lumOff val="70000"/>
+                  </a:schemeClr>
+                </a:gs>
+              </a:gsLst>
+              <a:lin ang="5400000" scaled="1"/>
+              <a:tileRect/>
+            </a:gradFill>
           </a:ln>
-          <a:effectLst/>
+          <a:effectLst>
+            <a:glow rad="642660">
+              <a:srgbClr val="EBF9DA">
+                <a:alpha val="4000"/>
+              </a:srgbClr>
+            </a:glow>
+            <a:outerShdw blurRad="353782" dist="38100" dir="2520000" algn="tl" rotWithShape="0">
+              <a:prstClr val="black">
+                <a:alpha val="9609"/>
+              </a:prstClr>
+            </a:outerShdw>
+            <a:softEdge rad="12700"/>
+          </a:effectLst>
         </p:spPr>
         <p:style>
           <a:lnRef idx="1">
@@ -4073,65 +4363,72 @@
       </p:sp>
       <p:sp>
         <p:nvSpPr>
-          <p:cNvPr id="4" name="TextBox 3"/>
-          <p:cNvSpPr txBox="1"/>
-          <p:nvPr/>
-        </p:nvSpPr>
-        <p:spPr>
-          <a:xfrm>
-            <a:off x="731520" y="2514600"/>
-            <a:ext cx="1188720" cy="457200"/>
-          </a:xfrm>
-          <a:prstGeom prst="rect">
-            <a:avLst/>
-          </a:prstGeom>
-          <a:noFill/>
-        </p:spPr>
-        <p:txBody>
-          <a:bodyPr wrap="none" anchor="ctr">
-            <a:spAutoFit/>
-          </a:bodyPr>
-          <a:lstStyle/>
-          <a:p>
-            <a:pPr algn="ctr">
-              <a:defRPr sz="1400" b="1">
-                <a:solidFill>
-                  <a:srgbClr val="3498DB"/>
-                </a:solidFill>
-                <a:latin typeface="Calibri"/>
-              </a:defRPr>
-            </a:pPr>
-            <a:r>
-              <a:t>Unity</a:t>
-            </a:r>
-          </a:p>
-          <a:p>
-            <a:r>
-              <a:t>Simulator</a:t>
-            </a:r>
-          </a:p>
-        </p:txBody>
-      </p:sp>
-      <p:sp>
-        <p:nvSpPr>
-          <p:cNvPr id="5" name="Right Arrow 4"/>
+          <p:cNvPr id="21" name="Rounded Rectangle 20">
+            <a:extLst>
+              <a:ext uri="{FF2B5EF4-FFF2-40B4-BE49-F238E27FC236}">
+                <a16:creationId xmlns:a16="http://schemas.microsoft.com/office/drawing/2014/main" id="{7BEE875B-1D82-F136-6EE6-F3881BF35BA8}"/>
+              </a:ext>
+            </a:extLst>
+          </p:cNvPr>
           <p:cNvSpPr/>
           <p:nvPr/>
         </p:nvSpPr>
         <p:spPr>
           <a:xfrm>
-            <a:off x="1965960" y="2697480"/>
-            <a:ext cx="320040" cy="91440"/>
-          </a:xfrm>
-          <a:prstGeom prst="rightArrow">
+            <a:off x="5463540" y="2286000"/>
+            <a:ext cx="1188720" cy="914400"/>
+          </a:xfrm>
+          <a:prstGeom prst="roundRect">
             <a:avLst/>
           </a:prstGeom>
           <a:solidFill>
-            <a:srgbClr val="E67E22"/>
+            <a:srgbClr val="F9FFEF"/>
           </a:solidFill>
-          <a:ln>
-            <a:noFill/>
+          <a:ln w="6350">
+            <a:gradFill flip="none" rotWithShape="1">
+              <a:gsLst>
+                <a:gs pos="0">
+                  <a:schemeClr val="accent1">
+                    <a:lumMod val="5000"/>
+                    <a:lumOff val="95000"/>
+                  </a:schemeClr>
+                </a:gs>
+                <a:gs pos="74000">
+                  <a:schemeClr val="accent1">
+                    <a:lumMod val="45000"/>
+                    <a:lumOff val="55000"/>
+                  </a:schemeClr>
+                </a:gs>
+                <a:gs pos="83000">
+                  <a:schemeClr val="accent1">
+                    <a:lumMod val="45000"/>
+                    <a:lumOff val="55000"/>
+                  </a:schemeClr>
+                </a:gs>
+                <a:gs pos="100000">
+                  <a:schemeClr val="accent1">
+                    <a:lumMod val="30000"/>
+                    <a:lumOff val="70000"/>
+                  </a:schemeClr>
+                </a:gs>
+              </a:gsLst>
+              <a:lin ang="5400000" scaled="1"/>
+              <a:tileRect/>
+            </a:gradFill>
           </a:ln>
+          <a:effectLst>
+            <a:glow rad="642660">
+              <a:srgbClr val="EBF9DA">
+                <a:alpha val="4000"/>
+              </a:srgbClr>
+            </a:glow>
+            <a:outerShdw blurRad="353782" dist="38100" dir="2520000" algn="tl" rotWithShape="0">
+              <a:prstClr val="black">
+                <a:alpha val="9609"/>
+              </a:prstClr>
+            </a:outerShdw>
+            <a:softEdge rad="12700"/>
+          </a:effectLst>
         </p:spPr>
         <p:style>
           <a:lnRef idx="1">
@@ -4158,27 +4455,72 @@
       </p:sp>
       <p:sp>
         <p:nvSpPr>
-          <p:cNvPr id="6" name="Rounded Rectangle 5"/>
+          <p:cNvPr id="20" name="Rounded Rectangle 19">
+            <a:extLst>
+              <a:ext uri="{FF2B5EF4-FFF2-40B4-BE49-F238E27FC236}">
+                <a16:creationId xmlns:a16="http://schemas.microsoft.com/office/drawing/2014/main" id="{7FDD2CF4-19E7-8715-B6AF-6392F014021A}"/>
+              </a:ext>
+            </a:extLst>
+          </p:cNvPr>
           <p:cNvSpPr/>
           <p:nvPr/>
         </p:nvSpPr>
         <p:spPr>
           <a:xfrm>
-            <a:off x="2103120" y="2286000"/>
+            <a:off x="3943350" y="2286000"/>
             <a:ext cx="1188720" cy="914400"/>
           </a:xfrm>
           <a:prstGeom prst="roundRect">
             <a:avLst/>
           </a:prstGeom>
           <a:solidFill>
-            <a:srgbClr val="FFFFFF"/>
+            <a:srgbClr val="F9FFEF"/>
           </a:solidFill>
           <a:ln w="6350">
-            <a:solidFill>
-              <a:srgbClr val="ECF0F1"/>
-            </a:solidFill>
+            <a:gradFill flip="none" rotWithShape="1">
+              <a:gsLst>
+                <a:gs pos="0">
+                  <a:schemeClr val="accent1">
+                    <a:lumMod val="5000"/>
+                    <a:lumOff val="95000"/>
+                  </a:schemeClr>
+                </a:gs>
+                <a:gs pos="74000">
+                  <a:schemeClr val="accent1">
+                    <a:lumMod val="45000"/>
+                    <a:lumOff val="55000"/>
+                  </a:schemeClr>
+                </a:gs>
+                <a:gs pos="83000">
+                  <a:schemeClr val="accent1">
+                    <a:lumMod val="45000"/>
+                    <a:lumOff val="55000"/>
+                  </a:schemeClr>
+                </a:gs>
+                <a:gs pos="100000">
+                  <a:schemeClr val="accent1">
+                    <a:lumMod val="30000"/>
+                    <a:lumOff val="70000"/>
+                  </a:schemeClr>
+                </a:gs>
+              </a:gsLst>
+              <a:lin ang="5400000" scaled="1"/>
+              <a:tileRect/>
+            </a:gradFill>
           </a:ln>
-          <a:effectLst/>
+          <a:effectLst>
+            <a:glow rad="642660">
+              <a:srgbClr val="EBF9DA">
+                <a:alpha val="4000"/>
+              </a:srgbClr>
+            </a:glow>
+            <a:outerShdw blurRad="353782" dist="38100" dir="2520000" algn="tl" rotWithShape="0">
+              <a:prstClr val="black">
+                <a:alpha val="9609"/>
+              </a:prstClr>
+            </a:outerShdw>
+            <a:softEdge rad="12700"/>
+          </a:effectLst>
         </p:spPr>
         <p:style>
           <a:lnRef idx="1">
@@ -4205,65 +4547,72 @@
       </p:sp>
       <p:sp>
         <p:nvSpPr>
-          <p:cNvPr id="7" name="TextBox 6"/>
-          <p:cNvSpPr txBox="1"/>
-          <p:nvPr/>
-        </p:nvSpPr>
-        <p:spPr>
-          <a:xfrm>
-            <a:off x="2103120" y="2514600"/>
-            <a:ext cx="1188720" cy="457200"/>
-          </a:xfrm>
-          <a:prstGeom prst="rect">
-            <a:avLst/>
-          </a:prstGeom>
-          <a:noFill/>
-        </p:spPr>
-        <p:txBody>
-          <a:bodyPr wrap="none" anchor="ctr">
-            <a:spAutoFit/>
-          </a:bodyPr>
-          <a:lstStyle/>
-          <a:p>
-            <a:pPr algn="ctr">
-              <a:defRPr sz="1400" b="1">
-                <a:solidFill>
-                  <a:srgbClr val="3498DB"/>
-                </a:solidFill>
-                <a:latin typeface="Calibri"/>
-              </a:defRPr>
-            </a:pPr>
-            <a:r>
-              <a:t>Analytics</a:t>
-            </a:r>
-          </a:p>
-          <a:p>
-            <a:r>
-              <a:t>Manager</a:t>
-            </a:r>
-          </a:p>
-        </p:txBody>
-      </p:sp>
-      <p:sp>
-        <p:nvSpPr>
-          <p:cNvPr id="8" name="Right Arrow 7"/>
+          <p:cNvPr id="19" name="Rounded Rectangle 18">
+            <a:extLst>
+              <a:ext uri="{FF2B5EF4-FFF2-40B4-BE49-F238E27FC236}">
+                <a16:creationId xmlns:a16="http://schemas.microsoft.com/office/drawing/2014/main" id="{36305CF9-279A-E36A-52CC-35359FFF9C26}"/>
+              </a:ext>
+            </a:extLst>
+          </p:cNvPr>
           <p:cNvSpPr/>
           <p:nvPr/>
         </p:nvSpPr>
         <p:spPr>
           <a:xfrm>
-            <a:off x="3337560" y="2697480"/>
-            <a:ext cx="320040" cy="91440"/>
-          </a:xfrm>
-          <a:prstGeom prst="rightArrow">
+            <a:off x="2457450" y="2258347"/>
+            <a:ext cx="1188720" cy="914400"/>
+          </a:xfrm>
+          <a:prstGeom prst="roundRect">
             <a:avLst/>
           </a:prstGeom>
           <a:solidFill>
-            <a:srgbClr val="E67E22"/>
+            <a:srgbClr val="F9FFEF"/>
           </a:solidFill>
-          <a:ln>
-            <a:noFill/>
+          <a:ln w="6350">
+            <a:gradFill flip="none" rotWithShape="1">
+              <a:gsLst>
+                <a:gs pos="0">
+                  <a:schemeClr val="accent1">
+                    <a:lumMod val="5000"/>
+                    <a:lumOff val="95000"/>
+                  </a:schemeClr>
+                </a:gs>
+                <a:gs pos="74000">
+                  <a:schemeClr val="accent1">
+                    <a:lumMod val="45000"/>
+                    <a:lumOff val="55000"/>
+                  </a:schemeClr>
+                </a:gs>
+                <a:gs pos="83000">
+                  <a:schemeClr val="accent1">
+                    <a:lumMod val="45000"/>
+                    <a:lumOff val="55000"/>
+                  </a:schemeClr>
+                </a:gs>
+                <a:gs pos="100000">
+                  <a:schemeClr val="accent1">
+                    <a:lumMod val="30000"/>
+                    <a:lumOff val="70000"/>
+                  </a:schemeClr>
+                </a:gs>
+              </a:gsLst>
+              <a:lin ang="5400000" scaled="1"/>
+              <a:tileRect/>
+            </a:gradFill>
           </a:ln>
+          <a:effectLst>
+            <a:glow rad="642660">
+              <a:srgbClr val="EBF9DA">
+                <a:alpha val="4000"/>
+              </a:srgbClr>
+            </a:glow>
+            <a:outerShdw blurRad="353782" dist="38100" dir="2520000" algn="tl" rotWithShape="0">
+              <a:prstClr val="black">
+                <a:alpha val="9609"/>
+              </a:prstClr>
+            </a:outerShdw>
+            <a:softEdge rad="12700"/>
+          </a:effectLst>
         </p:spPr>
         <p:style>
           <a:lnRef idx="1">
@@ -4290,27 +4639,102 @@
       </p:sp>
       <p:sp>
         <p:nvSpPr>
-          <p:cNvPr id="9" name="Rounded Rectangle 8"/>
+          <p:cNvPr id="2" name="TextBox 1"/>
+          <p:cNvSpPr txBox="1"/>
+          <p:nvPr/>
+        </p:nvSpPr>
+        <p:spPr>
+          <a:xfrm>
+            <a:off x="457200" y="457200"/>
+            <a:ext cx="8229600" cy="914400"/>
+          </a:xfrm>
+          <a:prstGeom prst="rect">
+            <a:avLst/>
+          </a:prstGeom>
+          <a:noFill/>
+        </p:spPr>
+        <p:txBody>
+          <a:bodyPr wrap="square">
+            <a:spAutoFit/>
+          </a:bodyPr>
+          <a:lstStyle/>
+          <a:p>
+            <a:pPr algn="ctr">
+              <a:defRPr sz="4000" b="1">
+                <a:solidFill>
+                  <a:srgbClr val="2C3E50"/>
+                </a:solidFill>
+                <a:latin typeface="Calibri"/>
+              </a:defRPr>
+            </a:pPr>
+            <a:r>
+              <a:t>Pipeline Architecture</a:t>
+            </a:r>
+          </a:p>
+        </p:txBody>
+      </p:sp>
+      <p:sp>
+        <p:nvSpPr>
+          <p:cNvPr id="3" name="Rounded Rectangle 2"/>
           <p:cNvSpPr/>
           <p:nvPr/>
         </p:nvSpPr>
         <p:spPr>
           <a:xfrm>
-            <a:off x="3474720" y="2286000"/>
+            <a:off x="960120" y="2286000"/>
             <a:ext cx="1188720" cy="914400"/>
           </a:xfrm>
           <a:prstGeom prst="roundRect">
             <a:avLst/>
           </a:prstGeom>
           <a:solidFill>
-            <a:srgbClr val="FFFFFF"/>
+            <a:srgbClr val="F9FFEF"/>
           </a:solidFill>
           <a:ln w="6350">
-            <a:solidFill>
-              <a:srgbClr val="ECF0F1"/>
-            </a:solidFill>
+            <a:gradFill flip="none" rotWithShape="1">
+              <a:gsLst>
+                <a:gs pos="0">
+                  <a:schemeClr val="accent1">
+                    <a:lumMod val="5000"/>
+                    <a:lumOff val="95000"/>
+                  </a:schemeClr>
+                </a:gs>
+                <a:gs pos="74000">
+                  <a:schemeClr val="accent1">
+                    <a:lumMod val="45000"/>
+                    <a:lumOff val="55000"/>
+                  </a:schemeClr>
+                </a:gs>
+                <a:gs pos="83000">
+                  <a:schemeClr val="accent1">
+                    <a:lumMod val="45000"/>
+                    <a:lumOff val="55000"/>
+                  </a:schemeClr>
+                </a:gs>
+                <a:gs pos="100000">
+                  <a:schemeClr val="accent1">
+                    <a:lumMod val="30000"/>
+                    <a:lumOff val="70000"/>
+                  </a:schemeClr>
+                </a:gs>
+              </a:gsLst>
+              <a:lin ang="5400000" scaled="1"/>
+              <a:tileRect/>
+            </a:gradFill>
           </a:ln>
-          <a:effectLst/>
+          <a:effectLst>
+            <a:glow rad="642660">
+              <a:srgbClr val="EBF9DA">
+                <a:alpha val="4000"/>
+              </a:srgbClr>
+            </a:glow>
+            <a:outerShdw blurRad="353782" dist="38100" dir="2520000" algn="tl" rotWithShape="0">
+              <a:prstClr val="black">
+                <a:alpha val="9609"/>
+              </a:prstClr>
+            </a:outerShdw>
+            <a:softEdge rad="12700"/>
+          </a:effectLst>
         </p:spPr>
         <p:style>
           <a:lnRef idx="1">
@@ -4337,14 +4761,14 @@
       </p:sp>
       <p:sp>
         <p:nvSpPr>
-          <p:cNvPr id="10" name="TextBox 9"/>
+          <p:cNvPr id="4" name="TextBox 3"/>
           <p:cNvSpPr txBox="1"/>
           <p:nvPr/>
         </p:nvSpPr>
         <p:spPr>
           <a:xfrm>
-            <a:off x="3474720" y="2514600"/>
-            <a:ext cx="1188720" cy="457200"/>
+            <a:off x="1010677" y="2450813"/>
+            <a:ext cx="1087605" cy="584775"/>
           </a:xfrm>
           <a:prstGeom prst="rect">
             <a:avLst/>
@@ -4366,25 +4790,28 @@
               </a:defRPr>
             </a:pPr>
             <a:r>
-              <a:t>PHP</a:t>
-            </a:r>
-          </a:p>
-          <a:p>
-            <a:r>
-              <a:t>Backend</a:t>
-            </a:r>
-          </a:p>
-        </p:txBody>
-      </p:sp>
-      <p:sp>
-        <p:nvSpPr>
-          <p:cNvPr id="11" name="Right Arrow 10"/>
+              <a:rPr dirty="0"/>
+              <a:t>Unity</a:t>
+            </a:r>
+          </a:p>
+          <a:p>
+            <a:pPr algn="ctr"/>
+            <a:r>
+              <a:rPr dirty="0"/>
+              <a:t>Simulator</a:t>
+            </a:r>
+          </a:p>
+        </p:txBody>
+      </p:sp>
+      <p:sp>
+        <p:nvSpPr>
+          <p:cNvPr id="5" name="Right Arrow 4"/>
           <p:cNvSpPr/>
           <p:nvPr/>
         </p:nvSpPr>
         <p:spPr>
           <a:xfrm>
-            <a:off x="4709160" y="2697480"/>
+            <a:off x="2148840" y="2697480"/>
             <a:ext cx="320040" cy="91440"/>
           </a:xfrm>
           <a:prstGeom prst="rightArrow">
@@ -4422,27 +4849,68 @@
       </p:sp>
       <p:sp>
         <p:nvSpPr>
-          <p:cNvPr id="12" name="Rounded Rectangle 11"/>
+          <p:cNvPr id="7" name="TextBox 6"/>
+          <p:cNvSpPr txBox="1"/>
+          <p:nvPr/>
+        </p:nvSpPr>
+        <p:spPr>
+          <a:xfrm>
+            <a:off x="2549477" y="2450813"/>
+            <a:ext cx="1027525" cy="584775"/>
+          </a:xfrm>
+          <a:prstGeom prst="rect">
+            <a:avLst/>
+          </a:prstGeom>
+          <a:noFill/>
+        </p:spPr>
+        <p:txBody>
+          <a:bodyPr wrap="none" anchor="ctr">
+            <a:spAutoFit/>
+          </a:bodyPr>
+          <a:lstStyle/>
+          <a:p>
+            <a:pPr algn="ctr">
+              <a:defRPr sz="1400" b="1">
+                <a:solidFill>
+                  <a:srgbClr val="3498DB"/>
+                </a:solidFill>
+                <a:latin typeface="Calibri"/>
+              </a:defRPr>
+            </a:pPr>
+            <a:r>
+              <a:rPr dirty="0"/>
+              <a:t>Analytics</a:t>
+            </a:r>
+          </a:p>
+          <a:p>
+            <a:pPr algn="ctr"/>
+            <a:r>
+              <a:rPr dirty="0"/>
+              <a:t>Manager</a:t>
+            </a:r>
+          </a:p>
+        </p:txBody>
+      </p:sp>
+      <p:sp>
+        <p:nvSpPr>
+          <p:cNvPr id="8" name="Right Arrow 7"/>
           <p:cNvSpPr/>
           <p:nvPr/>
         </p:nvSpPr>
         <p:spPr>
           <a:xfrm>
-            <a:off x="4846320" y="2286000"/>
-            <a:ext cx="1188720" cy="914400"/>
-          </a:xfrm>
-          <a:prstGeom prst="roundRect">
+            <a:off x="3623310" y="2697480"/>
+            <a:ext cx="320040" cy="91440"/>
+          </a:xfrm>
+          <a:prstGeom prst="rightArrow">
             <a:avLst/>
           </a:prstGeom>
           <a:solidFill>
-            <a:srgbClr val="FFFFFF"/>
+            <a:srgbClr val="E67E22"/>
           </a:solidFill>
-          <a:ln w="6350">
-            <a:solidFill>
-              <a:srgbClr val="ECF0F1"/>
-            </a:solidFill>
+          <a:ln>
+            <a:noFill/>
           </a:ln>
-          <a:effectLst/>
         </p:spPr>
         <p:style>
           <a:lnRef idx="1">
@@ -4469,14 +4937,14 @@
       </p:sp>
       <p:sp>
         <p:nvSpPr>
-          <p:cNvPr id="13" name="TextBox 12"/>
+          <p:cNvPr id="10" name="TextBox 9"/>
           <p:cNvSpPr txBox="1"/>
           <p:nvPr/>
         </p:nvSpPr>
         <p:spPr>
           <a:xfrm>
-            <a:off x="4846320" y="2514600"/>
-            <a:ext cx="1188720" cy="457200"/>
+            <a:off x="4050749" y="2450813"/>
+            <a:ext cx="973921" cy="584775"/>
           </a:xfrm>
           <a:prstGeom prst="rect">
             <a:avLst/>
@@ -4499,26 +4967,27 @@
             </a:pPr>
             <a:r>
               <a:rPr dirty="0"/>
-              <a:t>MySQL</a:t>
-            </a:r>
-          </a:p>
-          <a:p>
+              <a:t>PHP</a:t>
+            </a:r>
+          </a:p>
+          <a:p>
+            <a:pPr algn="ctr"/>
             <a:r>
               <a:rPr dirty="0"/>
-              <a:t>Database</a:t>
-            </a:r>
-          </a:p>
-        </p:txBody>
-      </p:sp>
-      <p:sp>
-        <p:nvSpPr>
-          <p:cNvPr id="14" name="Right Arrow 13"/>
+              <a:t>Backend</a:t>
+            </a:r>
+          </a:p>
+        </p:txBody>
+      </p:sp>
+      <p:sp>
+        <p:nvSpPr>
+          <p:cNvPr id="11" name="Right Arrow 10"/>
           <p:cNvSpPr/>
           <p:nvPr/>
         </p:nvSpPr>
         <p:spPr>
           <a:xfrm>
-            <a:off x="6080760" y="2697480"/>
+            <a:off x="5109210" y="2743200"/>
             <a:ext cx="320040" cy="91440"/>
           </a:xfrm>
           <a:prstGeom prst="rightArrow">
@@ -4556,27 +5025,68 @@
       </p:sp>
       <p:sp>
         <p:nvSpPr>
-          <p:cNvPr id="15" name="Rounded Rectangle 14"/>
+          <p:cNvPr id="13" name="TextBox 12"/>
+          <p:cNvSpPr txBox="1"/>
+          <p:nvPr/>
+        </p:nvSpPr>
+        <p:spPr>
+          <a:xfrm>
+            <a:off x="5463540" y="2514600"/>
+            <a:ext cx="1188720" cy="584775"/>
+          </a:xfrm>
+          <a:prstGeom prst="rect">
+            <a:avLst/>
+          </a:prstGeom>
+          <a:noFill/>
+        </p:spPr>
+        <p:txBody>
+          <a:bodyPr wrap="square" anchor="ctr">
+            <a:spAutoFit/>
+          </a:bodyPr>
+          <a:lstStyle/>
+          <a:p>
+            <a:pPr algn="ctr">
+              <a:defRPr sz="1400" b="1">
+                <a:solidFill>
+                  <a:srgbClr val="3498DB"/>
+                </a:solidFill>
+                <a:latin typeface="Calibri"/>
+              </a:defRPr>
+            </a:pPr>
+            <a:r>
+              <a:rPr dirty="0"/>
+              <a:t>MySQL</a:t>
+            </a:r>
+          </a:p>
+          <a:p>
+            <a:pPr algn="ctr"/>
+            <a:r>
+              <a:rPr dirty="0"/>
+              <a:t>Database</a:t>
+            </a:r>
+          </a:p>
+        </p:txBody>
+      </p:sp>
+      <p:sp>
+        <p:nvSpPr>
+          <p:cNvPr id="14" name="Right Arrow 13"/>
           <p:cNvSpPr/>
           <p:nvPr/>
         </p:nvSpPr>
         <p:spPr>
           <a:xfrm>
-            <a:off x="6217920" y="2286000"/>
-            <a:ext cx="1188720" cy="914400"/>
-          </a:xfrm>
-          <a:prstGeom prst="roundRect">
+            <a:off x="6675120" y="2715547"/>
+            <a:ext cx="320040" cy="91440"/>
+          </a:xfrm>
+          <a:prstGeom prst="rightArrow">
             <a:avLst/>
           </a:prstGeom>
           <a:solidFill>
-            <a:srgbClr val="FFFFFF"/>
+            <a:srgbClr val="E67E22"/>
           </a:solidFill>
-          <a:ln w="6350">
-            <a:solidFill>
-              <a:srgbClr val="ECF0F1"/>
-            </a:solidFill>
+          <a:ln>
+            <a:noFill/>
           </a:ln>
-          <a:effectLst/>
         </p:spPr>
         <p:style>
           <a:lnRef idx="1">
@@ -4609,8 +5119,8 @@
         </p:nvSpPr>
         <p:spPr>
           <a:xfrm>
-            <a:off x="6217920" y="2514600"/>
-            <a:ext cx="1188720" cy="457200"/>
+            <a:off x="7166458" y="2450813"/>
+            <a:ext cx="937564" cy="584775"/>
           </a:xfrm>
           <a:prstGeom prst="rect">
             <a:avLst/>
@@ -4632,11 +5142,14 @@
               </a:defRPr>
             </a:pPr>
             <a:r>
+              <a:rPr dirty="0"/>
               <a:t>R</a:t>
             </a:r>
           </a:p>
           <a:p>
-            <a:r>
+            <a:pPr algn="ctr"/>
+            <a:r>
+              <a:rPr dirty="0"/>
               <a:t>Analysis</a:t>
             </a:r>
           </a:p>
@@ -4679,6 +5192,7 @@
               </a:defRPr>
             </a:pPr>
             <a:r>
+              <a:rPr dirty="0"/>
               <a:t>Non-intrusive event subscription</a:t>
             </a:r>
           </a:p>
@@ -4698,6 +5212,7 @@
               </a:defRPr>
             </a:pPr>
             <a:r>
+              <a:rPr dirty="0"/>
               <a:t>Async coroutines (Unity → PHP)</a:t>
             </a:r>
           </a:p>
@@ -4717,6 +5232,7 @@
               </a:defRPr>
             </a:pPr>
             <a:r>
+              <a:rPr dirty="0"/>
               <a:t>Prepared statements (SQL injection prevention)</a:t>
             </a:r>
           </a:p>
@@ -4736,6 +5252,7 @@
               </a:defRPr>
             </a:pPr>
             <a:r>
+              <a:rPr dirty="0"/>
               <a:t>Normalized database schema</a:t>
             </a:r>
           </a:p>
@@ -4788,22 +5305,6 @@
 <file path=ppt/slides/slide3.xml><?xml version="1.0" encoding="utf-8"?>
 <p:sld xmlns:a="http://schemas.openxmlformats.org/drawingml/2006/main" xmlns:r="http://schemas.openxmlformats.org/officeDocument/2006/relationships" xmlns:p="http://schemas.openxmlformats.org/presentationml/2006/main">
   <p:cSld>
-    <p:bg>
-      <p:bgPr>
-        <a:gradFill rotWithShape="1">
-          <a:gsLst>
-            <a:gs pos="0">
-              <a:srgbClr val="FFFFFF"/>
-            </a:gs>
-            <a:gs pos="100000">
-              <a:srgbClr val="F8F9FA"/>
-            </a:gs>
-          </a:gsLst>
-          <a:lin ang="18900000" scaled="0"/>
-        </a:gradFill>
-        <a:effectLst/>
-      </p:bgPr>
-    </p:bg>
     <p:spTree>
       <p:nvGrpSpPr>
         <p:cNvPr id="1" name=""/>
@@ -4849,6 +5350,7 @@
               </a:defRPr>
             </a:pPr>
             <a:r>
+              <a:rPr dirty="0"/>
               <a:t>Database Design</a:t>
             </a:r>
           </a:p>
@@ -4862,7 +5364,7 @@
         </p:nvSpPr>
         <p:spPr>
           <a:xfrm>
-            <a:off x="1371600" y="2011680"/>
+            <a:off x="1371600" y="1819025"/>
             <a:ext cx="2743200" cy="1508760"/>
           </a:xfrm>
           <a:prstGeom prst="roundRect">
@@ -4876,7 +5378,21 @@
               <a:srgbClr val="ECF0F1"/>
             </a:solidFill>
           </a:ln>
-          <a:effectLst/>
+          <a:effectLst>
+            <a:glow rad="919951">
+              <a:schemeClr val="accent6">
+                <a:lumMod val="20000"/>
+                <a:lumOff val="80000"/>
+                <a:alpha val="5000"/>
+              </a:schemeClr>
+            </a:glow>
+            <a:outerShdw blurRad="1003435" dist="38100" dir="2700000" algn="tl" rotWithShape="0">
+              <a:prstClr val="black">
+                <a:alpha val="7000"/>
+              </a:prstClr>
+            </a:outerShdw>
+            <a:softEdge rad="0"/>
+          </a:effectLst>
         </p:spPr>
         <p:style>
           <a:lnRef idx="1">
@@ -4909,7 +5425,7 @@
         </p:nvSpPr>
         <p:spPr>
           <a:xfrm>
-            <a:off x="1371600" y="2084832"/>
+            <a:off x="1371600" y="1799476"/>
             <a:ext cx="2743200" cy="274320"/>
           </a:xfrm>
           <a:prstGeom prst="rect">
@@ -4932,6 +5448,7 @@
               </a:defRPr>
             </a:pPr>
             <a:r>
+              <a:rPr dirty="0"/>
               <a:t>users</a:t>
             </a:r>
           </a:p>
@@ -4945,8 +5462,8 @@
         </p:nvSpPr>
         <p:spPr>
           <a:xfrm>
-            <a:off x="1508760" y="2423160"/>
-            <a:ext cx="2468880" cy="1051560"/>
+            <a:off x="1508760" y="2107936"/>
+            <a:ext cx="1765227" cy="1200329"/>
           </a:xfrm>
           <a:prstGeom prst="rect">
             <a:avLst/>
@@ -5028,9 +5545,29 @@
               </a:defRPr>
             </a:pPr>
             <a:r>
+              <a:rPr lang="en-US" dirty="0"/>
+              <a:t>g</a:t>
+            </a:r>
+            <a:r>
               <a:rPr dirty="0"/>
-              <a:t>gender</a:t>
-            </a:r>
+              <a:t>ender</a:t>
+            </a:r>
+            <a:endParaRPr lang="en-US" dirty="0"/>
+          </a:p>
+          <a:p>
+            <a:pPr>
+              <a:defRPr sz="1200">
+                <a:solidFill>
+                  <a:srgbClr val="212121"/>
+                </a:solidFill>
+                <a:latin typeface="Courier New"/>
+              </a:defRPr>
+            </a:pPr>
+            <a:r>
+              <a:rPr lang="en-US" dirty="0"/>
+              <a:t>registration_date</a:t>
+            </a:r>
+            <a:endParaRPr dirty="0"/>
           </a:p>
         </p:txBody>
       </p:sp>
@@ -5042,8 +5579,8 @@
         </p:nvSpPr>
         <p:spPr>
           <a:xfrm>
-            <a:off x="5029200" y="2011680"/>
-            <a:ext cx="2743200" cy="1280160"/>
+            <a:off x="5029200" y="1819025"/>
+            <a:ext cx="2743200" cy="1508760"/>
           </a:xfrm>
           <a:prstGeom prst="roundRect">
             <a:avLst/>
@@ -5056,7 +5593,20 @@
               <a:srgbClr val="ECF0F1"/>
             </a:solidFill>
           </a:ln>
-          <a:effectLst/>
+          <a:effectLst>
+            <a:glow rad="820539">
+              <a:schemeClr val="accent6">
+                <a:lumMod val="20000"/>
+                <a:lumOff val="80000"/>
+                <a:alpha val="6000"/>
+              </a:schemeClr>
+            </a:glow>
+            <a:outerShdw blurRad="1058925" dist="38100" dir="2700000" algn="tl" rotWithShape="0">
+              <a:prstClr val="black">
+                <a:alpha val="7000"/>
+              </a:prstClr>
+            </a:outerShdw>
+          </a:effectLst>
         </p:spPr>
         <p:style>
           <a:lnRef idx="1">
@@ -5089,7 +5639,7 @@
         </p:nvSpPr>
         <p:spPr>
           <a:xfrm>
-            <a:off x="5029200" y="2084832"/>
+            <a:off x="5029200" y="1804855"/>
             <a:ext cx="2743200" cy="274320"/>
           </a:xfrm>
           <a:prstGeom prst="rect">
@@ -5112,6 +5662,7 @@
               </a:defRPr>
             </a:pPr>
             <a:r>
+              <a:rPr dirty="0"/>
               <a:t>sessions</a:t>
             </a:r>
           </a:p>
@@ -5125,7 +5676,7 @@
         </p:nvSpPr>
         <p:spPr>
           <a:xfrm>
-            <a:off x="5166360" y="2423160"/>
+            <a:off x="5166360" y="2107936"/>
             <a:ext cx="2468880" cy="822960"/>
           </a:xfrm>
           <a:prstGeom prst="rect">
@@ -5148,7 +5699,12 @@
               </a:defRPr>
             </a:pPr>
             <a:r>
-              <a:t>session_id (PK)</a:t>
+              <a:rPr dirty="0" err="1"/>
+              <a:t>session_id</a:t>
+            </a:r>
+            <a:r>
+              <a:rPr dirty="0"/>
+              <a:t> (PK)</a:t>
             </a:r>
           </a:p>
           <a:p>
@@ -5161,7 +5717,12 @@
               </a:defRPr>
             </a:pPr>
             <a:r>
-              <a:t>user_id (FK)</a:t>
+              <a:rPr dirty="0" err="1"/>
+              <a:t>user_id</a:t>
+            </a:r>
+            <a:r>
+              <a:rPr dirty="0"/>
+              <a:t> (FK)</a:t>
             </a:r>
           </a:p>
           <a:p>
@@ -5174,8 +5735,10 @@
               </a:defRPr>
             </a:pPr>
             <a:r>
+              <a:rPr dirty="0" err="1"/>
               <a:t>start_time</a:t>
             </a:r>
+            <a:endParaRPr dirty="0"/>
           </a:p>
           <a:p>
             <a:pPr>
@@ -5187,8 +5750,10 @@
               </a:defRPr>
             </a:pPr>
             <a:r>
+              <a:rPr dirty="0" err="1"/>
               <a:t>end_time</a:t>
             </a:r>
+            <a:endParaRPr dirty="0"/>
           </a:p>
         </p:txBody>
       </p:sp>
@@ -5200,7 +5765,7 @@
         </p:nvSpPr>
         <p:spPr>
           <a:xfrm>
-            <a:off x="1371600" y="4114800"/>
+            <a:off x="1371600" y="3922145"/>
             <a:ext cx="2743200" cy="1280160"/>
           </a:xfrm>
           <a:prstGeom prst="roundRect">
@@ -5214,7 +5779,20 @@
               <a:srgbClr val="ECF0F1"/>
             </a:solidFill>
           </a:ln>
-          <a:effectLst/>
+          <a:effectLst>
+            <a:glow rad="635000">
+              <a:schemeClr val="accent6">
+                <a:lumMod val="20000"/>
+                <a:lumOff val="80000"/>
+                <a:alpha val="5000"/>
+              </a:schemeClr>
+            </a:glow>
+            <a:outerShdw blurRad="1138143" dist="38100" dir="2700000" algn="tl" rotWithShape="0">
+              <a:prstClr val="black">
+                <a:alpha val="9000"/>
+              </a:prstClr>
+            </a:outerShdw>
+          </a:effectLst>
         </p:spPr>
         <p:style>
           <a:lnRef idx="1">
@@ -5247,7 +5825,7 @@
         </p:nvSpPr>
         <p:spPr>
           <a:xfrm>
-            <a:off x="1371600" y="4187952"/>
+            <a:off x="1371600" y="3922145"/>
             <a:ext cx="2743200" cy="274320"/>
           </a:xfrm>
           <a:prstGeom prst="rect">
@@ -5283,8 +5861,8 @@
         </p:nvSpPr>
         <p:spPr>
           <a:xfrm>
-            <a:off x="1508760" y="4526280"/>
-            <a:ext cx="2468880" cy="822960"/>
+            <a:off x="1508760" y="4170301"/>
+            <a:ext cx="1672253" cy="1015663"/>
           </a:xfrm>
           <a:prstGeom prst="rect">
             <a:avLst/>
@@ -5306,6 +5884,7 @@
               </a:defRPr>
             </a:pPr>
             <a:r>
+              <a:rPr dirty="0"/>
               <a:t>purchase_id (PK)</a:t>
             </a:r>
           </a:p>
@@ -5319,6 +5898,7 @@
               </a:defRPr>
             </a:pPr>
             <a:r>
+              <a:rPr dirty="0"/>
               <a:t>user_id (FK)</a:t>
             </a:r>
           </a:p>
@@ -5332,6 +5912,7 @@
               </a:defRPr>
             </a:pPr>
             <a:r>
+              <a:rPr dirty="0"/>
               <a:t>item_id (FK)</a:t>
             </a:r>
           </a:p>
@@ -5345,8 +5926,24 @@
               </a:defRPr>
             </a:pPr>
             <a:r>
+              <a:rPr lang="en-US" dirty="0"/>
               <a:t>amount</a:t>
             </a:r>
+          </a:p>
+          <a:p>
+            <a:pPr>
+              <a:defRPr sz="1200">
+                <a:solidFill>
+                  <a:srgbClr val="212121"/>
+                </a:solidFill>
+                <a:latin typeface="Courier New"/>
+              </a:defRPr>
+            </a:pPr>
+            <a:r>
+              <a:rPr lang="en-US" dirty="0"/>
+              <a:t>purchase_date</a:t>
+            </a:r>
+            <a:endParaRPr dirty="0"/>
           </a:p>
         </p:txBody>
       </p:sp>
@@ -5358,7 +5955,7 @@
         </p:nvSpPr>
         <p:spPr>
           <a:xfrm>
-            <a:off x="5029200" y="4114800"/>
+            <a:off x="5029200" y="3922145"/>
             <a:ext cx="2743200" cy="1280160"/>
           </a:xfrm>
           <a:prstGeom prst="roundRect">
@@ -5372,7 +5969,20 @@
               <a:srgbClr val="ECF0F1"/>
             </a:solidFill>
           </a:ln>
-          <a:effectLst/>
+          <a:effectLst>
+            <a:glow rad="635000">
+              <a:schemeClr val="accent6">
+                <a:lumMod val="20000"/>
+                <a:lumOff val="80000"/>
+                <a:alpha val="5000"/>
+              </a:schemeClr>
+            </a:glow>
+            <a:outerShdw blurRad="1030412" dist="38100" dir="2700000" algn="tl" rotWithShape="0">
+              <a:prstClr val="black">
+                <a:alpha val="7000"/>
+              </a:prstClr>
+            </a:outerShdw>
+          </a:effectLst>
         </p:spPr>
         <p:style>
           <a:lnRef idx="1">
@@ -5405,7 +6015,7 @@
         </p:nvSpPr>
         <p:spPr>
           <a:xfrm>
-            <a:off x="5029200" y="4187952"/>
+            <a:off x="5029200" y="3922145"/>
             <a:ext cx="2743200" cy="274320"/>
           </a:xfrm>
           <a:prstGeom prst="rect">
@@ -5428,6 +6038,7 @@
               </a:defRPr>
             </a:pPr>
             <a:r>
+              <a:rPr dirty="0"/>
               <a:t>items</a:t>
             </a:r>
           </a:p>
@@ -5441,7 +6052,7 @@
         </p:nvSpPr>
         <p:spPr>
           <a:xfrm>
-            <a:off x="5166360" y="4526280"/>
+            <a:off x="5166360" y="4222636"/>
             <a:ext cx="2468880" cy="822960"/>
           </a:xfrm>
           <a:prstGeom prst="rect">
@@ -5464,7 +6075,12 @@
               </a:defRPr>
             </a:pPr>
             <a:r>
-              <a:t>item_id (PK)</a:t>
+              <a:rPr dirty="0" err="1"/>
+              <a:t>item_id</a:t>
+            </a:r>
+            <a:r>
+              <a:rPr dirty="0"/>
+              <a:t> (PK)</a:t>
             </a:r>
           </a:p>
           <a:p>
@@ -5477,8 +6093,10 @@
               </a:defRPr>
             </a:pPr>
             <a:r>
+              <a:rPr dirty="0" err="1"/>
               <a:t>item_name</a:t>
             </a:r>
+            <a:endParaRPr dirty="0"/>
           </a:p>
           <a:p>
             <a:pPr>
@@ -5490,6 +6108,7 @@
               </a:defRPr>
             </a:pPr>
             <a:r>
+              <a:rPr dirty="0"/>
               <a:t>price</a:t>
             </a:r>
           </a:p>
@@ -5503,6 +6122,7 @@
               </a:defRPr>
             </a:pPr>
             <a:r>
+              <a:rPr dirty="0"/>
               <a:t>category</a:t>
             </a:r>
           </a:p>
@@ -5530,7 +6150,13 @@
               <a:srgbClr val="ECF0F1"/>
             </a:solidFill>
           </a:ln>
-          <a:effectLst/>
+          <a:effectLst>
+            <a:outerShdw blurRad="363631" dist="38100" dir="2700000" algn="tl" rotWithShape="0">
+              <a:prstClr val="black">
+                <a:alpha val="10422"/>
+              </a:prstClr>
+            </a:outerShdw>
+          </a:effectLst>
         </p:spPr>
         <p:style>
           <a:lnRef idx="1">
@@ -5564,7 +6190,7 @@
         <p:spPr>
           <a:xfrm>
             <a:off x="1371600" y="5760720"/>
-            <a:ext cx="6400800" cy="457200"/>
+            <a:ext cx="6400800" cy="400110"/>
           </a:xfrm>
           <a:prstGeom prst="rect">
             <a:avLst/>
@@ -5586,7 +6212,16 @@
               </a:defRPr>
             </a:pPr>
             <a:r>
-              <a:t>4 Tables | 3 Foreign Keys | 5 Indexes | 99.99% Data Quality</a:t>
+              <a:rPr dirty="0"/>
+              <a:t>4 Tables | 3 Foreign Keys | </a:t>
+            </a:r>
+            <a:r>
+              <a:rPr lang="en-US" dirty="0"/>
+              <a:t>4 - </a:t>
+            </a:r>
+            <a:r>
+              <a:rPr dirty="0"/>
+              <a:t>5 Indexes </a:t>
             </a:r>
           </a:p>
         </p:txBody>
@@ -5638,22 +6273,6 @@
 <file path=ppt/slides/slide4.xml><?xml version="1.0" encoding="utf-8"?>
 <p:sld xmlns:a="http://schemas.openxmlformats.org/drawingml/2006/main" xmlns:r="http://schemas.openxmlformats.org/officeDocument/2006/relationships" xmlns:p="http://schemas.openxmlformats.org/presentationml/2006/main">
   <p:cSld>
-    <p:bg>
-      <p:bgPr>
-        <a:gradFill rotWithShape="1">
-          <a:gsLst>
-            <a:gs pos="0">
-              <a:srgbClr val="FFFFFF"/>
-            </a:gs>
-            <a:gs pos="100000">
-              <a:srgbClr val="F8F9FA"/>
-            </a:gs>
-          </a:gsLst>
-          <a:lin ang="18900000" scaled="0"/>
-        </a:gradFill>
-        <a:effectLst/>
-      </p:bgPr>
-    </p:bg>
     <p:spTree>
       <p:nvGrpSpPr>
         <p:cNvPr id="1" name=""/>
@@ -5677,7 +6296,7 @@
         <p:spPr>
           <a:xfrm>
             <a:off x="457200" y="457200"/>
-            <a:ext cx="8229600" cy="914400"/>
+            <a:ext cx="8229600" cy="707886"/>
           </a:xfrm>
           <a:prstGeom prst="rect">
             <a:avLst/>
@@ -5699,7 +6318,8 @@
               </a:defRPr>
             </a:pPr>
             <a:r>
-              <a:t>Data Quality Metrics</a:t>
+              <a:rPr dirty="0"/>
+              <a:t>Data Quality</a:t>
             </a:r>
           </a:p>
         </p:txBody>
@@ -5712,7 +6332,7 @@
         </p:nvSpPr>
         <p:spPr>
           <a:xfrm>
-            <a:off x="914400" y="1828800"/>
+            <a:off x="1185862" y="1828800"/>
             <a:ext cx="1828800" cy="1645920"/>
           </a:xfrm>
           <a:prstGeom prst="roundRect">
@@ -5759,7 +6379,7 @@
         </p:nvSpPr>
         <p:spPr>
           <a:xfrm>
-            <a:off x="914400" y="2103120"/>
+            <a:off x="1185862" y="2103120"/>
             <a:ext cx="1828800" cy="731520"/>
           </a:xfrm>
           <a:prstGeom prst="rect">
@@ -5782,6 +6402,7 @@
               </a:defRPr>
             </a:pPr>
             <a:r>
+              <a:rPr dirty="0"/>
               <a:t>1,007</a:t>
             </a:r>
           </a:p>
@@ -5795,7 +6416,7 @@
         </p:nvSpPr>
         <p:spPr>
           <a:xfrm>
-            <a:off x="914400" y="2926080"/>
+            <a:off x="1185862" y="2926080"/>
             <a:ext cx="1828800" cy="365760"/>
           </a:xfrm>
           <a:prstGeom prst="rect">
@@ -5818,6 +6439,7 @@
               </a:defRPr>
             </a:pPr>
             <a:r>
+              <a:rPr dirty="0"/>
               <a:t>Total Users</a:t>
             </a:r>
           </a:p>
@@ -5831,7 +6453,7 @@
         </p:nvSpPr>
         <p:spPr>
           <a:xfrm>
-            <a:off x="3017520" y="1828800"/>
+            <a:off x="3657600" y="1828800"/>
             <a:ext cx="1828800" cy="1645920"/>
           </a:xfrm>
           <a:prstGeom prst="roundRect">
@@ -5878,7 +6500,7 @@
         </p:nvSpPr>
         <p:spPr>
           <a:xfrm>
-            <a:off x="3017520" y="2103120"/>
+            <a:off x="3657600" y="2103120"/>
             <a:ext cx="1828800" cy="731520"/>
           </a:xfrm>
           <a:prstGeom prst="rect">
@@ -5901,6 +6523,7 @@
               </a:defRPr>
             </a:pPr>
             <a:r>
+              <a:rPr dirty="0"/>
               <a:t>12,611</a:t>
             </a:r>
           </a:p>
@@ -5914,7 +6537,7 @@
         </p:nvSpPr>
         <p:spPr>
           <a:xfrm>
-            <a:off x="3017520" y="2926080"/>
+            <a:off x="3657600" y="2926080"/>
             <a:ext cx="1828800" cy="365760"/>
           </a:xfrm>
           <a:prstGeom prst="rect">
@@ -5937,6 +6560,7 @@
               </a:defRPr>
             </a:pPr>
             <a:r>
+              <a:rPr dirty="0"/>
               <a:t>Total Sessions</a:t>
             </a:r>
           </a:p>
@@ -5950,7 +6574,7 @@
         </p:nvSpPr>
         <p:spPr>
           <a:xfrm>
-            <a:off x="5120640" y="1828800"/>
+            <a:off x="5943600" y="1811655"/>
             <a:ext cx="1828800" cy="1645920"/>
           </a:xfrm>
           <a:prstGeom prst="roundRect">
@@ -5997,7 +6621,7 @@
         </p:nvSpPr>
         <p:spPr>
           <a:xfrm>
-            <a:off x="5120640" y="2103120"/>
+            <a:off x="5943600" y="2085975"/>
             <a:ext cx="1828800" cy="731520"/>
           </a:xfrm>
           <a:prstGeom prst="rect">
@@ -6033,7 +6657,7 @@
         </p:nvSpPr>
         <p:spPr>
           <a:xfrm>
-            <a:off x="5120640" y="2926080"/>
+            <a:off x="5943600" y="2908935"/>
             <a:ext cx="1828800" cy="365760"/>
           </a:xfrm>
           <a:prstGeom prst="rect">
@@ -6092,6 +6716,7 @@
               </a:defRPr>
             </a:pPr>
             <a:r>
+              <a:rPr dirty="0"/>
               <a:t>364 days coverage  |  51 countries  |  Zero orphaned records</a:t>
             </a:r>
           </a:p>
@@ -6134,8 +6759,10 @@
               </a:defRPr>
             </a:pPr>
             <a:r>
+              <a:rPr dirty="0"/>
               <a:t>Full Year 2022 - Complete temporal coverage</a:t>
             </a:r>
+            <a:endParaRPr lang="en-US" dirty="0"/>
           </a:p>
           <a:p>
             <a:pPr>
@@ -6153,7 +6780,8 @@
               </a:defRPr>
             </a:pPr>
             <a:r>
-              <a:t>5/5 Data Quality Score - Perfect referential integrity</a:t>
+              <a:rPr lang="en-US" dirty="0"/>
+              <a:t>Data Quality - referential integrity</a:t>
             </a:r>
           </a:p>
           <a:p>
@@ -6172,6 +6800,7 @@
               </a:defRPr>
             </a:pPr>
             <a:r>
+              <a:rPr dirty="0"/>
               <a:t>99.99% Complete Sessions - Robust data collection</a:t>
             </a:r>
           </a:p>
@@ -6191,6 +6820,7 @@
               </a:defRPr>
             </a:pPr>
             <a:r>
+              <a:rPr dirty="0"/>
               <a:t>Global Reach - 51 countries represented</a:t>
             </a:r>
           </a:p>
@@ -6243,22 +6873,6 @@
 <file path=ppt/slides/slide5.xml><?xml version="1.0" encoding="utf-8"?>
 <p:sld xmlns:a="http://schemas.openxmlformats.org/drawingml/2006/main" xmlns:r="http://schemas.openxmlformats.org/officeDocument/2006/relationships" xmlns:p="http://schemas.openxmlformats.org/presentationml/2006/main">
   <p:cSld>
-    <p:bg>
-      <p:bgPr>
-        <a:gradFill rotWithShape="1">
-          <a:gsLst>
-            <a:gs pos="0">
-              <a:srgbClr val="FFFFFF"/>
-            </a:gs>
-            <a:gs pos="100000">
-              <a:srgbClr val="F8F9FA"/>
-            </a:gs>
-          </a:gsLst>
-          <a:lin ang="18900000" scaled="0"/>
-        </a:gradFill>
-        <a:effectLst/>
-      </p:bgPr>
-    </p:bg>
     <p:spTree>
       <p:nvGrpSpPr>
         <p:cNvPr id="1" name=""/>
@@ -6388,7 +7002,7 @@
         </p:nvSpPr>
         <p:spPr>
           <a:xfrm>
-            <a:off x="6492240" y="1920240"/>
+            <a:off x="6492240" y="1641455"/>
             <a:ext cx="2194560" cy="731520"/>
           </a:xfrm>
           <a:prstGeom prst="rect">
@@ -6411,6 +7025,7 @@
               </a:defRPr>
             </a:pPr>
             <a:r>
+              <a:rPr dirty="0"/>
               <a:t>9.1</a:t>
             </a:r>
           </a:p>
@@ -6424,7 +7039,7 @@
         </p:nvSpPr>
         <p:spPr>
           <a:xfrm>
-            <a:off x="7072166" y="2449286"/>
+            <a:off x="7072166" y="2170501"/>
             <a:ext cx="1034707" cy="584775"/>
           </a:xfrm>
           <a:prstGeom prst="rect">
@@ -6519,7 +7134,7 @@
         </p:nvSpPr>
         <p:spPr>
           <a:xfrm>
-            <a:off x="6492240" y="3383280"/>
+            <a:off x="6492240" y="3104495"/>
             <a:ext cx="2194560" cy="731520"/>
           </a:xfrm>
           <a:prstGeom prst="rect">
@@ -6542,6 +7157,7 @@
               </a:defRPr>
             </a:pPr>
             <a:r>
+              <a:rPr dirty="0"/>
               <a:t>88.8</a:t>
             </a:r>
           </a:p>
@@ -6555,7 +7171,7 @@
         </p:nvSpPr>
         <p:spPr>
           <a:xfrm>
-            <a:off x="6929724" y="3931920"/>
+            <a:off x="6929723" y="3656073"/>
             <a:ext cx="1319592" cy="584775"/>
           </a:xfrm>
           <a:prstGeom prst="rect">
@@ -6650,7 +7266,7 @@
         </p:nvSpPr>
         <p:spPr>
           <a:xfrm>
-            <a:off x="6492240" y="4846320"/>
+            <a:off x="6492240" y="4638913"/>
             <a:ext cx="2194560" cy="731520"/>
           </a:xfrm>
           <a:prstGeom prst="rect">
@@ -6673,6 +7289,7 @@
               </a:defRPr>
             </a:pPr>
             <a:r>
+              <a:rPr dirty="0"/>
               <a:t>10.2%</a:t>
             </a:r>
           </a:p>
@@ -6686,8 +7303,8 @@
         </p:nvSpPr>
         <p:spPr>
           <a:xfrm>
-            <a:off x="7142923" y="5486400"/>
-            <a:ext cx="893193" cy="584775"/>
+            <a:off x="6916484" y="5212080"/>
+            <a:ext cx="1313116" cy="307777"/>
           </a:xfrm>
           <a:prstGeom prst="rect">
             <a:avLst/>
@@ -6712,13 +7329,11 @@
               <a:rPr dirty="0"/>
               <a:t>Stickiness</a:t>
             </a:r>
-          </a:p>
-          <a:p>
-            <a:pPr algn="ctr"/>
-            <a:r>
-              <a:rPr dirty="0"/>
-              <a:t>Ratio</a:t>
-            </a:r>
+            <a:r>
+              <a:rPr lang="en-US" dirty="0"/>
+              <a:t> Ratio</a:t>
+            </a:r>
+            <a:endParaRPr dirty="0"/>
           </a:p>
         </p:txBody>
       </p:sp>
@@ -6753,6 +7368,7 @@
               </a:defRPr>
             </a:pPr>
             <a:r>
+              <a:rPr dirty="0"/>
               <a:t>Stable engagement with 12.5 sessions per user throughout 2022</a:t>
             </a:r>
           </a:p>
@@ -6790,6 +7406,41 @@
             </a:pPr>
             <a:r>
               <a:t>5/10</a:t>
+            </a:r>
+          </a:p>
+        </p:txBody>
+      </p:sp>
+      <p:sp>
+        <p:nvSpPr>
+          <p:cNvPr id="15" name="TextBox 14">
+            <a:extLst>
+              <a:ext uri="{FF2B5EF4-FFF2-40B4-BE49-F238E27FC236}">
+                <a16:creationId xmlns:a16="http://schemas.microsoft.com/office/drawing/2014/main" id="{79B27733-A43C-56A9-A46F-6C941005CF95}"/>
+              </a:ext>
+            </a:extLst>
+          </p:cNvPr>
+          <p:cNvSpPr txBox="1"/>
+          <p:nvPr/>
+        </p:nvSpPr>
+        <p:spPr>
+          <a:xfrm>
+            <a:off x="890111" y="5320022"/>
+            <a:ext cx="4986338" cy="369332"/>
+          </a:xfrm>
+          <a:prstGeom prst="rect">
+            <a:avLst/>
+          </a:prstGeom>
+          <a:noFill/>
+        </p:spPr>
+        <p:txBody>
+          <a:bodyPr wrap="square" rtlCol="0">
+            <a:spAutoFit/>
+          </a:bodyPr>
+          <a:lstStyle/>
+          <a:p>
+            <a:r>
+              <a:rPr lang="en-US" dirty="0"/>
+              <a:t>Significant Surge Since July 2022</a:t>
             </a:r>
           </a:p>
         </p:txBody>
@@ -6805,22 +7456,6 @@
 <file path=ppt/slides/slide6.xml><?xml version="1.0" encoding="utf-8"?>
 <p:sld xmlns:a="http://schemas.openxmlformats.org/drawingml/2006/main" xmlns:r="http://schemas.openxmlformats.org/officeDocument/2006/relationships" xmlns:p="http://schemas.openxmlformats.org/presentationml/2006/main">
   <p:cSld>
-    <p:bg>
-      <p:bgPr>
-        <a:gradFill rotWithShape="1">
-          <a:gsLst>
-            <a:gs pos="0">
-              <a:srgbClr val="FFFFFF"/>
-            </a:gs>
-            <a:gs pos="100000">
-              <a:srgbClr val="F8F9FA"/>
-            </a:gs>
-          </a:gsLst>
-          <a:lin ang="18900000" scaled="0"/>
-        </a:gradFill>
-        <a:effectLst/>
-      </p:bgPr>
-    </p:bg>
     <p:spTree>
       <p:nvGrpSpPr>
         <p:cNvPr id="1" name=""/>
@@ -6866,8 +7501,14 @@
               </a:defRPr>
             </a:pPr>
             <a:r>
-              <a:t>Retention Excellence</a:t>
-            </a:r>
+              <a:rPr dirty="0"/>
+              <a:t>Excellen</a:t>
+            </a:r>
+            <a:r>
+              <a:rPr lang="en-US" dirty="0"/>
+              <a:t>t Retention</a:t>
+            </a:r>
+            <a:endParaRPr dirty="0"/>
           </a:p>
         </p:txBody>
       </p:sp>
@@ -6893,7 +7534,20 @@
               <a:srgbClr val="ECF0F1"/>
             </a:solidFill>
           </a:ln>
-          <a:effectLst/>
+          <a:effectLst>
+            <a:glow rad="531624">
+              <a:schemeClr val="accent3">
+                <a:lumMod val="60000"/>
+                <a:lumOff val="40000"/>
+                <a:alpha val="5905"/>
+              </a:schemeClr>
+            </a:glow>
+            <a:outerShdw blurRad="202427" dist="38100" dir="2700000" algn="tl" rotWithShape="0">
+              <a:prstClr val="black">
+                <a:alpha val="20592"/>
+              </a:prstClr>
+            </a:outerShdw>
+          </a:effectLst>
         </p:spPr>
         <p:style>
           <a:lnRef idx="1">
@@ -6933,6 +7587,11 @@
             <a:avLst/>
           </a:prstGeom>
           <a:noFill/>
+          <a:effectLst>
+            <a:glow rad="127000">
+              <a:schemeClr val="bg1"/>
+            </a:glow>
+          </a:effectLst>
         </p:spPr>
         <p:txBody>
           <a:bodyPr wrap="square">
@@ -7063,22 +7722,6 @@
 <file path=ppt/slides/slide7.xml><?xml version="1.0" encoding="utf-8"?>
 <p:sld xmlns:a="http://schemas.openxmlformats.org/drawingml/2006/main" xmlns:r="http://schemas.openxmlformats.org/officeDocument/2006/relationships" xmlns:p="http://schemas.openxmlformats.org/presentationml/2006/main">
   <p:cSld>
-    <p:bg>
-      <p:bgPr>
-        <a:gradFill rotWithShape="1">
-          <a:gsLst>
-            <a:gs pos="0">
-              <a:srgbClr val="FFFFFF"/>
-            </a:gs>
-            <a:gs pos="100000">
-              <a:srgbClr val="F8F9FA"/>
-            </a:gs>
-          </a:gsLst>
-          <a:lin ang="18900000" scaled="0"/>
-        </a:gradFill>
-        <a:effectLst/>
-      </p:bgPr>
-    </p:bg>
     <p:spTree>
       <p:nvGrpSpPr>
         <p:cNvPr id="1" name=""/>
@@ -7184,7 +7827,7 @@
         </p:nvSpPr>
         <p:spPr>
           <a:xfrm>
-            <a:off x="1097280" y="1737360"/>
+            <a:off x="1097280" y="1600200"/>
             <a:ext cx="1554480" cy="731520"/>
           </a:xfrm>
           <a:prstGeom prst="rect">
@@ -7304,7 +7947,7 @@
         </p:nvSpPr>
         <p:spPr>
           <a:xfrm>
-            <a:off x="2926080" y="1737360"/>
+            <a:off x="2926080" y="1600200"/>
             <a:ext cx="1554480" cy="731520"/>
           </a:xfrm>
           <a:prstGeom prst="rect">
@@ -7327,6 +7970,7 @@
               </a:defRPr>
             </a:pPr>
             <a:r>
+              <a:rPr dirty="0"/>
               <a:t>$21.07</a:t>
             </a:r>
           </a:p>
@@ -7423,7 +8067,7 @@
         </p:nvSpPr>
         <p:spPr>
           <a:xfrm>
-            <a:off x="4754880" y="1737360"/>
+            <a:off x="4754880" y="1600200"/>
             <a:ext cx="1554480" cy="731520"/>
           </a:xfrm>
           <a:prstGeom prst="rect">
@@ -7542,7 +8186,7 @@
         </p:nvSpPr>
         <p:spPr>
           <a:xfrm>
-            <a:off x="6583680" y="1737360"/>
+            <a:off x="6583680" y="1600200"/>
             <a:ext cx="1554480" cy="731520"/>
           </a:xfrm>
           <a:prstGeom prst="rect">
@@ -7638,7 +8282,7 @@
         </p:nvSpPr>
         <p:spPr>
           <a:xfrm>
-            <a:off x="914400" y="6217920"/>
+            <a:off x="914400" y="6384175"/>
             <a:ext cx="7315200" cy="457200"/>
           </a:xfrm>
           <a:prstGeom prst="rect">
@@ -7661,6 +8305,7 @@
               </a:defRPr>
             </a:pPr>
             <a:r>
+              <a:rPr dirty="0"/>
               <a:t>Diamond Pack ($49.99) drives 62% of revenue - premium monetization works</a:t>
             </a:r>
           </a:p>
@@ -7713,22 +8358,6 @@
 <file path=ppt/slides/slide8.xml><?xml version="1.0" encoding="utf-8"?>
 <p:sld xmlns:a="http://schemas.openxmlformats.org/drawingml/2006/main" xmlns:r="http://schemas.openxmlformats.org/officeDocument/2006/relationships" xmlns:p="http://schemas.openxmlformats.org/presentationml/2006/main">
   <p:cSld>
-    <p:bg>
-      <p:bgPr>
-        <a:gradFill rotWithShape="1">
-          <a:gsLst>
-            <a:gs pos="0">
-              <a:srgbClr val="FFFFFF"/>
-            </a:gs>
-            <a:gs pos="100000">
-              <a:srgbClr val="F8F9FA"/>
-            </a:gs>
-          </a:gsLst>
-          <a:lin ang="18900000" scaled="0"/>
-        </a:gradFill>
-        <a:effectLst/>
-      </p:bgPr>
-    </p:bg>
     <p:spTree>
       <p:nvGrpSpPr>
         <p:cNvPr id="1" name=""/>
@@ -7795,8 +8424,8 @@
         </p:blipFill>
         <p:spPr>
           <a:xfrm>
-            <a:off x="548640" y="1645920"/>
-            <a:ext cx="5303520" cy="3182112"/>
+            <a:off x="274320" y="1920240"/>
+            <a:ext cx="5760720" cy="3456432"/>
           </a:xfrm>
           <a:prstGeom prst="rect">
             <a:avLst/>
@@ -7825,7 +8454,20 @@
               <a:srgbClr val="ECF0F1"/>
             </a:solidFill>
           </a:ln>
-          <a:effectLst/>
+          <a:effectLst>
+            <a:glow rad="579646">
+              <a:schemeClr val="accent1">
+                <a:lumMod val="60000"/>
+                <a:lumOff val="40000"/>
+                <a:alpha val="5000"/>
+              </a:schemeClr>
+            </a:glow>
+            <a:outerShdw blurRad="387716" dist="38100" dir="2700000" algn="tl" rotWithShape="0">
+              <a:prstClr val="black">
+                <a:alpha val="4000"/>
+              </a:prstClr>
+            </a:outerShdw>
+          </a:effectLst>
         </p:spPr>
         <p:style>
           <a:lnRef idx="1">
@@ -7884,6 +8526,7 @@
               </a:defRPr>
             </a:pPr>
             <a:r>
+              <a:rPr dirty="0"/>
               <a:t>Top Markets:</a:t>
             </a:r>
           </a:p>
@@ -7900,6 +8543,7 @@
               </a:defRPr>
             </a:pPr>
             <a:r>
+              <a:rPr dirty="0"/>
               <a:t>• Suriname: $39.19 ARPU</a:t>
             </a:r>
           </a:p>
@@ -7916,6 +8560,7 @@
               </a:defRPr>
             </a:pPr>
             <a:r>
+              <a:rPr dirty="0"/>
               <a:t>• Ireland: $22.98 ARPU</a:t>
             </a:r>
           </a:p>
@@ -7931,7 +8576,7 @@
                 <a:latin typeface="Calibri"/>
               </a:defRPr>
             </a:pPr>
-            <a:endParaRPr/>
+            <a:endParaRPr dirty="0"/>
           </a:p>
           <a:p>
             <a:pPr>
@@ -7946,6 +8591,7 @@
               </a:defRPr>
             </a:pPr>
             <a:r>
+              <a:rPr dirty="0"/>
               <a:t>Best Age Group:</a:t>
             </a:r>
           </a:p>
@@ -7962,6 +8608,7 @@
               </a:defRPr>
             </a:pPr>
             <a:r>
+              <a:rPr dirty="0"/>
               <a:t>• 18-25: $13.38 ARPU</a:t>
             </a:r>
           </a:p>
@@ -7977,7 +8624,7 @@
                 <a:latin typeface="Calibri"/>
               </a:defRPr>
             </a:pPr>
-            <a:endParaRPr/>
+            <a:endParaRPr dirty="0"/>
           </a:p>
           <a:p>
             <a:pPr>
@@ -7992,6 +8639,7 @@
               </a:defRPr>
             </a:pPr>
             <a:r>
+              <a:rPr dirty="0"/>
               <a:t>High-Value Profile:</a:t>
             </a:r>
           </a:p>
@@ -8008,6 +8656,7 @@
               </a:defRPr>
             </a:pPr>
             <a:r>
+              <a:rPr dirty="0"/>
               <a:t>Ireland + 18-25 age</a:t>
             </a:r>
           </a:p>
@@ -8060,22 +8709,6 @@
 <file path=ppt/slides/slide9.xml><?xml version="1.0" encoding="utf-8"?>
 <p:sld xmlns:a="http://schemas.openxmlformats.org/drawingml/2006/main" xmlns:r="http://schemas.openxmlformats.org/officeDocument/2006/relationships" xmlns:p="http://schemas.openxmlformats.org/presentationml/2006/main">
   <p:cSld>
-    <p:bg>
-      <p:bgPr>
-        <a:gradFill rotWithShape="1">
-          <a:gsLst>
-            <a:gs pos="0">
-              <a:srgbClr val="FFFFFF"/>
-            </a:gs>
-            <a:gs pos="100000">
-              <a:srgbClr val="F8F9FA"/>
-            </a:gs>
-          </a:gsLst>
-          <a:lin ang="18900000" scaled="0"/>
-        </a:gradFill>
-        <a:effectLst/>
-      </p:bgPr>
-    </p:bg>
     <p:spTree>
       <p:nvGrpSpPr>
         <p:cNvPr id="1" name=""/>
@@ -8121,6 +8754,7 @@
               </a:defRPr>
             </a:pPr>
             <a:r>
+              <a:rPr dirty="0"/>
               <a:t>Key Findings &amp; Recommendations</a:t>
             </a:r>
           </a:p>
@@ -8237,7 +8871,7 @@
         </p:nvSpPr>
         <p:spPr>
           <a:xfrm>
-            <a:off x="1371599" y="5486400"/>
+            <a:off x="1306285" y="5212080"/>
             <a:ext cx="6531429" cy="914400"/>
           </a:xfrm>
           <a:prstGeom prst="roundRect">
@@ -8246,15 +8880,22 @@
           <a:gradFill flip="none" rotWithShape="1">
             <a:gsLst>
               <a:gs pos="0">
-                <a:schemeClr val="accent6">
-                  <a:lumMod val="86000"/>
-                  <a:lumOff val="14000"/>
+                <a:schemeClr val="accent4">
+                  <a:alpha val="40687"/>
+                  <a:lumMod val="73000"/>
                 </a:schemeClr>
               </a:gs>
-              <a:gs pos="99000">
+              <a:gs pos="48000">
+                <a:schemeClr val="accent6">
+                  <a:lumMod val="97421"/>
+                  <a:lumOff val="2579"/>
+                  <a:alpha val="76000"/>
+                </a:schemeClr>
+              </a:gs>
+              <a:gs pos="100000">
                 <a:schemeClr val="accent4">
-                  <a:lumMod val="52000"/>
-                  <a:lumOff val="48000"/>
+                  <a:alpha val="67000"/>
+                  <a:lumMod val="90000"/>
                 </a:schemeClr>
               </a:gs>
             </a:gsLst>
@@ -8305,7 +8946,7 @@
         </p:nvSpPr>
         <p:spPr>
           <a:xfrm>
-            <a:off x="1371600" y="5577840"/>
+            <a:off x="1306286" y="5303520"/>
             <a:ext cx="6400800" cy="548640"/>
           </a:xfrm>
           <a:prstGeom prst="rect">
@@ -8379,9 +9020,9 @@
 </file>
 
 <file path=ppt/theme/theme1.xml><?xml version="1.0" encoding="utf-8"?>
-<a:theme xmlns:a="http://schemas.openxmlformats.org/drawingml/2006/main" name="Office Theme">
+<a:theme xmlns:a="http://schemas.openxmlformats.org/drawingml/2006/main" name="Office 2013 - 2022 Theme">
   <a:themeElements>
-    <a:clrScheme name="Office">
+    <a:clrScheme name="Office 2013 - 2022 Theme">
       <a:dk1>
         <a:sysClr val="windowText" lastClr="000000"/>
       </a:dk1>
@@ -8389,44 +9030,44 @@
         <a:sysClr val="window" lastClr="FFFFFF"/>
       </a:lt1>
       <a:dk2>
-        <a:srgbClr val="1F497D"/>
+        <a:srgbClr val="44546A"/>
       </a:dk2>
       <a:lt2>
-        <a:srgbClr val="EEECE1"/>
+        <a:srgbClr val="E7E6E6"/>
       </a:lt2>
       <a:accent1>
-        <a:srgbClr val="4F81BD"/>
+        <a:srgbClr val="4472C4"/>
       </a:accent1>
       <a:accent2>
-        <a:srgbClr val="C0504D"/>
+        <a:srgbClr val="ED7D31"/>
       </a:accent2>
       <a:accent3>
-        <a:srgbClr val="9BBB59"/>
+        <a:srgbClr val="A5A5A5"/>
       </a:accent3>
       <a:accent4>
-        <a:srgbClr val="8064A2"/>
+        <a:srgbClr val="FFC000"/>
       </a:accent4>
       <a:accent5>
-        <a:srgbClr val="4BACC6"/>
+        <a:srgbClr val="5B9BD5"/>
       </a:accent5>
       <a:accent6>
-        <a:srgbClr val="F79646"/>
+        <a:srgbClr val="70AD47"/>
       </a:accent6>
       <a:hlink>
-        <a:srgbClr val="0000FF"/>
+        <a:srgbClr val="0563C1"/>
       </a:hlink>
       <a:folHlink>
-        <a:srgbClr val="800080"/>
+        <a:srgbClr val="954F72"/>
       </a:folHlink>
     </a:clrScheme>
-    <a:fontScheme name="Office">
+    <a:fontScheme name="Office 2013 - 2022 Theme">
       <a:majorFont>
-        <a:latin typeface="Calibri"/>
+        <a:latin typeface="Calibri Light" panose="020F0302020204030204"/>
         <a:ea typeface=""/>
         <a:cs typeface=""/>
-        <a:font script="Jpan" typeface="ＭＳ Ｐゴシック"/>
+        <a:font script="Jpan" typeface="游ゴシック Light"/>
         <a:font script="Hang" typeface="맑은 고딕"/>
-        <a:font script="Hans" typeface="宋体"/>
+        <a:font script="Hans" typeface="等线 Light"/>
         <a:font script="Hant" typeface="新細明體"/>
         <a:font script="Arab" typeface="Times New Roman"/>
         <a:font script="Hebr" typeface="Times New Roman"/>
@@ -8456,12 +9097,12 @@
         <a:font script="Geor" typeface="Sylfaen"/>
       </a:majorFont>
       <a:minorFont>
-        <a:latin typeface="Calibri"/>
+        <a:latin typeface="Calibri" panose="020F0502020204030204"/>
         <a:ea typeface=""/>
         <a:cs typeface=""/>
-        <a:font script="Jpan" typeface="ＭＳ Ｐゴシック"/>
+        <a:font script="Jpan" typeface="游ゴシック"/>
         <a:font script="Hang" typeface="맑은 고딕"/>
-        <a:font script="Hans" typeface="宋体"/>
+        <a:font script="Hans" typeface="等线"/>
         <a:font script="Hant" typeface="新細明體"/>
         <a:font script="Arab" typeface="Arial"/>
         <a:font script="Hebr" typeface="Arial"/>
@@ -8491,7 +9132,7 @@
         <a:font script="Geor" typeface="Sylfaen"/>
       </a:minorFont>
     </a:fontScheme>
-    <a:fmtScheme name="Office">
+    <a:fmtScheme name="Office 2013 - 2022 Theme">
       <a:fillStyleLst>
         <a:solidFill>
           <a:schemeClr val="phClr"/>
@@ -8500,200 +9141,141 @@
           <a:gsLst>
             <a:gs pos="0">
               <a:schemeClr val="phClr">
-                <a:tint val="50000"/>
-                <a:satMod val="300000"/>
+                <a:lumMod val="110000"/>
+                <a:satMod val="105000"/>
+                <a:tint val="67000"/>
               </a:schemeClr>
             </a:gs>
-            <a:gs pos="35000">
+            <a:gs pos="50000">
               <a:schemeClr val="phClr">
-                <a:tint val="37000"/>
-                <a:satMod val="300000"/>
+                <a:lumMod val="105000"/>
+                <a:satMod val="103000"/>
+                <a:tint val="73000"/>
               </a:schemeClr>
             </a:gs>
             <a:gs pos="100000">
               <a:schemeClr val="phClr">
-                <a:tint val="15000"/>
-                <a:satMod val="350000"/>
+                <a:lumMod val="105000"/>
+                <a:satMod val="109000"/>
+                <a:tint val="81000"/>
               </a:schemeClr>
             </a:gs>
           </a:gsLst>
-          <a:lin ang="16200000" scaled="1"/>
+          <a:lin ang="5400000" scaled="0"/>
         </a:gradFill>
         <a:gradFill rotWithShape="1">
           <a:gsLst>
             <a:gs pos="0">
               <a:schemeClr val="phClr">
-                <a:tint val="100000"/>
+                <a:satMod val="103000"/>
+                <a:lumMod val="102000"/>
+                <a:tint val="94000"/>
+              </a:schemeClr>
+            </a:gs>
+            <a:gs pos="50000">
+              <a:schemeClr val="phClr">
+                <a:satMod val="110000"/>
+                <a:lumMod val="100000"/>
                 <a:shade val="100000"/>
-                <a:satMod val="130000"/>
               </a:schemeClr>
             </a:gs>
             <a:gs pos="100000">
               <a:schemeClr val="phClr">
-                <a:tint val="50000"/>
-                <a:shade val="100000"/>
-                <a:satMod val="350000"/>
+                <a:lumMod val="99000"/>
+                <a:satMod val="120000"/>
+                <a:shade val="78000"/>
               </a:schemeClr>
             </a:gs>
           </a:gsLst>
-          <a:lin ang="16200000" scaled="0"/>
+          <a:lin ang="5400000" scaled="0"/>
         </a:gradFill>
       </a:fillStyleLst>
       <a:lnStyleLst>
-        <a:ln w="9525" cap="flat" cmpd="sng" algn="ctr">
-          <a:solidFill>
-            <a:schemeClr val="phClr">
-              <a:shade val="95000"/>
-              <a:satMod val="105000"/>
-            </a:schemeClr>
-          </a:solidFill>
-          <a:prstDash val="solid"/>
-        </a:ln>
-        <a:ln w="25400" cap="flat" cmpd="sng" algn="ctr">
+        <a:ln w="6350" cap="flat" cmpd="sng" algn="ctr">
           <a:solidFill>
             <a:schemeClr val="phClr"/>
           </a:solidFill>
           <a:prstDash val="solid"/>
+          <a:miter lim="800000"/>
         </a:ln>
-        <a:ln w="38100" cap="flat" cmpd="sng" algn="ctr">
+        <a:ln w="12700" cap="flat" cmpd="sng" algn="ctr">
           <a:solidFill>
             <a:schemeClr val="phClr"/>
           </a:solidFill>
           <a:prstDash val="solid"/>
+          <a:miter lim="800000"/>
+        </a:ln>
+        <a:ln w="19050" cap="flat" cmpd="sng" algn="ctr">
+          <a:solidFill>
+            <a:schemeClr val="phClr"/>
+          </a:solidFill>
+          <a:prstDash val="solid"/>
+          <a:miter lim="800000"/>
         </a:ln>
       </a:lnStyleLst>
       <a:effectStyleLst>
         <a:effectStyle>
+          <a:effectLst/>
+        </a:effectStyle>
+        <a:effectStyle>
+          <a:effectLst/>
+        </a:effectStyle>
+        <a:effectStyle>
           <a:effectLst>
-            <a:outerShdw blurRad="40000" dist="20000" dir="5400000" rotWithShape="0">
+            <a:outerShdw blurRad="57150" dist="19050" dir="5400000" algn="ctr" rotWithShape="0">
               <a:srgbClr val="000000">
-                <a:alpha val="38000"/>
+                <a:alpha val="63000"/>
               </a:srgbClr>
             </a:outerShdw>
           </a:effectLst>
-        </a:effectStyle>
-        <a:effectStyle>
-          <a:effectLst>
-            <a:outerShdw blurRad="40000" dist="23000" dir="5400000" rotWithShape="0">
-              <a:srgbClr val="000000">
-                <a:alpha val="35000"/>
-              </a:srgbClr>
-            </a:outerShdw>
-          </a:effectLst>
-        </a:effectStyle>
-        <a:effectStyle>
-          <a:effectLst>
-            <a:outerShdw blurRad="40000" dist="23000" dir="5400000" rotWithShape="0">
-              <a:srgbClr val="000000">
-                <a:alpha val="35000"/>
-              </a:srgbClr>
-            </a:outerShdw>
-          </a:effectLst>
-          <a:scene3d>
-            <a:camera prst="orthographicFront">
-              <a:rot lat="0" lon="0" rev="0"/>
-            </a:camera>
-            <a:lightRig rig="threePt" dir="t">
-              <a:rot lat="0" lon="0" rev="1200000"/>
-            </a:lightRig>
-          </a:scene3d>
-          <a:sp3d>
-            <a:bevelT w="63500" h="25400"/>
-          </a:sp3d>
         </a:effectStyle>
       </a:effectStyleLst>
       <a:bgFillStyleLst>
         <a:solidFill>
           <a:schemeClr val="phClr"/>
         </a:solidFill>
+        <a:solidFill>
+          <a:schemeClr val="phClr">
+            <a:tint val="95000"/>
+            <a:satMod val="170000"/>
+          </a:schemeClr>
+        </a:solidFill>
         <a:gradFill rotWithShape="1">
           <a:gsLst>
             <a:gs pos="0">
               <a:schemeClr val="phClr">
-                <a:tint val="40000"/>
-                <a:satMod val="350000"/>
+                <a:tint val="93000"/>
+                <a:satMod val="150000"/>
+                <a:shade val="98000"/>
+                <a:lumMod val="102000"/>
               </a:schemeClr>
             </a:gs>
-            <a:gs pos="40000">
+            <a:gs pos="50000">
               <a:schemeClr val="phClr">
-                <a:tint val="45000"/>
-                <a:shade val="99000"/>
-                <a:satMod val="350000"/>
+                <a:tint val="98000"/>
+                <a:satMod val="130000"/>
+                <a:shade val="90000"/>
+                <a:lumMod val="103000"/>
               </a:schemeClr>
             </a:gs>
             <a:gs pos="100000">
               <a:schemeClr val="phClr">
-                <a:shade val="20000"/>
-                <a:satMod val="255000"/>
+                <a:shade val="63000"/>
+                <a:satMod val="120000"/>
               </a:schemeClr>
             </a:gs>
           </a:gsLst>
-          <a:path path="circle">
-            <a:fillToRect l="50000" t="-80000" r="50000" b="180000"/>
-          </a:path>
-        </a:gradFill>
-        <a:gradFill rotWithShape="1">
-          <a:gsLst>
-            <a:gs pos="0">
-              <a:schemeClr val="phClr">
-                <a:tint val="80000"/>
-                <a:satMod val="300000"/>
-              </a:schemeClr>
-            </a:gs>
-            <a:gs pos="100000">
-              <a:schemeClr val="phClr">
-                <a:shade val="30000"/>
-                <a:satMod val="200000"/>
-              </a:schemeClr>
-            </a:gs>
-          </a:gsLst>
-          <a:path path="circle">
-            <a:fillToRect l="50000" t="50000" r="50000" b="50000"/>
-          </a:path>
+          <a:lin ang="5400000" scaled="0"/>
         </a:gradFill>
       </a:bgFillStyleLst>
     </a:fmtScheme>
   </a:themeElements>
-  <a:objectDefaults>
-    <a:spDef>
-      <a:spPr/>
-      <a:bodyPr/>
-      <a:lstStyle/>
-      <a:style>
-        <a:lnRef idx="1">
-          <a:schemeClr val="accent1"/>
-        </a:lnRef>
-        <a:fillRef idx="3">
-          <a:schemeClr val="accent1"/>
-        </a:fillRef>
-        <a:effectRef idx="2">
-          <a:schemeClr val="accent1"/>
-        </a:effectRef>
-        <a:fontRef idx="minor">
-          <a:schemeClr val="lt1"/>
-        </a:fontRef>
-      </a:style>
-    </a:spDef>
-    <a:lnDef>
-      <a:spPr/>
-      <a:bodyPr/>
-      <a:lstStyle/>
-      <a:style>
-        <a:lnRef idx="2">
-          <a:schemeClr val="accent1"/>
-        </a:lnRef>
-        <a:fillRef idx="0">
-          <a:schemeClr val="accent1"/>
-        </a:fillRef>
-        <a:effectRef idx="1">
-          <a:schemeClr val="accent1"/>
-        </a:effectRef>
-        <a:fontRef idx="minor">
-          <a:schemeClr val="tx1"/>
-        </a:fontRef>
-      </a:style>
-    </a:lnDef>
-  </a:objectDefaults>
+  <a:objectDefaults/>
   <a:extraClrSchemeLst/>
+  <a:extLst>
+    <a:ext uri="{05A4C25C-085E-4340-85A3-A5531E510DB2}">
+      <thm15:themeFamily xmlns:thm15="http://schemas.microsoft.com/office/thememl/2012/main" name="Office 2013 - 2022 Theme" id="{62F939B6-93AF-4DB8-9C6B-D6C7DFDC589F}" vid="{4A3C46E8-61CC-4603-A589-7422A47A8E4A}"/>
+    </a:ext>
+  </a:extLst>
 </a:theme>
 </file>
</xml_diff>